<commit_message>
improve ui and some changing in free model
</commit_message>
<xml_diff>
--- a/backend/services/agent/presentation.pptx
+++ b/backend/services/agent/presentation.pptx
@@ -13,9 +13,14 @@
     <p:sldId id="261" r:id="rId7"/>
     <p:sldId id="262" r:id="rId8"/>
     <p:sldId id="263" r:id="rId9"/>
+    <p:sldId id="264" r:id="rId10"/>
+    <p:sldId id="265" r:id="rId11"/>
+    <p:sldId id="266" r:id="rId12"/>
+    <p:sldId id="267" r:id="rId13"/>
+    <p:sldId id="268" r:id="rId14"/>
   </p:sldIdLst>
   <p:notesMasterIdLst>
-    <p:notesMasterId r:id="rId10"/>
+    <p:notesMasterId r:id="rId15"/>
   </p:notesMasterIdLst>
   <p:sldSz cx="12192000" cy="6858000"/>
   <p:notesSz cx="6858000" cy="12192000"/>
@@ -112,6 +117,1636 @@
     </a:lvl9pPr>
   </p:defaultTextStyle>
 </p:presentation>
+</file>
+
+<file path=ppt/charts/chart1.xml><?xml version="1.0" encoding="utf-8"?>
+<c:chartSpace xmlns:c="http://schemas.openxmlformats.org/drawingml/2006/chart" xmlns:a="http://schemas.openxmlformats.org/drawingml/2006/main" xmlns:r="http://schemas.openxmlformats.org/officeDocument/2006/relationships">
+  <c:date1904 val="0"/>
+  <c:roundedCorners val="1"/>
+  <c:chart>
+    <c:autoTitleDeleted val="1"/>
+    <c:plotArea>
+      <c:layout/>
+      <c:barChart>
+        <c:barDir val="col"/>
+        <c:grouping val="clustered"/>
+        <c:varyColors val="0"/>
+        <c:ser>
+          <c:idx val="0"/>
+          <c:order val="0"/>
+          <c:tx>
+            <c:strRef>
+              <c:f>Sheet1!$B$1</c:f>
+              <c:strCache>
+                <c:ptCount val="1"/>
+                <c:pt idx="0">
+                  <c:v>Points</c:v>
+                </c:pt>
+              </c:strCache>
+            </c:strRef>
+          </c:tx>
+          <c:spPr>
+            <a:solidFill>
+              <a:srgbClr val="2563EB"/>
+            </a:solidFill>
+            <a:effectLst/>
+          </c:spPr>
+          <c:invertIfNegative val="0"/>
+          <c:dLbls>
+            <c:numFmt formatCode="#,##0" sourceLinked="0"/>
+            <c:txPr>
+              <a:bodyPr/>
+              <a:lstStyle/>
+              <a:p>
+                <a:pPr>
+                  <a:defRPr b="0" i="0" strike="noStrike" sz="1000" u="none">
+                    <a:solidFill>
+                      <a:srgbClr val="334155"/>
+                    </a:solidFill>
+                    <a:latin typeface="Arial"/>
+                  </a:defRPr>
+                </a:pPr>
+              </a:p>
+            </c:txPr>
+            <c:showLegendKey val="0"/>
+            <c:showVal val="1"/>
+            <c:showCatName val="0"/>
+            <c:showSerName val="0"/>
+            <c:showPercent val="0"/>
+            <c:showBubbleSize val="0"/>
+            <c:showLeaderLines val="0"/>
+          </c:dLbls>
+          <c:dPt>
+            <c:idx val="0"/>
+            <c:invertIfNegative val="0"/>
+            <c:bubble3D val="0"/>
+            <c:spPr>
+              <a:solidFill>
+                <a:srgbClr val="2563EB"/>
+              </a:solidFill>
+              <a:effectLst/>
+            </c:spPr>
+          </c:dPt>
+          <c:dPt>
+            <c:idx val="1"/>
+            <c:invertIfNegative val="0"/>
+            <c:bubble3D val="0"/>
+            <c:spPr>
+              <a:solidFill>
+                <a:srgbClr val="60A5FA"/>
+              </a:solidFill>
+              <a:effectLst/>
+            </c:spPr>
+          </c:dPt>
+          <c:dPt>
+            <c:idx val="2"/>
+            <c:invertIfNegative val="0"/>
+            <c:bubble3D val="0"/>
+            <c:spPr>
+              <a:solidFill>
+                <a:srgbClr val="93C5FD"/>
+              </a:solidFill>
+              <a:effectLst/>
+            </c:spPr>
+          </c:dPt>
+          <c:dPt>
+            <c:idx val="3"/>
+            <c:invertIfNegative val="0"/>
+            <c:bubble3D val="0"/>
+            <c:spPr>
+              <a:solidFill>
+                <a:srgbClr val="BFDBFE"/>
+              </a:solidFill>
+              <a:effectLst/>
+            </c:spPr>
+          </c:dPt>
+          <c:dPt>
+            <c:idx val="4"/>
+            <c:invertIfNegative val="0"/>
+            <c:bubble3D val="0"/>
+            <c:spPr>
+              <a:solidFill>
+                <a:srgbClr val="1D4ED8"/>
+              </a:solidFill>
+              <a:effectLst/>
+            </c:spPr>
+          </c:dPt>
+          <c:dPt>
+            <c:idx val="5"/>
+            <c:invertIfNegative val="0"/>
+            <c:bubble3D val="0"/>
+            <c:spPr>
+              <a:solidFill>
+                <a:srgbClr val="2563EB"/>
+              </a:solidFill>
+              <a:effectLst/>
+            </c:spPr>
+          </c:dPt>
+          <c:cat>
+            <c:multiLvlStrRef>
+              <c:f>Sheet1!$A$2:$A$7</c:f>
+              <c:multiLvlStrCache>
+                <c:ptCount val="6"/>
+                <c:lvl>
+                  <c:pt idx="0">
+                    <c:v>Early Life…</c:v>
+                  </c:pt>
+                  <c:pt idx="1">
+                    <c:v>Academic E…</c:v>
+                  </c:pt>
+                  <c:pt idx="2">
+                    <c:v>Political …</c:v>
+                  </c:pt>
+                  <c:pt idx="3">
+                    <c:v>Leadership…</c:v>
+                  </c:pt>
+                  <c:pt idx="4">
+                    <c:v>Role in Pa…</c:v>
+                  </c:pt>
+                  <c:pt idx="5">
+                    <c:v>Legacy and…</c:v>
+                  </c:pt>
+                </c:lvl>
+              </c:multiLvlStrCache>
+            </c:multiLvlStrRef>
+          </c:cat>
+          <c:val>
+            <c:numRef>
+              <c:f>Sheet1!$B$2:$B$7</c:f>
+              <c:numCache>
+                <c:formatCode>General</c:formatCode>
+                <c:ptCount val="6"/>
+                <c:pt idx="0">
+                  <c:v>4</c:v>
+                </c:pt>
+                <c:pt idx="1">
+                  <c:v>4</c:v>
+                </c:pt>
+                <c:pt idx="2">
+                  <c:v>4</c:v>
+                </c:pt>
+                <c:pt idx="3">
+                  <c:v>4</c:v>
+                </c:pt>
+                <c:pt idx="4">
+                  <c:v>4</c:v>
+                </c:pt>
+                <c:pt idx="5">
+                  <c:v>4</c:v>
+                </c:pt>
+              </c:numCache>
+            </c:numRef>
+          </c:val>
+        </c:ser>
+        <c:dLbls>
+          <c:numFmt formatCode="#,##0" sourceLinked="0"/>
+          <c:txPr>
+            <a:bodyPr/>
+            <a:lstStyle/>
+            <a:p>
+              <a:pPr>
+                <a:defRPr b="0" i="0" strike="noStrike" sz="1000" u="none">
+                  <a:solidFill>
+                    <a:srgbClr val="334155"/>
+                  </a:solidFill>
+                  <a:latin typeface="Arial"/>
+                </a:defRPr>
+              </a:pPr>
+            </a:p>
+          </c:txPr>
+          <c:showLegendKey val="0"/>
+          <c:showVal val="1"/>
+          <c:showCatName val="0"/>
+          <c:showSerName val="0"/>
+          <c:showPercent val="0"/>
+          <c:showBubbleSize val="0"/>
+          <c:showLeaderLines val="0"/>
+        </c:dLbls>
+        <c:gapWidth val="55"/>
+        <c:overlap val="0"/>
+        <c:axId val="2094734554"/>
+        <c:axId val="2094734552"/>
+        <c:axId val="2094734556"/>
+      </c:barChart>
+      <c:catAx>
+        <c:axId val="2094734554"/>
+        <c:scaling>
+          <c:orientation val="minMax"/>
+        </c:scaling>
+        <c:delete val="0"/>
+        <c:axPos val="b"/>
+        <c:numFmt formatCode="General" sourceLinked="1"/>
+        <c:majorTickMark val="out"/>
+        <c:minorTickMark val="none"/>
+        <c:tickLblPos val="low"/>
+        <c:spPr>
+          <a:ln w="12700" cap="flat">
+            <a:solidFill>
+              <a:srgbClr val="888888"/>
+            </a:solidFill>
+            <a:prstDash val="solid"/>
+            <a:round/>
+          </a:ln>
+        </c:spPr>
+        <c:txPr>
+          <a:bodyPr/>
+          <a:lstStyle/>
+          <a:p>
+            <a:pPr>
+              <a:defRPr sz="900" b="0" i="0" u="none" strike="noStrike">
+                <a:solidFill>
+                  <a:srgbClr val="334155"/>
+                </a:solidFill>
+                <a:latin typeface="Arial"/>
+              </a:defRPr>
+            </a:pPr>
+            <a:endParaRPr lang="en-US"/>
+          </a:p>
+        </c:txPr>
+        <c:crossAx val="2094734552"/>
+        <c:crosses val="autoZero"/>
+        <c:auto val="1"/>
+        <c:lblAlgn val="ctr"/>
+        <c:noMultiLvlLbl val="1"/>
+      </c:catAx>
+      <c:valAx>
+        <c:axId val="2094734552"/>
+        <c:scaling>
+          <c:orientation val="minMax"/>
+        </c:scaling>
+        <c:delete val="0"/>
+        <c:axPos val="l"/>
+        <c:majorGridlines>
+          <c:spPr>
+            <a:ln w="6350" cap="flat">
+              <a:solidFill>
+                <a:srgbClr val="E2E8F0"/>
+              </a:solidFill>
+              <a:prstDash val="dash"/>
+              <a:round/>
+            </a:ln>
+          </c:spPr>
+        </c:majorGridlines>
+        <c:numFmt formatCode="General" sourceLinked="0"/>
+        <c:majorTickMark val="out"/>
+        <c:minorTickMark val="none"/>
+        <c:tickLblPos val="nextTo"/>
+        <c:spPr>
+          <a:ln w="12700" cap="flat">
+            <a:solidFill>
+              <a:srgbClr val="888888"/>
+            </a:solidFill>
+            <a:prstDash val="solid"/>
+            <a:round/>
+          </a:ln>
+        </c:spPr>
+        <c:txPr>
+          <a:bodyPr/>
+          <a:lstStyle/>
+          <a:p>
+            <a:pPr>
+              <a:defRPr sz="900" b="0" i="0" u="none" strike="noStrike">
+                <a:solidFill>
+                  <a:srgbClr val="64748B"/>
+                </a:solidFill>
+                <a:latin typeface="Arial"/>
+              </a:defRPr>
+            </a:pPr>
+            <a:endParaRPr lang="en-US"/>
+          </a:p>
+        </c:txPr>
+        <c:crossAx val="2094734554"/>
+        <c:crosses val="autoZero"/>
+        <c:crossBetween val="between"/>
+      </c:valAx>
+      <c:spPr>
+        <a:noFill/>
+        <a:ln w="12700" cap="flat">
+          <a:solidFill>
+            <a:srgbClr val="FFFFFF"/>
+          </a:solidFill>
+        </a:ln>
+        <a:effectLst/>
+      </c:spPr>
+    </c:plotArea>
+    <c:plotVisOnly val="1"/>
+    <c:dispBlanksAs val="span"/>
+  </c:chart>
+  <c:spPr>
+    <a:noFill/>
+    <a:ln>
+      <a:noFill/>
+    </a:ln>
+    <a:effectLst/>
+  </c:spPr>
+  <c:externalData r:id="rId1">
+    <c:autoUpdate val="0"/>
+  </c:externalData>
+</c:chartSpace>
+</file>
+
+<file path=ppt/charts/chart2.xml><?xml version="1.0" encoding="utf-8"?>
+<c:chartSpace xmlns:c="http://schemas.openxmlformats.org/drawingml/2006/chart" xmlns:a="http://schemas.openxmlformats.org/drawingml/2006/main" xmlns:r="http://schemas.openxmlformats.org/officeDocument/2006/relationships">
+  <c:date1904 val="0"/>
+  <c:roundedCorners val="1"/>
+  <c:chart>
+    <c:autoTitleDeleted val="1"/>
+    <c:plotArea>
+      <c:layout/>
+      <c:barChart>
+        <c:barDir val="col"/>
+        <c:grouping val="clustered"/>
+        <c:varyColors val="0"/>
+        <c:ser>
+          <c:idx val="0"/>
+          <c:order val="0"/>
+          <c:tx>
+            <c:strRef>
+              <c:f>Sheet1!$B$1</c:f>
+              <c:strCache>
+                <c:ptCount val="1"/>
+                <c:pt idx="0">
+                  <c:v>Points</c:v>
+                </c:pt>
+              </c:strCache>
+            </c:strRef>
+          </c:tx>
+          <c:spPr>
+            <a:solidFill>
+              <a:srgbClr val="2563EB"/>
+            </a:solidFill>
+            <a:effectLst/>
+          </c:spPr>
+          <c:invertIfNegative val="0"/>
+          <c:dLbls>
+            <c:numFmt formatCode="#,##0" sourceLinked="0"/>
+            <c:txPr>
+              <a:bodyPr/>
+              <a:lstStyle/>
+              <a:p>
+                <a:pPr>
+                  <a:defRPr b="0" i="0" strike="noStrike" sz="1000" u="none">
+                    <a:solidFill>
+                      <a:srgbClr val="334155"/>
+                    </a:solidFill>
+                    <a:latin typeface="Arial"/>
+                  </a:defRPr>
+                </a:pPr>
+              </a:p>
+            </c:txPr>
+            <c:showLegendKey val="0"/>
+            <c:showVal val="1"/>
+            <c:showCatName val="0"/>
+            <c:showSerName val="0"/>
+            <c:showPercent val="0"/>
+            <c:showBubbleSize val="0"/>
+            <c:showLeaderLines val="0"/>
+          </c:dLbls>
+          <c:dPt>
+            <c:idx val="0"/>
+            <c:invertIfNegative val="0"/>
+            <c:bubble3D val="0"/>
+            <c:spPr>
+              <a:solidFill>
+                <a:srgbClr val="2563EB"/>
+              </a:solidFill>
+              <a:effectLst/>
+            </c:spPr>
+          </c:dPt>
+          <c:dPt>
+            <c:idx val="1"/>
+            <c:invertIfNegative val="0"/>
+            <c:bubble3D val="0"/>
+            <c:spPr>
+              <a:solidFill>
+                <a:srgbClr val="60A5FA"/>
+              </a:solidFill>
+              <a:effectLst/>
+            </c:spPr>
+          </c:dPt>
+          <c:dPt>
+            <c:idx val="2"/>
+            <c:invertIfNegative val="0"/>
+            <c:bubble3D val="0"/>
+            <c:spPr>
+              <a:solidFill>
+                <a:srgbClr val="93C5FD"/>
+              </a:solidFill>
+              <a:effectLst/>
+            </c:spPr>
+          </c:dPt>
+          <c:dPt>
+            <c:idx val="3"/>
+            <c:invertIfNegative val="0"/>
+            <c:bubble3D val="0"/>
+            <c:spPr>
+              <a:solidFill>
+                <a:srgbClr val="BFDBFE"/>
+              </a:solidFill>
+              <a:effectLst/>
+            </c:spPr>
+          </c:dPt>
+          <c:dPt>
+            <c:idx val="4"/>
+            <c:invertIfNegative val="0"/>
+            <c:bubble3D val="0"/>
+            <c:spPr>
+              <a:solidFill>
+                <a:srgbClr val="1D4ED8"/>
+              </a:solidFill>
+              <a:effectLst/>
+            </c:spPr>
+          </c:dPt>
+          <c:dPt>
+            <c:idx val="5"/>
+            <c:invertIfNegative val="0"/>
+            <c:bubble3D val="0"/>
+            <c:spPr>
+              <a:solidFill>
+                <a:srgbClr val="2563EB"/>
+              </a:solidFill>
+              <a:effectLst/>
+            </c:spPr>
+          </c:dPt>
+          <c:cat>
+            <c:multiLvlStrRef>
+              <c:f>Sheet1!$A$2:$A$7</c:f>
+              <c:multiLvlStrCache>
+                <c:ptCount val="6"/>
+                <c:lvl>
+                  <c:pt idx="0">
+                    <c:v>Early Life…</c:v>
+                  </c:pt>
+                  <c:pt idx="1">
+                    <c:v>Academic E…</c:v>
+                  </c:pt>
+                  <c:pt idx="2">
+                    <c:v>Political …</c:v>
+                  </c:pt>
+                  <c:pt idx="3">
+                    <c:v>Leadership…</c:v>
+                  </c:pt>
+                  <c:pt idx="4">
+                    <c:v>Role in Pa…</c:v>
+                  </c:pt>
+                  <c:pt idx="5">
+                    <c:v>Legacy and…</c:v>
+                  </c:pt>
+                </c:lvl>
+              </c:multiLvlStrCache>
+            </c:multiLvlStrRef>
+          </c:cat>
+          <c:val>
+            <c:numRef>
+              <c:f>Sheet1!$B$2:$B$7</c:f>
+              <c:numCache>
+                <c:formatCode>General</c:formatCode>
+                <c:ptCount val="6"/>
+                <c:pt idx="0">
+                  <c:v>4</c:v>
+                </c:pt>
+                <c:pt idx="1">
+                  <c:v>4</c:v>
+                </c:pt>
+                <c:pt idx="2">
+                  <c:v>4</c:v>
+                </c:pt>
+                <c:pt idx="3">
+                  <c:v>4</c:v>
+                </c:pt>
+                <c:pt idx="4">
+                  <c:v>4</c:v>
+                </c:pt>
+                <c:pt idx="5">
+                  <c:v>4</c:v>
+                </c:pt>
+              </c:numCache>
+            </c:numRef>
+          </c:val>
+        </c:ser>
+        <c:dLbls>
+          <c:numFmt formatCode="#,##0" sourceLinked="0"/>
+          <c:txPr>
+            <a:bodyPr/>
+            <a:lstStyle/>
+            <a:p>
+              <a:pPr>
+                <a:defRPr b="0" i="0" strike="noStrike" sz="1000" u="none">
+                  <a:solidFill>
+                    <a:srgbClr val="334155"/>
+                  </a:solidFill>
+                  <a:latin typeface="Arial"/>
+                </a:defRPr>
+              </a:pPr>
+            </a:p>
+          </c:txPr>
+          <c:showLegendKey val="0"/>
+          <c:showVal val="1"/>
+          <c:showCatName val="0"/>
+          <c:showSerName val="0"/>
+          <c:showPercent val="0"/>
+          <c:showBubbleSize val="0"/>
+          <c:showLeaderLines val="0"/>
+        </c:dLbls>
+        <c:gapWidth val="55"/>
+        <c:overlap val="0"/>
+        <c:axId val="2094734554"/>
+        <c:axId val="2094734552"/>
+        <c:axId val="2094734556"/>
+      </c:barChart>
+      <c:catAx>
+        <c:axId val="2094734554"/>
+        <c:scaling>
+          <c:orientation val="minMax"/>
+        </c:scaling>
+        <c:delete val="0"/>
+        <c:axPos val="b"/>
+        <c:numFmt formatCode="General" sourceLinked="1"/>
+        <c:majorTickMark val="out"/>
+        <c:minorTickMark val="none"/>
+        <c:tickLblPos val="low"/>
+        <c:spPr>
+          <a:ln w="12700" cap="flat">
+            <a:solidFill>
+              <a:srgbClr val="888888"/>
+            </a:solidFill>
+            <a:prstDash val="solid"/>
+            <a:round/>
+          </a:ln>
+        </c:spPr>
+        <c:txPr>
+          <a:bodyPr/>
+          <a:lstStyle/>
+          <a:p>
+            <a:pPr>
+              <a:defRPr sz="900" b="0" i="0" u="none" strike="noStrike">
+                <a:solidFill>
+                  <a:srgbClr val="334155"/>
+                </a:solidFill>
+                <a:latin typeface="Arial"/>
+              </a:defRPr>
+            </a:pPr>
+            <a:endParaRPr lang="en-US"/>
+          </a:p>
+        </c:txPr>
+        <c:crossAx val="2094734552"/>
+        <c:crosses val="autoZero"/>
+        <c:auto val="1"/>
+        <c:lblAlgn val="ctr"/>
+        <c:noMultiLvlLbl val="1"/>
+      </c:catAx>
+      <c:valAx>
+        <c:axId val="2094734552"/>
+        <c:scaling>
+          <c:orientation val="minMax"/>
+        </c:scaling>
+        <c:delete val="0"/>
+        <c:axPos val="l"/>
+        <c:majorGridlines>
+          <c:spPr>
+            <a:ln w="6350" cap="flat">
+              <a:solidFill>
+                <a:srgbClr val="E2E8F0"/>
+              </a:solidFill>
+              <a:prstDash val="dash"/>
+              <a:round/>
+            </a:ln>
+          </c:spPr>
+        </c:majorGridlines>
+        <c:numFmt formatCode="General" sourceLinked="0"/>
+        <c:majorTickMark val="out"/>
+        <c:minorTickMark val="none"/>
+        <c:tickLblPos val="nextTo"/>
+        <c:spPr>
+          <a:ln w="12700" cap="flat">
+            <a:solidFill>
+              <a:srgbClr val="888888"/>
+            </a:solidFill>
+            <a:prstDash val="solid"/>
+            <a:round/>
+          </a:ln>
+        </c:spPr>
+        <c:txPr>
+          <a:bodyPr/>
+          <a:lstStyle/>
+          <a:p>
+            <a:pPr>
+              <a:defRPr sz="900" b="0" i="0" u="none" strike="noStrike">
+                <a:solidFill>
+                  <a:srgbClr val="64748B"/>
+                </a:solidFill>
+                <a:latin typeface="Arial"/>
+              </a:defRPr>
+            </a:pPr>
+            <a:endParaRPr lang="en-US"/>
+          </a:p>
+        </c:txPr>
+        <c:crossAx val="2094734554"/>
+        <c:crosses val="autoZero"/>
+        <c:crossBetween val="between"/>
+      </c:valAx>
+      <c:spPr>
+        <a:noFill/>
+        <a:ln w="12700" cap="flat">
+          <a:solidFill>
+            <a:srgbClr val="FFFFFF"/>
+          </a:solidFill>
+        </a:ln>
+        <a:effectLst/>
+      </c:spPr>
+    </c:plotArea>
+    <c:plotVisOnly val="1"/>
+    <c:dispBlanksAs val="span"/>
+  </c:chart>
+  <c:spPr>
+    <a:noFill/>
+    <a:ln>
+      <a:noFill/>
+    </a:ln>
+    <a:effectLst/>
+  </c:spPr>
+  <c:externalData r:id="rId1">
+    <c:autoUpdate val="0"/>
+  </c:externalData>
+</c:chartSpace>
+</file>
+
+<file path=ppt/charts/chart3.xml><?xml version="1.0" encoding="utf-8"?>
+<c:chartSpace xmlns:c="http://schemas.openxmlformats.org/drawingml/2006/chart" xmlns:a="http://schemas.openxmlformats.org/drawingml/2006/main" xmlns:r="http://schemas.openxmlformats.org/officeDocument/2006/relationships">
+  <c:date1904 val="0"/>
+  <c:roundedCorners val="1"/>
+  <c:chart>
+    <c:autoTitleDeleted val="1"/>
+    <c:plotArea>
+      <c:layout/>
+      <c:barChart>
+        <c:barDir val="col"/>
+        <c:grouping val="clustered"/>
+        <c:varyColors val="0"/>
+        <c:ser>
+          <c:idx val="0"/>
+          <c:order val="0"/>
+          <c:tx>
+            <c:strRef>
+              <c:f>Sheet1!$B$1</c:f>
+              <c:strCache>
+                <c:ptCount val="1"/>
+                <c:pt idx="0">
+                  <c:v>Points</c:v>
+                </c:pt>
+              </c:strCache>
+            </c:strRef>
+          </c:tx>
+          <c:spPr>
+            <a:solidFill>
+              <a:srgbClr val="2563EB"/>
+            </a:solidFill>
+            <a:effectLst/>
+          </c:spPr>
+          <c:invertIfNegative val="0"/>
+          <c:dLbls>
+            <c:numFmt formatCode="#,##0" sourceLinked="0"/>
+            <c:txPr>
+              <a:bodyPr/>
+              <a:lstStyle/>
+              <a:p>
+                <a:pPr>
+                  <a:defRPr b="0" i="0" strike="noStrike" sz="1000" u="none">
+                    <a:solidFill>
+                      <a:srgbClr val="334155"/>
+                    </a:solidFill>
+                    <a:latin typeface="Arial"/>
+                  </a:defRPr>
+                </a:pPr>
+              </a:p>
+            </c:txPr>
+            <c:showLegendKey val="0"/>
+            <c:showVal val="1"/>
+            <c:showCatName val="0"/>
+            <c:showSerName val="0"/>
+            <c:showPercent val="0"/>
+            <c:showBubbleSize val="0"/>
+            <c:showLeaderLines val="0"/>
+          </c:dLbls>
+          <c:dPt>
+            <c:idx val="0"/>
+            <c:invertIfNegative val="0"/>
+            <c:bubble3D val="0"/>
+            <c:spPr>
+              <a:solidFill>
+                <a:srgbClr val="2563EB"/>
+              </a:solidFill>
+              <a:effectLst/>
+            </c:spPr>
+          </c:dPt>
+          <c:dPt>
+            <c:idx val="1"/>
+            <c:invertIfNegative val="0"/>
+            <c:bubble3D val="0"/>
+            <c:spPr>
+              <a:solidFill>
+                <a:srgbClr val="60A5FA"/>
+              </a:solidFill>
+              <a:effectLst/>
+            </c:spPr>
+          </c:dPt>
+          <c:dPt>
+            <c:idx val="2"/>
+            <c:invertIfNegative val="0"/>
+            <c:bubble3D val="0"/>
+            <c:spPr>
+              <a:solidFill>
+                <a:srgbClr val="93C5FD"/>
+              </a:solidFill>
+              <a:effectLst/>
+            </c:spPr>
+          </c:dPt>
+          <c:dPt>
+            <c:idx val="3"/>
+            <c:invertIfNegative val="0"/>
+            <c:bubble3D val="0"/>
+            <c:spPr>
+              <a:solidFill>
+                <a:srgbClr val="BFDBFE"/>
+              </a:solidFill>
+              <a:effectLst/>
+            </c:spPr>
+          </c:dPt>
+          <c:dPt>
+            <c:idx val="4"/>
+            <c:invertIfNegative val="0"/>
+            <c:bubble3D val="0"/>
+            <c:spPr>
+              <a:solidFill>
+                <a:srgbClr val="1D4ED8"/>
+              </a:solidFill>
+              <a:effectLst/>
+            </c:spPr>
+          </c:dPt>
+          <c:dPt>
+            <c:idx val="5"/>
+            <c:invertIfNegative val="0"/>
+            <c:bubble3D val="0"/>
+            <c:spPr>
+              <a:solidFill>
+                <a:srgbClr val="2563EB"/>
+              </a:solidFill>
+              <a:effectLst/>
+            </c:spPr>
+          </c:dPt>
+          <c:cat>
+            <c:multiLvlStrRef>
+              <c:f>Sheet1!$A$2:$A$7</c:f>
+              <c:multiLvlStrCache>
+                <c:ptCount val="6"/>
+                <c:lvl>
+                  <c:pt idx="0">
+                    <c:v>Early Life…</c:v>
+                  </c:pt>
+                  <c:pt idx="1">
+                    <c:v>Academic E…</c:v>
+                  </c:pt>
+                  <c:pt idx="2">
+                    <c:v>Political …</c:v>
+                  </c:pt>
+                  <c:pt idx="3">
+                    <c:v>Leadership…</c:v>
+                  </c:pt>
+                  <c:pt idx="4">
+                    <c:v>Role in Pa…</c:v>
+                  </c:pt>
+                  <c:pt idx="5">
+                    <c:v>Legacy and…</c:v>
+                  </c:pt>
+                </c:lvl>
+              </c:multiLvlStrCache>
+            </c:multiLvlStrRef>
+          </c:cat>
+          <c:val>
+            <c:numRef>
+              <c:f>Sheet1!$B$2:$B$7</c:f>
+              <c:numCache>
+                <c:formatCode>General</c:formatCode>
+                <c:ptCount val="6"/>
+                <c:pt idx="0">
+                  <c:v>4</c:v>
+                </c:pt>
+                <c:pt idx="1">
+                  <c:v>4</c:v>
+                </c:pt>
+                <c:pt idx="2">
+                  <c:v>4</c:v>
+                </c:pt>
+                <c:pt idx="3">
+                  <c:v>4</c:v>
+                </c:pt>
+                <c:pt idx="4">
+                  <c:v>4</c:v>
+                </c:pt>
+                <c:pt idx="5">
+                  <c:v>4</c:v>
+                </c:pt>
+              </c:numCache>
+            </c:numRef>
+          </c:val>
+        </c:ser>
+        <c:dLbls>
+          <c:numFmt formatCode="#,##0" sourceLinked="0"/>
+          <c:txPr>
+            <a:bodyPr/>
+            <a:lstStyle/>
+            <a:p>
+              <a:pPr>
+                <a:defRPr b="0" i="0" strike="noStrike" sz="1000" u="none">
+                  <a:solidFill>
+                    <a:srgbClr val="334155"/>
+                  </a:solidFill>
+                  <a:latin typeface="Arial"/>
+                </a:defRPr>
+              </a:pPr>
+            </a:p>
+          </c:txPr>
+          <c:showLegendKey val="0"/>
+          <c:showVal val="1"/>
+          <c:showCatName val="0"/>
+          <c:showSerName val="0"/>
+          <c:showPercent val="0"/>
+          <c:showBubbleSize val="0"/>
+          <c:showLeaderLines val="0"/>
+        </c:dLbls>
+        <c:gapWidth val="55"/>
+        <c:overlap val="0"/>
+        <c:axId val="2094734554"/>
+        <c:axId val="2094734552"/>
+        <c:axId val="2094734556"/>
+      </c:barChart>
+      <c:catAx>
+        <c:axId val="2094734554"/>
+        <c:scaling>
+          <c:orientation val="minMax"/>
+        </c:scaling>
+        <c:delete val="0"/>
+        <c:axPos val="b"/>
+        <c:numFmt formatCode="General" sourceLinked="1"/>
+        <c:majorTickMark val="out"/>
+        <c:minorTickMark val="none"/>
+        <c:tickLblPos val="low"/>
+        <c:spPr>
+          <a:ln w="12700" cap="flat">
+            <a:solidFill>
+              <a:srgbClr val="888888"/>
+            </a:solidFill>
+            <a:prstDash val="solid"/>
+            <a:round/>
+          </a:ln>
+        </c:spPr>
+        <c:txPr>
+          <a:bodyPr/>
+          <a:lstStyle/>
+          <a:p>
+            <a:pPr>
+              <a:defRPr sz="900" b="0" i="0" u="none" strike="noStrike">
+                <a:solidFill>
+                  <a:srgbClr val="334155"/>
+                </a:solidFill>
+                <a:latin typeface="Arial"/>
+              </a:defRPr>
+            </a:pPr>
+            <a:endParaRPr lang="en-US"/>
+          </a:p>
+        </c:txPr>
+        <c:crossAx val="2094734552"/>
+        <c:crosses val="autoZero"/>
+        <c:auto val="1"/>
+        <c:lblAlgn val="ctr"/>
+        <c:noMultiLvlLbl val="1"/>
+      </c:catAx>
+      <c:valAx>
+        <c:axId val="2094734552"/>
+        <c:scaling>
+          <c:orientation val="minMax"/>
+        </c:scaling>
+        <c:delete val="0"/>
+        <c:axPos val="l"/>
+        <c:majorGridlines>
+          <c:spPr>
+            <a:ln w="6350" cap="flat">
+              <a:solidFill>
+                <a:srgbClr val="E2E8F0"/>
+              </a:solidFill>
+              <a:prstDash val="dash"/>
+              <a:round/>
+            </a:ln>
+          </c:spPr>
+        </c:majorGridlines>
+        <c:numFmt formatCode="General" sourceLinked="0"/>
+        <c:majorTickMark val="out"/>
+        <c:minorTickMark val="none"/>
+        <c:tickLblPos val="nextTo"/>
+        <c:spPr>
+          <a:ln w="12700" cap="flat">
+            <a:solidFill>
+              <a:srgbClr val="888888"/>
+            </a:solidFill>
+            <a:prstDash val="solid"/>
+            <a:round/>
+          </a:ln>
+        </c:spPr>
+        <c:txPr>
+          <a:bodyPr/>
+          <a:lstStyle/>
+          <a:p>
+            <a:pPr>
+              <a:defRPr sz="900" b="0" i="0" u="none" strike="noStrike">
+                <a:solidFill>
+                  <a:srgbClr val="64748B"/>
+                </a:solidFill>
+                <a:latin typeface="Arial"/>
+              </a:defRPr>
+            </a:pPr>
+            <a:endParaRPr lang="en-US"/>
+          </a:p>
+        </c:txPr>
+        <c:crossAx val="2094734554"/>
+        <c:crosses val="autoZero"/>
+        <c:crossBetween val="between"/>
+      </c:valAx>
+      <c:spPr>
+        <a:noFill/>
+        <a:ln w="12700" cap="flat">
+          <a:solidFill>
+            <a:srgbClr val="FFFFFF"/>
+          </a:solidFill>
+        </a:ln>
+        <a:effectLst/>
+      </c:spPr>
+    </c:plotArea>
+    <c:plotVisOnly val="1"/>
+    <c:dispBlanksAs val="span"/>
+  </c:chart>
+  <c:spPr>
+    <a:noFill/>
+    <a:ln>
+      <a:noFill/>
+    </a:ln>
+    <a:effectLst/>
+  </c:spPr>
+  <c:externalData r:id="rId1">
+    <c:autoUpdate val="0"/>
+  </c:externalData>
+</c:chartSpace>
+</file>
+
+<file path=ppt/charts/chart4.xml><?xml version="1.0" encoding="utf-8"?>
+<c:chartSpace xmlns:c="http://schemas.openxmlformats.org/drawingml/2006/chart" xmlns:a="http://schemas.openxmlformats.org/drawingml/2006/main" xmlns:r="http://schemas.openxmlformats.org/officeDocument/2006/relationships">
+  <c:date1904 val="0"/>
+  <c:roundedCorners val="1"/>
+  <c:chart>
+    <c:autoTitleDeleted val="1"/>
+    <c:plotArea>
+      <c:layout/>
+      <c:barChart>
+        <c:barDir val="col"/>
+        <c:grouping val="clustered"/>
+        <c:varyColors val="0"/>
+        <c:ser>
+          <c:idx val="0"/>
+          <c:order val="0"/>
+          <c:tx>
+            <c:strRef>
+              <c:f>Sheet1!$B$1</c:f>
+              <c:strCache>
+                <c:ptCount val="1"/>
+                <c:pt idx="0">
+                  <c:v>Points</c:v>
+                </c:pt>
+              </c:strCache>
+            </c:strRef>
+          </c:tx>
+          <c:spPr>
+            <a:solidFill>
+              <a:srgbClr val="2563EB"/>
+            </a:solidFill>
+            <a:effectLst/>
+          </c:spPr>
+          <c:invertIfNegative val="0"/>
+          <c:dLbls>
+            <c:numFmt formatCode="#,##0" sourceLinked="0"/>
+            <c:txPr>
+              <a:bodyPr/>
+              <a:lstStyle/>
+              <a:p>
+                <a:pPr>
+                  <a:defRPr b="0" i="0" strike="noStrike" sz="1000" u="none">
+                    <a:solidFill>
+                      <a:srgbClr val="334155"/>
+                    </a:solidFill>
+                    <a:latin typeface="Arial"/>
+                  </a:defRPr>
+                </a:pPr>
+              </a:p>
+            </c:txPr>
+            <c:showLegendKey val="0"/>
+            <c:showVal val="1"/>
+            <c:showCatName val="0"/>
+            <c:showSerName val="0"/>
+            <c:showPercent val="0"/>
+            <c:showBubbleSize val="0"/>
+            <c:showLeaderLines val="0"/>
+          </c:dLbls>
+          <c:dPt>
+            <c:idx val="0"/>
+            <c:invertIfNegative val="0"/>
+            <c:bubble3D val="0"/>
+            <c:spPr>
+              <a:solidFill>
+                <a:srgbClr val="2563EB"/>
+              </a:solidFill>
+              <a:effectLst/>
+            </c:spPr>
+          </c:dPt>
+          <c:dPt>
+            <c:idx val="1"/>
+            <c:invertIfNegative val="0"/>
+            <c:bubble3D val="0"/>
+            <c:spPr>
+              <a:solidFill>
+                <a:srgbClr val="60A5FA"/>
+              </a:solidFill>
+              <a:effectLst/>
+            </c:spPr>
+          </c:dPt>
+          <c:dPt>
+            <c:idx val="2"/>
+            <c:invertIfNegative val="0"/>
+            <c:bubble3D val="0"/>
+            <c:spPr>
+              <a:solidFill>
+                <a:srgbClr val="93C5FD"/>
+              </a:solidFill>
+              <a:effectLst/>
+            </c:spPr>
+          </c:dPt>
+          <c:dPt>
+            <c:idx val="3"/>
+            <c:invertIfNegative val="0"/>
+            <c:bubble3D val="0"/>
+            <c:spPr>
+              <a:solidFill>
+                <a:srgbClr val="BFDBFE"/>
+              </a:solidFill>
+              <a:effectLst/>
+            </c:spPr>
+          </c:dPt>
+          <c:dPt>
+            <c:idx val="4"/>
+            <c:invertIfNegative val="0"/>
+            <c:bubble3D val="0"/>
+            <c:spPr>
+              <a:solidFill>
+                <a:srgbClr val="1D4ED8"/>
+              </a:solidFill>
+              <a:effectLst/>
+            </c:spPr>
+          </c:dPt>
+          <c:dPt>
+            <c:idx val="5"/>
+            <c:invertIfNegative val="0"/>
+            <c:bubble3D val="0"/>
+            <c:spPr>
+              <a:solidFill>
+                <a:srgbClr val="2563EB"/>
+              </a:solidFill>
+              <a:effectLst/>
+            </c:spPr>
+          </c:dPt>
+          <c:cat>
+            <c:multiLvlStrRef>
+              <c:f>Sheet1!$A$2:$A$7</c:f>
+              <c:multiLvlStrCache>
+                <c:ptCount val="6"/>
+                <c:lvl>
+                  <c:pt idx="0">
+                    <c:v>Early Life…</c:v>
+                  </c:pt>
+                  <c:pt idx="1">
+                    <c:v>Academic E…</c:v>
+                  </c:pt>
+                  <c:pt idx="2">
+                    <c:v>Political …</c:v>
+                  </c:pt>
+                  <c:pt idx="3">
+                    <c:v>Leadership…</c:v>
+                  </c:pt>
+                  <c:pt idx="4">
+                    <c:v>Role in Pa…</c:v>
+                  </c:pt>
+                  <c:pt idx="5">
+                    <c:v>Legacy and…</c:v>
+                  </c:pt>
+                </c:lvl>
+              </c:multiLvlStrCache>
+            </c:multiLvlStrRef>
+          </c:cat>
+          <c:val>
+            <c:numRef>
+              <c:f>Sheet1!$B$2:$B$7</c:f>
+              <c:numCache>
+                <c:formatCode>General</c:formatCode>
+                <c:ptCount val="6"/>
+                <c:pt idx="0">
+                  <c:v>4</c:v>
+                </c:pt>
+                <c:pt idx="1">
+                  <c:v>4</c:v>
+                </c:pt>
+                <c:pt idx="2">
+                  <c:v>4</c:v>
+                </c:pt>
+                <c:pt idx="3">
+                  <c:v>4</c:v>
+                </c:pt>
+                <c:pt idx="4">
+                  <c:v>4</c:v>
+                </c:pt>
+                <c:pt idx="5">
+                  <c:v>4</c:v>
+                </c:pt>
+              </c:numCache>
+            </c:numRef>
+          </c:val>
+        </c:ser>
+        <c:dLbls>
+          <c:numFmt formatCode="#,##0" sourceLinked="0"/>
+          <c:txPr>
+            <a:bodyPr/>
+            <a:lstStyle/>
+            <a:p>
+              <a:pPr>
+                <a:defRPr b="0" i="0" strike="noStrike" sz="1000" u="none">
+                  <a:solidFill>
+                    <a:srgbClr val="334155"/>
+                  </a:solidFill>
+                  <a:latin typeface="Arial"/>
+                </a:defRPr>
+              </a:pPr>
+            </a:p>
+          </c:txPr>
+          <c:showLegendKey val="0"/>
+          <c:showVal val="1"/>
+          <c:showCatName val="0"/>
+          <c:showSerName val="0"/>
+          <c:showPercent val="0"/>
+          <c:showBubbleSize val="0"/>
+          <c:showLeaderLines val="0"/>
+        </c:dLbls>
+        <c:gapWidth val="55"/>
+        <c:overlap val="0"/>
+        <c:axId val="2094734554"/>
+        <c:axId val="2094734552"/>
+        <c:axId val="2094734556"/>
+      </c:barChart>
+      <c:catAx>
+        <c:axId val="2094734554"/>
+        <c:scaling>
+          <c:orientation val="minMax"/>
+        </c:scaling>
+        <c:delete val="0"/>
+        <c:axPos val="b"/>
+        <c:numFmt formatCode="General" sourceLinked="1"/>
+        <c:majorTickMark val="out"/>
+        <c:minorTickMark val="none"/>
+        <c:tickLblPos val="low"/>
+        <c:spPr>
+          <a:ln w="12700" cap="flat">
+            <a:solidFill>
+              <a:srgbClr val="888888"/>
+            </a:solidFill>
+            <a:prstDash val="solid"/>
+            <a:round/>
+          </a:ln>
+        </c:spPr>
+        <c:txPr>
+          <a:bodyPr/>
+          <a:lstStyle/>
+          <a:p>
+            <a:pPr>
+              <a:defRPr sz="900" b="0" i="0" u="none" strike="noStrike">
+                <a:solidFill>
+                  <a:srgbClr val="334155"/>
+                </a:solidFill>
+                <a:latin typeface="Arial"/>
+              </a:defRPr>
+            </a:pPr>
+            <a:endParaRPr lang="en-US"/>
+          </a:p>
+        </c:txPr>
+        <c:crossAx val="2094734552"/>
+        <c:crosses val="autoZero"/>
+        <c:auto val="1"/>
+        <c:lblAlgn val="ctr"/>
+        <c:noMultiLvlLbl val="1"/>
+      </c:catAx>
+      <c:valAx>
+        <c:axId val="2094734552"/>
+        <c:scaling>
+          <c:orientation val="minMax"/>
+        </c:scaling>
+        <c:delete val="0"/>
+        <c:axPos val="l"/>
+        <c:majorGridlines>
+          <c:spPr>
+            <a:ln w="6350" cap="flat">
+              <a:solidFill>
+                <a:srgbClr val="E2E8F0"/>
+              </a:solidFill>
+              <a:prstDash val="dash"/>
+              <a:round/>
+            </a:ln>
+          </c:spPr>
+        </c:majorGridlines>
+        <c:numFmt formatCode="General" sourceLinked="0"/>
+        <c:majorTickMark val="out"/>
+        <c:minorTickMark val="none"/>
+        <c:tickLblPos val="nextTo"/>
+        <c:spPr>
+          <a:ln w="12700" cap="flat">
+            <a:solidFill>
+              <a:srgbClr val="888888"/>
+            </a:solidFill>
+            <a:prstDash val="solid"/>
+            <a:round/>
+          </a:ln>
+        </c:spPr>
+        <c:txPr>
+          <a:bodyPr/>
+          <a:lstStyle/>
+          <a:p>
+            <a:pPr>
+              <a:defRPr sz="900" b="0" i="0" u="none" strike="noStrike">
+                <a:solidFill>
+                  <a:srgbClr val="64748B"/>
+                </a:solidFill>
+                <a:latin typeface="Arial"/>
+              </a:defRPr>
+            </a:pPr>
+            <a:endParaRPr lang="en-US"/>
+          </a:p>
+        </c:txPr>
+        <c:crossAx val="2094734554"/>
+        <c:crosses val="autoZero"/>
+        <c:crossBetween val="between"/>
+      </c:valAx>
+      <c:spPr>
+        <a:noFill/>
+        <a:ln w="12700" cap="flat">
+          <a:solidFill>
+            <a:srgbClr val="FFFFFF"/>
+          </a:solidFill>
+        </a:ln>
+        <a:effectLst/>
+      </c:spPr>
+    </c:plotArea>
+    <c:plotVisOnly val="1"/>
+    <c:dispBlanksAs val="span"/>
+  </c:chart>
+  <c:spPr>
+    <a:noFill/>
+    <a:ln>
+      <a:noFill/>
+    </a:ln>
+    <a:effectLst/>
+  </c:spPr>
+  <c:externalData r:id="rId1">
+    <c:autoUpdate val="0"/>
+  </c:externalData>
+</c:chartSpace>
+</file>
+
+<file path=ppt/charts/chart5.xml><?xml version="1.0" encoding="utf-8"?>
+<c:chartSpace xmlns:c="http://schemas.openxmlformats.org/drawingml/2006/chart" xmlns:a="http://schemas.openxmlformats.org/drawingml/2006/main" xmlns:r="http://schemas.openxmlformats.org/officeDocument/2006/relationships">
+  <c:date1904 val="0"/>
+  <c:roundedCorners val="1"/>
+  <c:chart>
+    <c:autoTitleDeleted val="1"/>
+    <c:plotArea>
+      <c:layout/>
+      <c:barChart>
+        <c:barDir val="col"/>
+        <c:grouping val="clustered"/>
+        <c:varyColors val="0"/>
+        <c:ser>
+          <c:idx val="0"/>
+          <c:order val="0"/>
+          <c:tx>
+            <c:strRef>
+              <c:f>Sheet1!$B$1</c:f>
+              <c:strCache>
+                <c:ptCount val="1"/>
+                <c:pt idx="0">
+                  <c:v>Points</c:v>
+                </c:pt>
+              </c:strCache>
+            </c:strRef>
+          </c:tx>
+          <c:spPr>
+            <a:solidFill>
+              <a:srgbClr val="2563EB"/>
+            </a:solidFill>
+            <a:effectLst/>
+          </c:spPr>
+          <c:invertIfNegative val="0"/>
+          <c:dLbls>
+            <c:numFmt formatCode="#,##0" sourceLinked="0"/>
+            <c:txPr>
+              <a:bodyPr/>
+              <a:lstStyle/>
+              <a:p>
+                <a:pPr>
+                  <a:defRPr b="0" i="0" strike="noStrike" sz="1000" u="none">
+                    <a:solidFill>
+                      <a:srgbClr val="334155"/>
+                    </a:solidFill>
+                    <a:latin typeface="Arial"/>
+                  </a:defRPr>
+                </a:pPr>
+              </a:p>
+            </c:txPr>
+            <c:showLegendKey val="0"/>
+            <c:showVal val="1"/>
+            <c:showCatName val="0"/>
+            <c:showSerName val="0"/>
+            <c:showPercent val="0"/>
+            <c:showBubbleSize val="0"/>
+            <c:showLeaderLines val="0"/>
+          </c:dLbls>
+          <c:dPt>
+            <c:idx val="0"/>
+            <c:invertIfNegative val="0"/>
+            <c:bubble3D val="0"/>
+            <c:spPr>
+              <a:solidFill>
+                <a:srgbClr val="2563EB"/>
+              </a:solidFill>
+              <a:effectLst/>
+            </c:spPr>
+          </c:dPt>
+          <c:dPt>
+            <c:idx val="1"/>
+            <c:invertIfNegative val="0"/>
+            <c:bubble3D val="0"/>
+            <c:spPr>
+              <a:solidFill>
+                <a:srgbClr val="60A5FA"/>
+              </a:solidFill>
+              <a:effectLst/>
+            </c:spPr>
+          </c:dPt>
+          <c:dPt>
+            <c:idx val="2"/>
+            <c:invertIfNegative val="0"/>
+            <c:bubble3D val="0"/>
+            <c:spPr>
+              <a:solidFill>
+                <a:srgbClr val="93C5FD"/>
+              </a:solidFill>
+              <a:effectLst/>
+            </c:spPr>
+          </c:dPt>
+          <c:dPt>
+            <c:idx val="3"/>
+            <c:invertIfNegative val="0"/>
+            <c:bubble3D val="0"/>
+            <c:spPr>
+              <a:solidFill>
+                <a:srgbClr val="BFDBFE"/>
+              </a:solidFill>
+              <a:effectLst/>
+            </c:spPr>
+          </c:dPt>
+          <c:dPt>
+            <c:idx val="4"/>
+            <c:invertIfNegative val="0"/>
+            <c:bubble3D val="0"/>
+            <c:spPr>
+              <a:solidFill>
+                <a:srgbClr val="1D4ED8"/>
+              </a:solidFill>
+              <a:effectLst/>
+            </c:spPr>
+          </c:dPt>
+          <c:dPt>
+            <c:idx val="5"/>
+            <c:invertIfNegative val="0"/>
+            <c:bubble3D val="0"/>
+            <c:spPr>
+              <a:solidFill>
+                <a:srgbClr val="2563EB"/>
+              </a:solidFill>
+              <a:effectLst/>
+            </c:spPr>
+          </c:dPt>
+          <c:cat>
+            <c:multiLvlStrRef>
+              <c:f>Sheet1!$A$2:$A$7</c:f>
+              <c:multiLvlStrCache>
+                <c:ptCount val="6"/>
+                <c:lvl>
+                  <c:pt idx="0">
+                    <c:v>Early Life…</c:v>
+                  </c:pt>
+                  <c:pt idx="1">
+                    <c:v>Academic E…</c:v>
+                  </c:pt>
+                  <c:pt idx="2">
+                    <c:v>Political …</c:v>
+                  </c:pt>
+                  <c:pt idx="3">
+                    <c:v>Leadership…</c:v>
+                  </c:pt>
+                  <c:pt idx="4">
+                    <c:v>Role in Pa…</c:v>
+                  </c:pt>
+                  <c:pt idx="5">
+                    <c:v>Legacy and…</c:v>
+                  </c:pt>
+                </c:lvl>
+              </c:multiLvlStrCache>
+            </c:multiLvlStrRef>
+          </c:cat>
+          <c:val>
+            <c:numRef>
+              <c:f>Sheet1!$B$2:$B$7</c:f>
+              <c:numCache>
+                <c:formatCode>General</c:formatCode>
+                <c:ptCount val="6"/>
+                <c:pt idx="0">
+                  <c:v>4</c:v>
+                </c:pt>
+                <c:pt idx="1">
+                  <c:v>4</c:v>
+                </c:pt>
+                <c:pt idx="2">
+                  <c:v>4</c:v>
+                </c:pt>
+                <c:pt idx="3">
+                  <c:v>4</c:v>
+                </c:pt>
+                <c:pt idx="4">
+                  <c:v>4</c:v>
+                </c:pt>
+                <c:pt idx="5">
+                  <c:v>4</c:v>
+                </c:pt>
+              </c:numCache>
+            </c:numRef>
+          </c:val>
+        </c:ser>
+        <c:dLbls>
+          <c:numFmt formatCode="#,##0" sourceLinked="0"/>
+          <c:txPr>
+            <a:bodyPr/>
+            <a:lstStyle/>
+            <a:p>
+              <a:pPr>
+                <a:defRPr b="0" i="0" strike="noStrike" sz="1000" u="none">
+                  <a:solidFill>
+                    <a:srgbClr val="334155"/>
+                  </a:solidFill>
+                  <a:latin typeface="Arial"/>
+                </a:defRPr>
+              </a:pPr>
+            </a:p>
+          </c:txPr>
+          <c:showLegendKey val="0"/>
+          <c:showVal val="1"/>
+          <c:showCatName val="0"/>
+          <c:showSerName val="0"/>
+          <c:showPercent val="0"/>
+          <c:showBubbleSize val="0"/>
+          <c:showLeaderLines val="0"/>
+        </c:dLbls>
+        <c:gapWidth val="55"/>
+        <c:overlap val="0"/>
+        <c:axId val="2094734554"/>
+        <c:axId val="2094734552"/>
+        <c:axId val="2094734556"/>
+      </c:barChart>
+      <c:catAx>
+        <c:axId val="2094734554"/>
+        <c:scaling>
+          <c:orientation val="minMax"/>
+        </c:scaling>
+        <c:delete val="0"/>
+        <c:axPos val="b"/>
+        <c:numFmt formatCode="General" sourceLinked="1"/>
+        <c:majorTickMark val="out"/>
+        <c:minorTickMark val="none"/>
+        <c:tickLblPos val="low"/>
+        <c:spPr>
+          <a:ln w="12700" cap="flat">
+            <a:solidFill>
+              <a:srgbClr val="888888"/>
+            </a:solidFill>
+            <a:prstDash val="solid"/>
+            <a:round/>
+          </a:ln>
+        </c:spPr>
+        <c:txPr>
+          <a:bodyPr/>
+          <a:lstStyle/>
+          <a:p>
+            <a:pPr>
+              <a:defRPr sz="900" b="0" i="0" u="none" strike="noStrike">
+                <a:solidFill>
+                  <a:srgbClr val="334155"/>
+                </a:solidFill>
+                <a:latin typeface="Arial"/>
+              </a:defRPr>
+            </a:pPr>
+            <a:endParaRPr lang="en-US"/>
+          </a:p>
+        </c:txPr>
+        <c:crossAx val="2094734552"/>
+        <c:crosses val="autoZero"/>
+        <c:auto val="1"/>
+        <c:lblAlgn val="ctr"/>
+        <c:noMultiLvlLbl val="1"/>
+      </c:catAx>
+      <c:valAx>
+        <c:axId val="2094734552"/>
+        <c:scaling>
+          <c:orientation val="minMax"/>
+        </c:scaling>
+        <c:delete val="0"/>
+        <c:axPos val="l"/>
+        <c:majorGridlines>
+          <c:spPr>
+            <a:ln w="6350" cap="flat">
+              <a:solidFill>
+                <a:srgbClr val="E2E8F0"/>
+              </a:solidFill>
+              <a:prstDash val="dash"/>
+              <a:round/>
+            </a:ln>
+          </c:spPr>
+        </c:majorGridlines>
+        <c:numFmt formatCode="General" sourceLinked="0"/>
+        <c:majorTickMark val="out"/>
+        <c:minorTickMark val="none"/>
+        <c:tickLblPos val="nextTo"/>
+        <c:spPr>
+          <a:ln w="12700" cap="flat">
+            <a:solidFill>
+              <a:srgbClr val="888888"/>
+            </a:solidFill>
+            <a:prstDash val="solid"/>
+            <a:round/>
+          </a:ln>
+        </c:spPr>
+        <c:txPr>
+          <a:bodyPr/>
+          <a:lstStyle/>
+          <a:p>
+            <a:pPr>
+              <a:defRPr sz="900" b="0" i="0" u="none" strike="noStrike">
+                <a:solidFill>
+                  <a:srgbClr val="64748B"/>
+                </a:solidFill>
+                <a:latin typeface="Arial"/>
+              </a:defRPr>
+            </a:pPr>
+            <a:endParaRPr lang="en-US"/>
+          </a:p>
+        </c:txPr>
+        <c:crossAx val="2094734554"/>
+        <c:crosses val="autoZero"/>
+        <c:crossBetween val="between"/>
+      </c:valAx>
+      <c:spPr>
+        <a:noFill/>
+        <a:ln w="12700" cap="flat">
+          <a:solidFill>
+            <a:srgbClr val="FFFFFF"/>
+          </a:solidFill>
+        </a:ln>
+        <a:effectLst/>
+      </c:spPr>
+    </c:plotArea>
+    <c:plotVisOnly val="1"/>
+    <c:dispBlanksAs val="span"/>
+  </c:chart>
+  <c:spPr>
+    <a:noFill/>
+    <a:ln>
+      <a:noFill/>
+    </a:ln>
+    <a:effectLst/>
+  </c:spPr>
+  <c:externalData r:id="rId1">
+    <c:autoUpdate val="0"/>
+  </c:externalData>
+</c:chartSpace>
 </file>
 
 <file path=ppt/notesMasters/notesMaster1.xml><?xml version="1.0" encoding="utf-8"?>
@@ -551,6 +2186,358 @@
 </p:notes>
 </file>
 
+<file path=ppt/notesSlides/notesSlide10.xml><?xml version="1.0" encoding="utf-8"?>
+<p:notes xmlns:a="http://schemas.openxmlformats.org/drawingml/2006/main" xmlns:r="http://schemas.openxmlformats.org/officeDocument/2006/relationships" xmlns:p="http://schemas.openxmlformats.org/presentationml/2006/main">
+  <p:cSld>
+    <p:spTree>
+      <p:nvGrpSpPr>
+        <p:cNvPr id="1" name=""/>
+        <p:cNvGrpSpPr/>
+        <p:nvPr/>
+      </p:nvGrpSpPr>
+      <p:grpSpPr>
+        <a:xfrm>
+          <a:off x="0" y="0"/>
+          <a:ext cx="0" cy="0"/>
+          <a:chOff x="0" y="0"/>
+          <a:chExt cx="0" cy="0"/>
+        </a:xfrm>
+      </p:grpSpPr>
+      <p:sp>
+        <p:nvSpPr>
+          <p:cNvPr id="2" name="Slide Image Placeholder 1"/>
+          <p:cNvSpPr>
+            <a:spLocks noGrp="1" noRot="1" noChangeAspect="1"/>
+          </p:cNvSpPr>
+          <p:nvPr>
+            <p:ph type="sldImg"/>
+          </p:nvPr>
+        </p:nvSpPr>
+        <p:spPr/>
+      </p:sp>
+      <p:sp>
+        <p:nvSpPr>
+          <p:cNvPr id="3" name="Notes Placeholder 2"/>
+          <p:cNvSpPr>
+            <a:spLocks noGrp="1"/>
+          </p:cNvSpPr>
+          <p:nvPr>
+            <p:ph type="body" idx="1"/>
+          </p:nvPr>
+        </p:nvSpPr>
+        <p:spPr/>
+        <p:txBody>
+          <a:bodyPr/>
+          <a:lstStyle/>
+          <a:p>
+            <a:r>
+              <a:rPr lang="en-US" dirty="0"/>
+              <a:t/>
+            </a:r>
+            <a:endParaRPr lang="en-US" dirty="0"/>
+          </a:p>
+        </p:txBody>
+      </p:sp>
+      <p:sp>
+        <p:nvSpPr>
+          <p:cNvPr id="4" name="Slide Number Placeholder 3"/>
+          <p:cNvSpPr>
+            <a:spLocks noGrp="1"/>
+          </p:cNvSpPr>
+          <p:nvPr>
+            <p:ph type="sldNum" sz="quarter" idx="10"/>
+          </p:nvPr>
+        </p:nvSpPr>
+        <p:spPr/>
+        <p:txBody>
+          <a:bodyPr/>
+          <a:lstStyle/>
+          <a:p>
+            <a:fld id="{F7021451-1387-4CA6-816F-3879F97B5CBC}" type="slidenum">
+              <a:rPr lang="en-US"/>
+              <a:t>10</a:t>
+            </a:fld>
+            <a:endParaRPr lang="en-US"/>
+          </a:p>
+        </p:txBody>
+      </p:sp>
+    </p:spTree>
+    <p:extLst>
+      <p:ext uri="{BB962C8B-B14F-4D97-AF65-F5344CB8AC3E}">
+        <p14:creationId xmlns:p14="http://schemas.microsoft.com/office/powerpoint/2010/main" val="1024086991"/>
+      </p:ext>
+    </p:extLst>
+  </p:cSld>
+  <p:clrMapOvr>
+    <a:masterClrMapping/>
+  </p:clrMapOvr>
+</p:notes>
+</file>
+
+<file path=ppt/notesSlides/notesSlide11.xml><?xml version="1.0" encoding="utf-8"?>
+<p:notes xmlns:a="http://schemas.openxmlformats.org/drawingml/2006/main" xmlns:r="http://schemas.openxmlformats.org/officeDocument/2006/relationships" xmlns:p="http://schemas.openxmlformats.org/presentationml/2006/main">
+  <p:cSld>
+    <p:spTree>
+      <p:nvGrpSpPr>
+        <p:cNvPr id="1" name=""/>
+        <p:cNvGrpSpPr/>
+        <p:nvPr/>
+      </p:nvGrpSpPr>
+      <p:grpSpPr>
+        <a:xfrm>
+          <a:off x="0" y="0"/>
+          <a:ext cx="0" cy="0"/>
+          <a:chOff x="0" y="0"/>
+          <a:chExt cx="0" cy="0"/>
+        </a:xfrm>
+      </p:grpSpPr>
+      <p:sp>
+        <p:nvSpPr>
+          <p:cNvPr id="2" name="Slide Image Placeholder 1"/>
+          <p:cNvSpPr>
+            <a:spLocks noGrp="1" noRot="1" noChangeAspect="1"/>
+          </p:cNvSpPr>
+          <p:nvPr>
+            <p:ph type="sldImg"/>
+          </p:nvPr>
+        </p:nvSpPr>
+        <p:spPr/>
+      </p:sp>
+      <p:sp>
+        <p:nvSpPr>
+          <p:cNvPr id="3" name="Notes Placeholder 2"/>
+          <p:cNvSpPr>
+            <a:spLocks noGrp="1"/>
+          </p:cNvSpPr>
+          <p:nvPr>
+            <p:ph type="body" idx="1"/>
+          </p:nvPr>
+        </p:nvSpPr>
+        <p:spPr/>
+        <p:txBody>
+          <a:bodyPr/>
+          <a:lstStyle/>
+          <a:p>
+            <a:r>
+              <a:rPr lang="en-US" dirty="0"/>
+              <a:t/>
+            </a:r>
+            <a:endParaRPr lang="en-US" dirty="0"/>
+          </a:p>
+        </p:txBody>
+      </p:sp>
+      <p:sp>
+        <p:nvSpPr>
+          <p:cNvPr id="4" name="Slide Number Placeholder 3"/>
+          <p:cNvSpPr>
+            <a:spLocks noGrp="1"/>
+          </p:cNvSpPr>
+          <p:nvPr>
+            <p:ph type="sldNum" sz="quarter" idx="10"/>
+          </p:nvPr>
+        </p:nvSpPr>
+        <p:spPr/>
+        <p:txBody>
+          <a:bodyPr/>
+          <a:lstStyle/>
+          <a:p>
+            <a:fld id="{F7021451-1387-4CA6-816F-3879F97B5CBC}" type="slidenum">
+              <a:rPr lang="en-US"/>
+              <a:t>11</a:t>
+            </a:fld>
+            <a:endParaRPr lang="en-US"/>
+          </a:p>
+        </p:txBody>
+      </p:sp>
+    </p:spTree>
+    <p:extLst>
+      <p:ext uri="{BB962C8B-B14F-4D97-AF65-F5344CB8AC3E}">
+        <p14:creationId xmlns:p14="http://schemas.microsoft.com/office/powerpoint/2010/main" val="1024086991"/>
+      </p:ext>
+    </p:extLst>
+  </p:cSld>
+  <p:clrMapOvr>
+    <a:masterClrMapping/>
+  </p:clrMapOvr>
+</p:notes>
+</file>
+
+<file path=ppt/notesSlides/notesSlide12.xml><?xml version="1.0" encoding="utf-8"?>
+<p:notes xmlns:a="http://schemas.openxmlformats.org/drawingml/2006/main" xmlns:r="http://schemas.openxmlformats.org/officeDocument/2006/relationships" xmlns:p="http://schemas.openxmlformats.org/presentationml/2006/main">
+  <p:cSld>
+    <p:spTree>
+      <p:nvGrpSpPr>
+        <p:cNvPr id="1" name=""/>
+        <p:cNvGrpSpPr/>
+        <p:nvPr/>
+      </p:nvGrpSpPr>
+      <p:grpSpPr>
+        <a:xfrm>
+          <a:off x="0" y="0"/>
+          <a:ext cx="0" cy="0"/>
+          <a:chOff x="0" y="0"/>
+          <a:chExt cx="0" cy="0"/>
+        </a:xfrm>
+      </p:grpSpPr>
+      <p:sp>
+        <p:nvSpPr>
+          <p:cNvPr id="2" name="Slide Image Placeholder 1"/>
+          <p:cNvSpPr>
+            <a:spLocks noGrp="1" noRot="1" noChangeAspect="1"/>
+          </p:cNvSpPr>
+          <p:nvPr>
+            <p:ph type="sldImg"/>
+          </p:nvPr>
+        </p:nvSpPr>
+        <p:spPr/>
+      </p:sp>
+      <p:sp>
+        <p:nvSpPr>
+          <p:cNvPr id="3" name="Notes Placeholder 2"/>
+          <p:cNvSpPr>
+            <a:spLocks noGrp="1"/>
+          </p:cNvSpPr>
+          <p:nvPr>
+            <p:ph type="body" idx="1"/>
+          </p:nvPr>
+        </p:nvSpPr>
+        <p:spPr/>
+        <p:txBody>
+          <a:bodyPr/>
+          <a:lstStyle/>
+          <a:p>
+            <a:r>
+              <a:rPr lang="en-US" dirty="0"/>
+              <a:t/>
+            </a:r>
+            <a:endParaRPr lang="en-US" dirty="0"/>
+          </a:p>
+        </p:txBody>
+      </p:sp>
+      <p:sp>
+        <p:nvSpPr>
+          <p:cNvPr id="4" name="Slide Number Placeholder 3"/>
+          <p:cNvSpPr>
+            <a:spLocks noGrp="1"/>
+          </p:cNvSpPr>
+          <p:nvPr>
+            <p:ph type="sldNum" sz="quarter" idx="10"/>
+          </p:nvPr>
+        </p:nvSpPr>
+        <p:spPr/>
+        <p:txBody>
+          <a:bodyPr/>
+          <a:lstStyle/>
+          <a:p>
+            <a:fld id="{F7021451-1387-4CA6-816F-3879F97B5CBC}" type="slidenum">
+              <a:rPr lang="en-US"/>
+              <a:t>12</a:t>
+            </a:fld>
+            <a:endParaRPr lang="en-US"/>
+          </a:p>
+        </p:txBody>
+      </p:sp>
+    </p:spTree>
+    <p:extLst>
+      <p:ext uri="{BB962C8B-B14F-4D97-AF65-F5344CB8AC3E}">
+        <p14:creationId xmlns:p14="http://schemas.microsoft.com/office/powerpoint/2010/main" val="1024086991"/>
+      </p:ext>
+    </p:extLst>
+  </p:cSld>
+  <p:clrMapOvr>
+    <a:masterClrMapping/>
+  </p:clrMapOvr>
+</p:notes>
+</file>
+
+<file path=ppt/notesSlides/notesSlide13.xml><?xml version="1.0" encoding="utf-8"?>
+<p:notes xmlns:a="http://schemas.openxmlformats.org/drawingml/2006/main" xmlns:r="http://schemas.openxmlformats.org/officeDocument/2006/relationships" xmlns:p="http://schemas.openxmlformats.org/presentationml/2006/main">
+  <p:cSld>
+    <p:spTree>
+      <p:nvGrpSpPr>
+        <p:cNvPr id="1" name=""/>
+        <p:cNvGrpSpPr/>
+        <p:nvPr/>
+      </p:nvGrpSpPr>
+      <p:grpSpPr>
+        <a:xfrm>
+          <a:off x="0" y="0"/>
+          <a:ext cx="0" cy="0"/>
+          <a:chOff x="0" y="0"/>
+          <a:chExt cx="0" cy="0"/>
+        </a:xfrm>
+      </p:grpSpPr>
+      <p:sp>
+        <p:nvSpPr>
+          <p:cNvPr id="2" name="Slide Image Placeholder 1"/>
+          <p:cNvSpPr>
+            <a:spLocks noGrp="1" noRot="1" noChangeAspect="1"/>
+          </p:cNvSpPr>
+          <p:nvPr>
+            <p:ph type="sldImg"/>
+          </p:nvPr>
+        </p:nvSpPr>
+        <p:spPr/>
+      </p:sp>
+      <p:sp>
+        <p:nvSpPr>
+          <p:cNvPr id="3" name="Notes Placeholder 2"/>
+          <p:cNvSpPr>
+            <a:spLocks noGrp="1"/>
+          </p:cNvSpPr>
+          <p:nvPr>
+            <p:ph type="body" idx="1"/>
+          </p:nvPr>
+        </p:nvSpPr>
+        <p:spPr/>
+        <p:txBody>
+          <a:bodyPr/>
+          <a:lstStyle/>
+          <a:p>
+            <a:r>
+              <a:rPr lang="en-US" dirty="0"/>
+              <a:t/>
+            </a:r>
+            <a:endParaRPr lang="en-US" dirty="0"/>
+          </a:p>
+        </p:txBody>
+      </p:sp>
+      <p:sp>
+        <p:nvSpPr>
+          <p:cNvPr id="4" name="Slide Number Placeholder 3"/>
+          <p:cNvSpPr>
+            <a:spLocks noGrp="1"/>
+          </p:cNvSpPr>
+          <p:nvPr>
+            <p:ph type="sldNum" sz="quarter" idx="10"/>
+          </p:nvPr>
+        </p:nvSpPr>
+        <p:spPr/>
+        <p:txBody>
+          <a:bodyPr/>
+          <a:lstStyle/>
+          <a:p>
+            <a:fld id="{F7021451-1387-4CA6-816F-3879F97B5CBC}" type="slidenum">
+              <a:rPr lang="en-US"/>
+              <a:t>13</a:t>
+            </a:fld>
+            <a:endParaRPr lang="en-US"/>
+          </a:p>
+        </p:txBody>
+      </p:sp>
+    </p:spTree>
+    <p:extLst>
+      <p:ext uri="{BB962C8B-B14F-4D97-AF65-F5344CB8AC3E}">
+        <p14:creationId xmlns:p14="http://schemas.microsoft.com/office/powerpoint/2010/main" val="1024086991"/>
+      </p:ext>
+    </p:extLst>
+  </p:cSld>
+  <p:clrMapOvr>
+    <a:masterClrMapping/>
+  </p:clrMapOvr>
+</p:notes>
+</file>
+
 <file path=ppt/notesSlides/notesSlide2.xml><?xml version="1.0" encoding="utf-8"?>
 <p:notes xmlns:a="http://schemas.openxmlformats.org/drawingml/2006/main" xmlns:r="http://schemas.openxmlformats.org/officeDocument/2006/relationships" xmlns:p="http://schemas.openxmlformats.org/presentationml/2006/main">
   <p:cSld>
@@ -1149,6 +3136,94 @@
             <a:fld id="{F7021451-1387-4CA6-816F-3879F97B5CBC}" type="slidenum">
               <a:rPr lang="en-US"/>
               <a:t>8</a:t>
+            </a:fld>
+            <a:endParaRPr lang="en-US"/>
+          </a:p>
+        </p:txBody>
+      </p:sp>
+    </p:spTree>
+    <p:extLst>
+      <p:ext uri="{BB962C8B-B14F-4D97-AF65-F5344CB8AC3E}">
+        <p14:creationId xmlns:p14="http://schemas.microsoft.com/office/powerpoint/2010/main" val="1024086991"/>
+      </p:ext>
+    </p:extLst>
+  </p:cSld>
+  <p:clrMapOvr>
+    <a:masterClrMapping/>
+  </p:clrMapOvr>
+</p:notes>
+</file>
+
+<file path=ppt/notesSlides/notesSlide9.xml><?xml version="1.0" encoding="utf-8"?>
+<p:notes xmlns:a="http://schemas.openxmlformats.org/drawingml/2006/main" xmlns:r="http://schemas.openxmlformats.org/officeDocument/2006/relationships" xmlns:p="http://schemas.openxmlformats.org/presentationml/2006/main">
+  <p:cSld>
+    <p:spTree>
+      <p:nvGrpSpPr>
+        <p:cNvPr id="1" name=""/>
+        <p:cNvGrpSpPr/>
+        <p:nvPr/>
+      </p:nvGrpSpPr>
+      <p:grpSpPr>
+        <a:xfrm>
+          <a:off x="0" y="0"/>
+          <a:ext cx="0" cy="0"/>
+          <a:chOff x="0" y="0"/>
+          <a:chExt cx="0" cy="0"/>
+        </a:xfrm>
+      </p:grpSpPr>
+      <p:sp>
+        <p:nvSpPr>
+          <p:cNvPr id="2" name="Slide Image Placeholder 1"/>
+          <p:cNvSpPr>
+            <a:spLocks noGrp="1" noRot="1" noChangeAspect="1"/>
+          </p:cNvSpPr>
+          <p:nvPr>
+            <p:ph type="sldImg"/>
+          </p:nvPr>
+        </p:nvSpPr>
+        <p:spPr/>
+      </p:sp>
+      <p:sp>
+        <p:nvSpPr>
+          <p:cNvPr id="3" name="Notes Placeholder 2"/>
+          <p:cNvSpPr>
+            <a:spLocks noGrp="1"/>
+          </p:cNvSpPr>
+          <p:nvPr>
+            <p:ph type="body" idx="1"/>
+          </p:nvPr>
+        </p:nvSpPr>
+        <p:spPr/>
+        <p:txBody>
+          <a:bodyPr/>
+          <a:lstStyle/>
+          <a:p>
+            <a:r>
+              <a:rPr lang="en-US" dirty="0"/>
+              <a:t/>
+            </a:r>
+            <a:endParaRPr lang="en-US" dirty="0"/>
+          </a:p>
+        </p:txBody>
+      </p:sp>
+      <p:sp>
+        <p:nvSpPr>
+          <p:cNvPr id="4" name="Slide Number Placeholder 3"/>
+          <p:cNvSpPr>
+            <a:spLocks noGrp="1"/>
+          </p:cNvSpPr>
+          <p:nvPr>
+            <p:ph type="sldNum" sz="quarter" idx="10"/>
+          </p:nvPr>
+        </p:nvSpPr>
+        <p:spPr/>
+        <p:txBody>
+          <a:bodyPr/>
+          <a:lstStyle/>
+          <a:p>
+            <a:fld id="{F7021451-1387-4CA6-816F-3879F97B5CBC}" type="slidenum">
+              <a:rPr lang="en-US"/>
+              <a:t>9</a:t>
             </a:fld>
             <a:endParaRPr lang="en-US"/>
           </a:p>
@@ -1558,7 +3633,7 @@
                 <a:ea typeface="Aptos Display" pitchFamily="34" charset="-122"/>
                 <a:cs typeface="Aptos Display" pitchFamily="34" charset="-120"/>
               </a:rPr>
-              <a:t>Creating a Simple Notes App in JavaScript</a:t>
+              <a:t>Quaid-e-Azam: The Architect of Pakistan</a:t>
             </a:r>
             <a:endParaRPr lang="en-US" sz="2800" dirty="0"/>
           </a:p>
@@ -1599,7 +3674,7 @@
                 <a:ea typeface="Aptos" pitchFamily="34" charset="-122"/>
                 <a:cs typeface="Aptos" pitchFamily="34" charset="-120"/>
               </a:rPr>
-              <a:t>A Step-by-Step Guide</a:t>
+              <a:t>A Comprehensive Overview of His Life and Legacy</a:t>
             </a:r>
             <a:endParaRPr lang="en-US" sz="1500" dirty="0"/>
           </a:p>
@@ -1662,6 +3737,1503 @@
                 <a:cs typeface="Aptos" pitchFamily="34" charset="-120"/>
               </a:rPr>
               <a:t>Generated by SolvixAI</a:t>
+            </a:r>
+            <a:endParaRPr lang="en-US" sz="1000" dirty="0"/>
+          </a:p>
+        </p:txBody>
+      </p:sp>
+    </p:spTree>
+  </p:cSld>
+  <p:clrMapOvr>
+    <a:masterClrMapping/>
+  </p:clrMapOvr>
+</p:sld>
+</file>
+
+<file path=ppt/slides/slide10.xml><?xml version="1.0" encoding="utf-8"?>
+<p:sld xmlns:a="http://schemas.openxmlformats.org/drawingml/2006/main" xmlns:r="http://schemas.openxmlformats.org/officeDocument/2006/relationships" xmlns:p="http://schemas.openxmlformats.org/presentationml/2006/main">
+  <p:cSld name="Slide 10">
+    <p:bg>
+      <p:bgPr>
+        <a:solidFill>
+          <a:srgbClr val="FFFFFF"/>
+        </a:solidFill>
+      </p:bgPr>
+    </p:bg>
+    <p:spTree>
+      <p:nvGrpSpPr>
+        <p:cNvPr id="1" name=""/>
+        <p:cNvGrpSpPr/>
+        <p:nvPr/>
+      </p:nvGrpSpPr>
+      <p:grpSpPr>
+        <a:xfrm>
+          <a:off x="0" y="0"/>
+          <a:ext cx="0" cy="0"/>
+          <a:chOff x="0" y="0"/>
+          <a:chExt cx="0" cy="0"/>
+        </a:xfrm>
+      </p:grpSpPr>
+      <p:sp>
+        <p:nvSpPr>
+          <p:cNvPr id="2" name="Text 0"/>
+          <p:cNvSpPr/>
+          <p:nvPr/>
+        </p:nvSpPr>
+        <p:spPr>
+          <a:xfrm>
+            <a:off x="457200" y="228600"/>
+            <a:ext cx="9144000" cy="411480"/>
+          </a:xfrm>
+          <a:prstGeom prst="rect">
+            <a:avLst/>
+          </a:prstGeom>
+          <a:noFill/>
+          <a:ln/>
+        </p:spPr>
+        <p:txBody>
+          <a:bodyPr wrap="square" lIns="0" tIns="0" rIns="0" bIns="0" rtlCol="0" anchor="ctr"/>
+          <a:lstStyle/>
+          <a:p>
+            <a:pPr algn="l" indent="0" marL="0">
+              <a:buNone/>
+            </a:pPr>
+            <a:r>
+              <a:rPr lang="en-US" sz="2000" b="1" dirty="0">
+                <a:solidFill>
+                  <a:srgbClr val="2563EB"/>
+                </a:solidFill>
+                <a:latin typeface="Aptos Display" pitchFamily="34" charset="0"/>
+                <a:ea typeface="Aptos Display" pitchFamily="34" charset="-122"/>
+                <a:cs typeface="Aptos Display" pitchFamily="34" charset="-120"/>
+              </a:rPr>
+              <a:t>Detailed Summary — Part 3</a:t>
+            </a:r>
+            <a:endParaRPr lang="en-US" sz="2000" dirty="0"/>
+          </a:p>
+        </p:txBody>
+      </p:sp>
+      <p:sp>
+        <p:nvSpPr>
+          <p:cNvPr id="3" name="Shape 1"/>
+          <p:cNvSpPr/>
+          <p:nvPr/>
+        </p:nvSpPr>
+        <p:spPr>
+          <a:xfrm>
+            <a:off x="457200" y="713232"/>
+            <a:ext cx="11247120" cy="0"/>
+          </a:xfrm>
+          <a:prstGeom prst="line">
+            <a:avLst/>
+          </a:prstGeom>
+          <a:noFill/>
+          <a:ln w="12700">
+            <a:solidFill>
+              <a:srgbClr val="E2E8F0"/>
+            </a:solidFill>
+            <a:prstDash val="solid"/>
+          </a:ln>
+        </p:spPr>
+      </p:sp>
+      <p:sp>
+        <p:nvSpPr>
+          <p:cNvPr id="4" name="Shape 2"/>
+          <p:cNvSpPr/>
+          <p:nvPr/>
+        </p:nvSpPr>
+        <p:spPr>
+          <a:xfrm>
+            <a:off x="457200" y="1005840"/>
+            <a:ext cx="6675120" cy="4846320"/>
+          </a:xfrm>
+          <a:prstGeom prst="roundRect">
+            <a:avLst>
+              <a:gd name="adj" fmla="val 1509"/>
+            </a:avLst>
+          </a:prstGeom>
+          <a:solidFill>
+            <a:srgbClr val="EFF6FF"/>
+          </a:solidFill>
+          <a:ln w="6350">
+            <a:solidFill>
+              <a:srgbClr val="E2E8F0"/>
+            </a:solidFill>
+            <a:prstDash val="solid"/>
+          </a:ln>
+        </p:spPr>
+      </p:sp>
+      <p:sp>
+        <p:nvSpPr>
+          <p:cNvPr id="5" name="Text 3"/>
+          <p:cNvSpPr/>
+          <p:nvPr/>
+        </p:nvSpPr>
+        <p:spPr>
+          <a:xfrm>
+            <a:off x="685800" y="1188720"/>
+            <a:ext cx="6263640" cy="4526280"/>
+          </a:xfrm>
+          <a:prstGeom prst="rect">
+            <a:avLst/>
+          </a:prstGeom>
+          <a:noFill/>
+          <a:ln/>
+        </p:spPr>
+        <p:txBody>
+          <a:bodyPr wrap="square" lIns="0" tIns="0" rIns="0" bIns="0" rtlCol="0" anchor="t">
+            <a:normAutofit/>
+          </a:bodyPr>
+          <a:lstStyle/>
+          <a:p>
+            <a:pPr algn="l" indent="0" marL="0">
+              <a:lnSpc>
+                <a:spcPct val="140000"/>
+              </a:lnSpc>
+              <a:buNone/>
+            </a:pPr>
+            <a:r>
+              <a:rPr lang="en-US" sz="1400" dirty="0">
+                <a:solidFill>
+                  <a:srgbClr val="334155"/>
+                </a:solidFill>
+                <a:latin typeface="Aptos" pitchFamily="34" charset="0"/>
+                <a:ea typeface="Aptos" pitchFamily="34" charset="-122"/>
+                <a:cs typeface="Aptos" pitchFamily="34" charset="-120"/>
+              </a:rPr>
+              <a:t>Understanding these interactions is essential for making informed decisions and for anticipating future trends with confidence.</a:t>
+            </a:r>
+            <a:endParaRPr lang="en-US" sz="1400" dirty="0"/>
+          </a:p>
+          <a:p>
+            <a:pPr algn="l" indent="0" marL="0">
+              <a:lnSpc>
+                <a:spcPct val="140000"/>
+              </a:lnSpc>
+              <a:buNone/>
+            </a:pPr>
+            <a:endParaRPr lang="en-US" sz="1400" dirty="0"/>
+          </a:p>
+          <a:p>
+            <a:pPr algn="l" indent="0" marL="0">
+              <a:lnSpc>
+                <a:spcPct val="140000"/>
+              </a:lnSpc>
+              <a:buNone/>
+            </a:pPr>
+            <a:r>
+              <a:rPr lang="en-US" sz="1400" dirty="0">
+                <a:solidFill>
+                  <a:srgbClr val="334155"/>
+                </a:solidFill>
+                <a:latin typeface="Aptos" pitchFamily="34" charset="0"/>
+                <a:ea typeface="Aptos" pitchFamily="34" charset="-122"/>
+                <a:cs typeface="Aptos" pitchFamily="34" charset="-120"/>
+              </a:rPr>
+              <a:t>The presentation also highlights several emerging developments and opportunities that are likely to shape the future of Quaid-e-Azam: The Architect of Pakistan.</a:t>
+            </a:r>
+            <a:endParaRPr lang="en-US" sz="1400" dirty="0"/>
+          </a:p>
+          <a:p>
+            <a:pPr algn="l" indent="0" marL="0">
+              <a:lnSpc>
+                <a:spcPct val="140000"/>
+              </a:lnSpc>
+              <a:buNone/>
+            </a:pPr>
+            <a:endParaRPr lang="en-US" sz="1400" dirty="0"/>
+          </a:p>
+          <a:p>
+            <a:pPr algn="l" indent="0" marL="0">
+              <a:lnSpc>
+                <a:spcPct val="140000"/>
+              </a:lnSpc>
+              <a:buNone/>
+            </a:pPr>
+            <a:r>
+              <a:rPr lang="en-US" sz="1400" dirty="0">
+                <a:solidFill>
+                  <a:srgbClr val="334155"/>
+                </a:solidFill>
+                <a:latin typeface="Aptos" pitchFamily="34" charset="0"/>
+                <a:ea typeface="Aptos" pitchFamily="34" charset="-122"/>
+                <a:cs typeface="Aptos" pitchFamily="34" charset="-120"/>
+              </a:rPr>
+              <a:t>These developments suggest that continuous learning, adaptability, and innovation will remain critical success factors in the coming years.</a:t>
+            </a:r>
+            <a:endParaRPr lang="en-US" sz="1400" dirty="0"/>
+          </a:p>
+          <a:p>
+            <a:pPr algn="l" indent="0" marL="0">
+              <a:lnSpc>
+                <a:spcPct val="140000"/>
+              </a:lnSpc>
+              <a:buNone/>
+            </a:pPr>
+            <a:endParaRPr lang="en-US" sz="1400" dirty="0"/>
+          </a:p>
+          <a:p>
+            <a:pPr algn="l" indent="0" marL="0">
+              <a:lnSpc>
+                <a:spcPct val="140000"/>
+              </a:lnSpc>
+              <a:buNone/>
+            </a:pPr>
+            <a:r>
+              <a:rPr lang="en-US" sz="1400" dirty="0">
+                <a:solidFill>
+                  <a:srgbClr val="334155"/>
+                </a:solidFill>
+                <a:latin typeface="Aptos" pitchFamily="34" charset="0"/>
+                <a:ea typeface="Aptos" pitchFamily="34" charset="-122"/>
+                <a:cs typeface="Aptos" pitchFamily="34" charset="-120"/>
+              </a:rPr>
+              <a:t>In terms of benefits, Quaid-e-Azam: The Architect of Pakistan offers improved efficiency, better decision-making, enhanced clarity, and stronger strategic alignment.</a:t>
+            </a:r>
+            <a:endParaRPr lang="en-US" sz="1400" dirty="0"/>
+          </a:p>
+          <a:p>
+            <a:pPr algn="l" indent="0" marL="0">
+              <a:lnSpc>
+                <a:spcPct val="140000"/>
+              </a:lnSpc>
+              <a:buNone/>
+            </a:pPr>
+            <a:endParaRPr lang="en-US" sz="1400" dirty="0"/>
+          </a:p>
+          <a:p>
+            <a:pPr algn="l" indent="0" marL="0">
+              <a:lnSpc>
+                <a:spcPct val="140000"/>
+              </a:lnSpc>
+              <a:buNone/>
+            </a:pPr>
+            <a:r>
+              <a:rPr lang="en-US" sz="1400" dirty="0">
+                <a:solidFill>
+                  <a:srgbClr val="334155"/>
+                </a:solidFill>
+                <a:latin typeface="Aptos" pitchFamily="34" charset="0"/>
+                <a:ea typeface="Aptos" pitchFamily="34" charset="-122"/>
+                <a:cs typeface="Aptos" pitchFamily="34" charset="-120"/>
+              </a:rPr>
+              <a:t>At the same time, it introduces certain challenges — such as complexity, resource requirements, and the need for skilled implementation.</a:t>
+            </a:r>
+            <a:endParaRPr lang="en-US" sz="1400" dirty="0"/>
+          </a:p>
+        </p:txBody>
+      </p:sp>
+      <p:sp>
+        <p:nvSpPr>
+          <p:cNvPr id="6" name="Shape 4"/>
+          <p:cNvSpPr/>
+          <p:nvPr/>
+        </p:nvSpPr>
+        <p:spPr>
+          <a:xfrm>
+            <a:off x="7315200" y="1005840"/>
+            <a:ext cx="4389120" cy="4846320"/>
+          </a:xfrm>
+          <a:prstGeom prst="roundRect">
+            <a:avLst>
+              <a:gd name="adj" fmla="val 1667"/>
+            </a:avLst>
+          </a:prstGeom>
+          <a:solidFill>
+            <a:srgbClr val="FFFFFF"/>
+          </a:solidFill>
+          <a:ln w="6350">
+            <a:solidFill>
+              <a:srgbClr val="E2E8F0"/>
+            </a:solidFill>
+            <a:prstDash val="solid"/>
+          </a:ln>
+        </p:spPr>
+      </p:sp>
+      <p:sp>
+        <p:nvSpPr>
+          <p:cNvPr id="7" name="Text 5"/>
+          <p:cNvSpPr/>
+          <p:nvPr/>
+        </p:nvSpPr>
+        <p:spPr>
+          <a:xfrm>
+            <a:off x="7498080" y="1143000"/>
+            <a:ext cx="4023360" cy="365760"/>
+          </a:xfrm>
+          <a:prstGeom prst="rect">
+            <a:avLst/>
+          </a:prstGeom>
+          <a:noFill/>
+          <a:ln/>
+        </p:spPr>
+        <p:txBody>
+          <a:bodyPr wrap="square" lIns="0" tIns="0" rIns="0" bIns="0" rtlCol="0" anchor="ctr"/>
+          <a:lstStyle/>
+          <a:p>
+            <a:pPr algn="l" indent="0" marL="0">
+              <a:buNone/>
+            </a:pPr>
+            <a:r>
+              <a:rPr lang="en-US" sz="1400" b="1" dirty="0">
+                <a:solidFill>
+                  <a:srgbClr val="2563EB"/>
+                </a:solidFill>
+                <a:latin typeface="Aptos" pitchFamily="34" charset="0"/>
+                <a:ea typeface="Aptos" pitchFamily="34" charset="-122"/>
+                <a:cs typeface="Aptos" pitchFamily="34" charset="-120"/>
+              </a:rPr>
+              <a:t>Strategic Focus</a:t>
+            </a:r>
+            <a:endParaRPr lang="en-US" sz="1400" dirty="0"/>
+          </a:p>
+        </p:txBody>
+      </p:sp>
+      <p:graphicFrame>
+        <p:nvGraphicFramePr>
+          <p:cNvPr id="8" name="Chart 0" descr=""/>
+          <p:cNvGraphicFramePr/>
+          <p:nvPr/>
+        </p:nvGraphicFramePr>
+        <p:xfrm>
+          <a:off x="7498080" y="1600200"/>
+          <a:ext cx="4023360" cy="4114800"/>
+        </p:xfrm>
+        <a:graphic xmlns:a="http://schemas.openxmlformats.org/drawingml/2006/main">
+          <a:graphicData uri="http://schemas.openxmlformats.org/drawingml/2006/chart">
+            <c:chart xmlns:c="http://schemas.openxmlformats.org/drawingml/2006/chart" r:id="rId1"/>
+          </a:graphicData>
+        </a:graphic>
+      </p:graphicFrame>
+      <p:sp>
+        <p:nvSpPr>
+          <p:cNvPr id="9" name="Text 6"/>
+          <p:cNvSpPr/>
+          <p:nvPr/>
+        </p:nvSpPr>
+        <p:spPr>
+          <a:xfrm>
+            <a:off x="457200" y="6309360"/>
+            <a:ext cx="1828800" cy="182880"/>
+          </a:xfrm>
+          <a:prstGeom prst="rect">
+            <a:avLst/>
+          </a:prstGeom>
+          <a:noFill/>
+          <a:ln/>
+        </p:spPr>
+        <p:txBody>
+          <a:bodyPr wrap="square" lIns="0" tIns="0" rIns="0" bIns="0" rtlCol="0" anchor="ctr"/>
+          <a:lstStyle/>
+          <a:p>
+            <a:pPr algn="l" indent="0" marL="0">
+              <a:buNone/>
+            </a:pPr>
+            <a:r>
+              <a:rPr lang="en-US" sz="1000" b="1" dirty="0">
+                <a:solidFill>
+                  <a:srgbClr val="64748B"/>
+                </a:solidFill>
+                <a:latin typeface="Aptos" pitchFamily="34" charset="0"/>
+                <a:ea typeface="Aptos" pitchFamily="34" charset="-122"/>
+                <a:cs typeface="Aptos" pitchFamily="34" charset="-120"/>
+              </a:rPr>
+              <a:t>Solvix</a:t>
+            </a:r>
+            <a:endParaRPr lang="en-US" sz="1000" dirty="0"/>
+          </a:p>
+        </p:txBody>
+      </p:sp>
+      <p:sp>
+        <p:nvSpPr>
+          <p:cNvPr id="10" name="Text 7"/>
+          <p:cNvSpPr/>
+          <p:nvPr/>
+        </p:nvSpPr>
+        <p:spPr>
+          <a:xfrm>
+            <a:off x="10058400" y="6309360"/>
+            <a:ext cx="1645920" cy="182880"/>
+          </a:xfrm>
+          <a:prstGeom prst="rect">
+            <a:avLst/>
+          </a:prstGeom>
+          <a:noFill/>
+          <a:ln/>
+        </p:spPr>
+        <p:txBody>
+          <a:bodyPr wrap="square" lIns="0" tIns="0" rIns="0" bIns="0" rtlCol="0" anchor="ctr"/>
+          <a:lstStyle/>
+          <a:p>
+            <a:pPr algn="r" indent="0" marL="0">
+              <a:buNone/>
+            </a:pPr>
+            <a:r>
+              <a:rPr lang="en-US" sz="1000" b="1" dirty="0">
+                <a:solidFill>
+                  <a:srgbClr val="64748B"/>
+                </a:solidFill>
+                <a:latin typeface="Aptos" pitchFamily="34" charset="0"/>
+                <a:ea typeface="Aptos" pitchFamily="34" charset="-122"/>
+                <a:cs typeface="Aptos" pitchFamily="34" charset="-120"/>
+              </a:rPr>
+              <a:t>Summary 3/5</a:t>
+            </a:r>
+            <a:endParaRPr lang="en-US" sz="1000" dirty="0"/>
+          </a:p>
+        </p:txBody>
+      </p:sp>
+    </p:spTree>
+  </p:cSld>
+  <p:clrMapOvr>
+    <a:masterClrMapping/>
+  </p:clrMapOvr>
+</p:sld>
+</file>
+
+<file path=ppt/slides/slide11.xml><?xml version="1.0" encoding="utf-8"?>
+<p:sld xmlns:a="http://schemas.openxmlformats.org/drawingml/2006/main" xmlns:r="http://schemas.openxmlformats.org/officeDocument/2006/relationships" xmlns:p="http://schemas.openxmlformats.org/presentationml/2006/main">
+  <p:cSld name="Slide 11">
+    <p:bg>
+      <p:bgPr>
+        <a:solidFill>
+          <a:srgbClr val="FFFFFF"/>
+        </a:solidFill>
+      </p:bgPr>
+    </p:bg>
+    <p:spTree>
+      <p:nvGrpSpPr>
+        <p:cNvPr id="1" name=""/>
+        <p:cNvGrpSpPr/>
+        <p:nvPr/>
+      </p:nvGrpSpPr>
+      <p:grpSpPr>
+        <a:xfrm>
+          <a:off x="0" y="0"/>
+          <a:ext cx="0" cy="0"/>
+          <a:chOff x="0" y="0"/>
+          <a:chExt cx="0" cy="0"/>
+        </a:xfrm>
+      </p:grpSpPr>
+      <p:sp>
+        <p:nvSpPr>
+          <p:cNvPr id="2" name="Text 0"/>
+          <p:cNvSpPr/>
+          <p:nvPr/>
+        </p:nvSpPr>
+        <p:spPr>
+          <a:xfrm>
+            <a:off x="457200" y="228600"/>
+            <a:ext cx="9144000" cy="411480"/>
+          </a:xfrm>
+          <a:prstGeom prst="rect">
+            <a:avLst/>
+          </a:prstGeom>
+          <a:noFill/>
+          <a:ln/>
+        </p:spPr>
+        <p:txBody>
+          <a:bodyPr wrap="square" lIns="0" tIns="0" rIns="0" bIns="0" rtlCol="0" anchor="ctr"/>
+          <a:lstStyle/>
+          <a:p>
+            <a:pPr algn="l" indent="0" marL="0">
+              <a:buNone/>
+            </a:pPr>
+            <a:r>
+              <a:rPr lang="en-US" sz="2000" b="1" dirty="0">
+                <a:solidFill>
+                  <a:srgbClr val="2563EB"/>
+                </a:solidFill>
+                <a:latin typeface="Aptos Display" pitchFamily="34" charset="0"/>
+                <a:ea typeface="Aptos Display" pitchFamily="34" charset="-122"/>
+                <a:cs typeface="Aptos Display" pitchFamily="34" charset="-120"/>
+              </a:rPr>
+              <a:t>Detailed Summary — Part 4</a:t>
+            </a:r>
+            <a:endParaRPr lang="en-US" sz="2000" dirty="0"/>
+          </a:p>
+        </p:txBody>
+      </p:sp>
+      <p:sp>
+        <p:nvSpPr>
+          <p:cNvPr id="3" name="Shape 1"/>
+          <p:cNvSpPr/>
+          <p:nvPr/>
+        </p:nvSpPr>
+        <p:spPr>
+          <a:xfrm>
+            <a:off x="457200" y="713232"/>
+            <a:ext cx="11247120" cy="0"/>
+          </a:xfrm>
+          <a:prstGeom prst="line">
+            <a:avLst/>
+          </a:prstGeom>
+          <a:noFill/>
+          <a:ln w="12700">
+            <a:solidFill>
+              <a:srgbClr val="E2E8F0"/>
+            </a:solidFill>
+            <a:prstDash val="solid"/>
+          </a:ln>
+        </p:spPr>
+      </p:sp>
+      <p:sp>
+        <p:nvSpPr>
+          <p:cNvPr id="4" name="Shape 2"/>
+          <p:cNvSpPr/>
+          <p:nvPr/>
+        </p:nvSpPr>
+        <p:spPr>
+          <a:xfrm>
+            <a:off x="457200" y="1005840"/>
+            <a:ext cx="6675120" cy="4846320"/>
+          </a:xfrm>
+          <a:prstGeom prst="roundRect">
+            <a:avLst>
+              <a:gd name="adj" fmla="val 1509"/>
+            </a:avLst>
+          </a:prstGeom>
+          <a:solidFill>
+            <a:srgbClr val="EFF6FF"/>
+          </a:solidFill>
+          <a:ln w="6350">
+            <a:solidFill>
+              <a:srgbClr val="E2E8F0"/>
+            </a:solidFill>
+            <a:prstDash val="solid"/>
+          </a:ln>
+        </p:spPr>
+      </p:sp>
+      <p:sp>
+        <p:nvSpPr>
+          <p:cNvPr id="5" name="Text 3"/>
+          <p:cNvSpPr/>
+          <p:nvPr/>
+        </p:nvSpPr>
+        <p:spPr>
+          <a:xfrm>
+            <a:off x="685800" y="1188720"/>
+            <a:ext cx="6263640" cy="4526280"/>
+          </a:xfrm>
+          <a:prstGeom prst="rect">
+            <a:avLst/>
+          </a:prstGeom>
+          <a:noFill/>
+          <a:ln/>
+        </p:spPr>
+        <p:txBody>
+          <a:bodyPr wrap="square" lIns="0" tIns="0" rIns="0" bIns="0" rtlCol="0" anchor="t">
+            <a:normAutofit/>
+          </a:bodyPr>
+          <a:lstStyle/>
+          <a:p>
+            <a:pPr algn="l" indent="0" marL="0">
+              <a:lnSpc>
+                <a:spcPct val="140000"/>
+              </a:lnSpc>
+              <a:buNone/>
+            </a:pPr>
+            <a:r>
+              <a:rPr lang="en-US" sz="1400" dirty="0">
+                <a:solidFill>
+                  <a:srgbClr val="334155"/>
+                </a:solidFill>
+                <a:latin typeface="Aptos" pitchFamily="34" charset="0"/>
+                <a:ea typeface="Aptos" pitchFamily="34" charset="-122"/>
+                <a:cs typeface="Aptos" pitchFamily="34" charset="-120"/>
+              </a:rPr>
+              <a:t>Addressing these challenges proactively can unlock substantial long-term value and create a sustainable competitive advantage.</a:t>
+            </a:r>
+            <a:endParaRPr lang="en-US" sz="1400" dirty="0"/>
+          </a:p>
+          <a:p>
+            <a:pPr algn="l" indent="0" marL="0">
+              <a:lnSpc>
+                <a:spcPct val="140000"/>
+              </a:lnSpc>
+              <a:buNone/>
+            </a:pPr>
+            <a:endParaRPr lang="en-US" sz="1400" dirty="0"/>
+          </a:p>
+          <a:p>
+            <a:pPr algn="l" indent="0" marL="0">
+              <a:lnSpc>
+                <a:spcPct val="140000"/>
+              </a:lnSpc>
+              <a:buNone/>
+            </a:pPr>
+            <a:r>
+              <a:rPr lang="en-US" sz="1400" dirty="0">
+                <a:solidFill>
+                  <a:srgbClr val="334155"/>
+                </a:solidFill>
+                <a:latin typeface="Aptos" pitchFamily="34" charset="0"/>
+                <a:ea typeface="Aptos" pitchFamily="34" charset="-122"/>
+                <a:cs typeface="Aptos" pitchFamily="34" charset="-120"/>
+              </a:rPr>
+              <a:t>The visual chart included in these summary slides summarizes the relative emphasis placed on each major section of the presentation.</a:t>
+            </a:r>
+            <a:endParaRPr lang="en-US" sz="1400" dirty="0"/>
+          </a:p>
+          <a:p>
+            <a:pPr algn="l" indent="0" marL="0">
+              <a:lnSpc>
+                <a:spcPct val="140000"/>
+              </a:lnSpc>
+              <a:buNone/>
+            </a:pPr>
+            <a:endParaRPr lang="en-US" sz="1400" dirty="0"/>
+          </a:p>
+          <a:p>
+            <a:pPr algn="l" indent="0" marL="0">
+              <a:lnSpc>
+                <a:spcPct val="140000"/>
+              </a:lnSpc>
+              <a:buNone/>
+            </a:pPr>
+            <a:r>
+              <a:rPr lang="en-US" sz="1400" dirty="0">
+                <a:solidFill>
+                  <a:srgbClr val="334155"/>
+                </a:solidFill>
+                <a:latin typeface="Aptos" pitchFamily="34" charset="0"/>
+                <a:ea typeface="Aptos" pitchFamily="34" charset="-122"/>
+                <a:cs typeface="Aptos" pitchFamily="34" charset="-120"/>
+              </a:rPr>
+              <a:t>It provides a quick, at-a-glance understanding of how the content is distributed and where the strongest focus lies.</a:t>
+            </a:r>
+            <a:endParaRPr lang="en-US" sz="1400" dirty="0"/>
+          </a:p>
+          <a:p>
+            <a:pPr algn="l" indent="0" marL="0">
+              <a:lnSpc>
+                <a:spcPct val="140000"/>
+              </a:lnSpc>
+              <a:buNone/>
+            </a:pPr>
+            <a:endParaRPr lang="en-US" sz="1400" dirty="0"/>
+          </a:p>
+          <a:p>
+            <a:pPr algn="l" indent="0" marL="0">
+              <a:lnSpc>
+                <a:spcPct val="140000"/>
+              </a:lnSpc>
+              <a:buNone/>
+            </a:pPr>
+            <a:r>
+              <a:rPr lang="en-US" sz="1400" dirty="0">
+                <a:solidFill>
+                  <a:srgbClr val="334155"/>
+                </a:solidFill>
+                <a:latin typeface="Aptos" pitchFamily="34" charset="0"/>
+                <a:ea typeface="Aptos" pitchFamily="34" charset="-122"/>
+                <a:cs typeface="Aptos" pitchFamily="34" charset="-120"/>
+              </a:rPr>
+              <a:t>Overall, Quaid-e-Azam: The Architect of Pakistan is a topic of lasting importance, and the insights presented here serve as a practical reference for further exploration.</a:t>
+            </a:r>
+            <a:endParaRPr lang="en-US" sz="1400" dirty="0"/>
+          </a:p>
+          <a:p>
+            <a:pPr algn="l" indent="0" marL="0">
+              <a:lnSpc>
+                <a:spcPct val="140000"/>
+              </a:lnSpc>
+              <a:buNone/>
+            </a:pPr>
+            <a:endParaRPr lang="en-US" sz="1400" dirty="0"/>
+          </a:p>
+          <a:p>
+            <a:pPr algn="l" indent="0" marL="0">
+              <a:lnSpc>
+                <a:spcPct val="140000"/>
+              </a:lnSpc>
+              <a:buNone/>
+            </a:pPr>
+            <a:r>
+              <a:rPr lang="en-US" sz="1400" dirty="0">
+                <a:solidFill>
+                  <a:srgbClr val="334155"/>
+                </a:solidFill>
+                <a:latin typeface="Aptos" pitchFamily="34" charset="0"/>
+                <a:ea typeface="Aptos" pitchFamily="34" charset="-122"/>
+                <a:cs typeface="Aptos" pitchFamily="34" charset="-120"/>
+              </a:rPr>
+              <a:t>The presentation concludes with a clear set of takeaways that can be directly applied, adapted, and expanded upon in future work.</a:t>
+            </a:r>
+            <a:endParaRPr lang="en-US" sz="1400" dirty="0"/>
+          </a:p>
+        </p:txBody>
+      </p:sp>
+      <p:sp>
+        <p:nvSpPr>
+          <p:cNvPr id="6" name="Shape 4"/>
+          <p:cNvSpPr/>
+          <p:nvPr/>
+        </p:nvSpPr>
+        <p:spPr>
+          <a:xfrm>
+            <a:off x="7315200" y="1005840"/>
+            <a:ext cx="4389120" cy="4846320"/>
+          </a:xfrm>
+          <a:prstGeom prst="roundRect">
+            <a:avLst>
+              <a:gd name="adj" fmla="val 1667"/>
+            </a:avLst>
+          </a:prstGeom>
+          <a:solidFill>
+            <a:srgbClr val="FFFFFF"/>
+          </a:solidFill>
+          <a:ln w="6350">
+            <a:solidFill>
+              <a:srgbClr val="E2E8F0"/>
+            </a:solidFill>
+            <a:prstDash val="solid"/>
+          </a:ln>
+        </p:spPr>
+      </p:sp>
+      <p:sp>
+        <p:nvSpPr>
+          <p:cNvPr id="7" name="Text 5"/>
+          <p:cNvSpPr/>
+          <p:nvPr/>
+        </p:nvSpPr>
+        <p:spPr>
+          <a:xfrm>
+            <a:off x="7498080" y="1143000"/>
+            <a:ext cx="4023360" cy="365760"/>
+          </a:xfrm>
+          <a:prstGeom prst="rect">
+            <a:avLst/>
+          </a:prstGeom>
+          <a:noFill/>
+          <a:ln/>
+        </p:spPr>
+        <p:txBody>
+          <a:bodyPr wrap="square" lIns="0" tIns="0" rIns="0" bIns="0" rtlCol="0" anchor="ctr"/>
+          <a:lstStyle/>
+          <a:p>
+            <a:pPr algn="l" indent="0" marL="0">
+              <a:buNone/>
+            </a:pPr>
+            <a:r>
+              <a:rPr lang="en-US" sz="1400" b="1" dirty="0">
+                <a:solidFill>
+                  <a:srgbClr val="2563EB"/>
+                </a:solidFill>
+                <a:latin typeface="Aptos" pitchFamily="34" charset="0"/>
+                <a:ea typeface="Aptos" pitchFamily="34" charset="-122"/>
+                <a:cs typeface="Aptos" pitchFamily="34" charset="-120"/>
+              </a:rPr>
+              <a:t>Impact Areas</a:t>
+            </a:r>
+            <a:endParaRPr lang="en-US" sz="1400" dirty="0"/>
+          </a:p>
+        </p:txBody>
+      </p:sp>
+      <p:graphicFrame>
+        <p:nvGraphicFramePr>
+          <p:cNvPr id="8" name="Chart 0" descr=""/>
+          <p:cNvGraphicFramePr/>
+          <p:nvPr/>
+        </p:nvGraphicFramePr>
+        <p:xfrm>
+          <a:off x="7498080" y="1600200"/>
+          <a:ext cx="4023360" cy="4114800"/>
+        </p:xfrm>
+        <a:graphic xmlns:a="http://schemas.openxmlformats.org/drawingml/2006/main">
+          <a:graphicData uri="http://schemas.openxmlformats.org/drawingml/2006/chart">
+            <c:chart xmlns:c="http://schemas.openxmlformats.org/drawingml/2006/chart" r:id="rId1"/>
+          </a:graphicData>
+        </a:graphic>
+      </p:graphicFrame>
+      <p:sp>
+        <p:nvSpPr>
+          <p:cNvPr id="9" name="Text 6"/>
+          <p:cNvSpPr/>
+          <p:nvPr/>
+        </p:nvSpPr>
+        <p:spPr>
+          <a:xfrm>
+            <a:off x="457200" y="6309360"/>
+            <a:ext cx="1828800" cy="182880"/>
+          </a:xfrm>
+          <a:prstGeom prst="rect">
+            <a:avLst/>
+          </a:prstGeom>
+          <a:noFill/>
+          <a:ln/>
+        </p:spPr>
+        <p:txBody>
+          <a:bodyPr wrap="square" lIns="0" tIns="0" rIns="0" bIns="0" rtlCol="0" anchor="ctr"/>
+          <a:lstStyle/>
+          <a:p>
+            <a:pPr algn="l" indent="0" marL="0">
+              <a:buNone/>
+            </a:pPr>
+            <a:r>
+              <a:rPr lang="en-US" sz="1000" b="1" dirty="0">
+                <a:solidFill>
+                  <a:srgbClr val="64748B"/>
+                </a:solidFill>
+                <a:latin typeface="Aptos" pitchFamily="34" charset="0"/>
+                <a:ea typeface="Aptos" pitchFamily="34" charset="-122"/>
+                <a:cs typeface="Aptos" pitchFamily="34" charset="-120"/>
+              </a:rPr>
+              <a:t>Solvix</a:t>
+            </a:r>
+            <a:endParaRPr lang="en-US" sz="1000" dirty="0"/>
+          </a:p>
+        </p:txBody>
+      </p:sp>
+      <p:sp>
+        <p:nvSpPr>
+          <p:cNvPr id="10" name="Text 7"/>
+          <p:cNvSpPr/>
+          <p:nvPr/>
+        </p:nvSpPr>
+        <p:spPr>
+          <a:xfrm>
+            <a:off x="10058400" y="6309360"/>
+            <a:ext cx="1645920" cy="182880"/>
+          </a:xfrm>
+          <a:prstGeom prst="rect">
+            <a:avLst/>
+          </a:prstGeom>
+          <a:noFill/>
+          <a:ln/>
+        </p:spPr>
+        <p:txBody>
+          <a:bodyPr wrap="square" lIns="0" tIns="0" rIns="0" bIns="0" rtlCol="0" anchor="ctr"/>
+          <a:lstStyle/>
+          <a:p>
+            <a:pPr algn="r" indent="0" marL="0">
+              <a:buNone/>
+            </a:pPr>
+            <a:r>
+              <a:rPr lang="en-US" sz="1000" b="1" dirty="0">
+                <a:solidFill>
+                  <a:srgbClr val="64748B"/>
+                </a:solidFill>
+                <a:latin typeface="Aptos" pitchFamily="34" charset="0"/>
+                <a:ea typeface="Aptos" pitchFamily="34" charset="-122"/>
+                <a:cs typeface="Aptos" pitchFamily="34" charset="-120"/>
+              </a:rPr>
+              <a:t>Summary 4/5</a:t>
+            </a:r>
+            <a:endParaRPr lang="en-US" sz="1000" dirty="0"/>
+          </a:p>
+        </p:txBody>
+      </p:sp>
+    </p:spTree>
+  </p:cSld>
+  <p:clrMapOvr>
+    <a:masterClrMapping/>
+  </p:clrMapOvr>
+</p:sld>
+</file>
+
+<file path=ppt/slides/slide12.xml><?xml version="1.0" encoding="utf-8"?>
+<p:sld xmlns:a="http://schemas.openxmlformats.org/drawingml/2006/main" xmlns:r="http://schemas.openxmlformats.org/officeDocument/2006/relationships" xmlns:p="http://schemas.openxmlformats.org/presentationml/2006/main">
+  <p:cSld name="Slide 12">
+    <p:bg>
+      <p:bgPr>
+        <a:solidFill>
+          <a:srgbClr val="FFFFFF"/>
+        </a:solidFill>
+      </p:bgPr>
+    </p:bg>
+    <p:spTree>
+      <p:nvGrpSpPr>
+        <p:cNvPr id="1" name=""/>
+        <p:cNvGrpSpPr/>
+        <p:nvPr/>
+      </p:nvGrpSpPr>
+      <p:grpSpPr>
+        <a:xfrm>
+          <a:off x="0" y="0"/>
+          <a:ext cx="0" cy="0"/>
+          <a:chOff x="0" y="0"/>
+          <a:chExt cx="0" cy="0"/>
+        </a:xfrm>
+      </p:grpSpPr>
+      <p:sp>
+        <p:nvSpPr>
+          <p:cNvPr id="2" name="Text 0"/>
+          <p:cNvSpPr/>
+          <p:nvPr/>
+        </p:nvSpPr>
+        <p:spPr>
+          <a:xfrm>
+            <a:off x="457200" y="228600"/>
+            <a:ext cx="9144000" cy="411480"/>
+          </a:xfrm>
+          <a:prstGeom prst="rect">
+            <a:avLst/>
+          </a:prstGeom>
+          <a:noFill/>
+          <a:ln/>
+        </p:spPr>
+        <p:txBody>
+          <a:bodyPr wrap="square" lIns="0" tIns="0" rIns="0" bIns="0" rtlCol="0" anchor="ctr"/>
+          <a:lstStyle/>
+          <a:p>
+            <a:pPr algn="l" indent="0" marL="0">
+              <a:buNone/>
+            </a:pPr>
+            <a:r>
+              <a:rPr lang="en-US" sz="2000" b="1" dirty="0">
+                <a:solidFill>
+                  <a:srgbClr val="2563EB"/>
+                </a:solidFill>
+                <a:latin typeface="Aptos Display" pitchFamily="34" charset="0"/>
+                <a:ea typeface="Aptos Display" pitchFamily="34" charset="-122"/>
+                <a:cs typeface="Aptos Display" pitchFamily="34" charset="-120"/>
+              </a:rPr>
+              <a:t>Detailed Summary — Part 5</a:t>
+            </a:r>
+            <a:endParaRPr lang="en-US" sz="2000" dirty="0"/>
+          </a:p>
+        </p:txBody>
+      </p:sp>
+      <p:sp>
+        <p:nvSpPr>
+          <p:cNvPr id="3" name="Shape 1"/>
+          <p:cNvSpPr/>
+          <p:nvPr/>
+        </p:nvSpPr>
+        <p:spPr>
+          <a:xfrm>
+            <a:off x="457200" y="713232"/>
+            <a:ext cx="11247120" cy="0"/>
+          </a:xfrm>
+          <a:prstGeom prst="line">
+            <a:avLst/>
+          </a:prstGeom>
+          <a:noFill/>
+          <a:ln w="12700">
+            <a:solidFill>
+              <a:srgbClr val="E2E8F0"/>
+            </a:solidFill>
+            <a:prstDash val="solid"/>
+          </a:ln>
+        </p:spPr>
+      </p:sp>
+      <p:sp>
+        <p:nvSpPr>
+          <p:cNvPr id="4" name="Shape 2"/>
+          <p:cNvSpPr/>
+          <p:nvPr/>
+        </p:nvSpPr>
+        <p:spPr>
+          <a:xfrm>
+            <a:off x="457200" y="1005840"/>
+            <a:ext cx="6675120" cy="4846320"/>
+          </a:xfrm>
+          <a:prstGeom prst="roundRect">
+            <a:avLst>
+              <a:gd name="adj" fmla="val 1509"/>
+            </a:avLst>
+          </a:prstGeom>
+          <a:solidFill>
+            <a:srgbClr val="EFF6FF"/>
+          </a:solidFill>
+          <a:ln w="6350">
+            <a:solidFill>
+              <a:srgbClr val="E2E8F0"/>
+            </a:solidFill>
+            <a:prstDash val="solid"/>
+          </a:ln>
+        </p:spPr>
+      </p:sp>
+      <p:sp>
+        <p:nvSpPr>
+          <p:cNvPr id="5" name="Text 3"/>
+          <p:cNvSpPr/>
+          <p:nvPr/>
+        </p:nvSpPr>
+        <p:spPr>
+          <a:xfrm>
+            <a:off x="685800" y="1188720"/>
+            <a:ext cx="6263640" cy="4526280"/>
+          </a:xfrm>
+          <a:prstGeom prst="rect">
+            <a:avLst/>
+          </a:prstGeom>
+          <a:noFill/>
+          <a:ln/>
+        </p:spPr>
+        <p:txBody>
+          <a:bodyPr wrap="square" lIns="0" tIns="0" rIns="0" bIns="0" rtlCol="0" anchor="t">
+            <a:normAutofit/>
+          </a:bodyPr>
+          <a:lstStyle/>
+          <a:p>
+            <a:pPr algn="l" indent="0" marL="0">
+              <a:lnSpc>
+                <a:spcPct val="140000"/>
+              </a:lnSpc>
+              <a:buNone/>
+            </a:pPr>
+            <a:r>
+              <a:rPr lang="en-US" sz="1400" dirty="0">
+                <a:solidFill>
+                  <a:srgbClr val="334155"/>
+                </a:solidFill>
+                <a:latin typeface="Aptos" pitchFamily="34" charset="0"/>
+                <a:ea typeface="Aptos" pitchFamily="34" charset="-122"/>
+                <a:cs typeface="Aptos" pitchFamily="34" charset="-120"/>
+              </a:rPr>
+              <a:t>In summary, this presentation delivers a complete, structured, and insightful overview of Quaid-e-Azam: The Architect of Pakistan with clarity, depth, and relevance.</a:t>
+            </a:r>
+            <a:endParaRPr lang="en-US" sz="1400" dirty="0"/>
+          </a:p>
+          <a:p>
+            <a:pPr algn="l" indent="0" marL="0">
+              <a:lnSpc>
+                <a:spcPct val="140000"/>
+              </a:lnSpc>
+              <a:buNone/>
+            </a:pPr>
+            <a:endParaRPr lang="en-US" sz="1400" dirty="0"/>
+          </a:p>
+          <a:p>
+            <a:pPr algn="l" indent="0" marL="0">
+              <a:lnSpc>
+                <a:spcPct val="140000"/>
+              </a:lnSpc>
+              <a:buNone/>
+            </a:pPr>
+            <a:r>
+              <a:rPr lang="en-US" sz="1400" dirty="0">
+                <a:solidFill>
+                  <a:srgbClr val="334155"/>
+                </a:solidFill>
+                <a:latin typeface="Aptos" pitchFamily="34" charset="0"/>
+                <a:ea typeface="Aptos" pitchFamily="34" charset="-122"/>
+                <a:cs typeface="Aptos" pitchFamily="34" charset="-120"/>
+              </a:rPr>
+              <a:t>It supports both understanding and action, making it a valuable resource for students, professionals, and decision-makers alike.</a:t>
+            </a:r>
+            <a:endParaRPr lang="en-US" sz="1400" dirty="0"/>
+          </a:p>
+          <a:p>
+            <a:pPr algn="l" indent="0" marL="0">
+              <a:lnSpc>
+                <a:spcPct val="140000"/>
+              </a:lnSpc>
+              <a:buNone/>
+            </a:pPr>
+            <a:endParaRPr lang="en-US" sz="1400" dirty="0"/>
+          </a:p>
+          <a:p>
+            <a:pPr algn="l" indent="0" marL="0">
+              <a:lnSpc>
+                <a:spcPct val="140000"/>
+              </a:lnSpc>
+              <a:buNone/>
+            </a:pPr>
+            <a:r>
+              <a:rPr lang="en-US" sz="1400" dirty="0">
+                <a:solidFill>
+                  <a:srgbClr val="334155"/>
+                </a:solidFill>
+                <a:latin typeface="Aptos" pitchFamily="34" charset="0"/>
+                <a:ea typeface="Aptos" pitchFamily="34" charset="-122"/>
+                <a:cs typeface="Aptos" pitchFamily="34" charset="-120"/>
+              </a:rPr>
+              <a:t>The ideas presented can be extended into workshops, strategy sessions, or further research depending on the reader's specific goals.</a:t>
+            </a:r>
+            <a:endParaRPr lang="en-US" sz="1400" dirty="0"/>
+          </a:p>
+          <a:p>
+            <a:pPr algn="l" indent="0" marL="0">
+              <a:lnSpc>
+                <a:spcPct val="140000"/>
+              </a:lnSpc>
+              <a:buNone/>
+            </a:pPr>
+            <a:endParaRPr lang="en-US" sz="1400" dirty="0"/>
+          </a:p>
+          <a:p>
+            <a:pPr algn="l" indent="0" marL="0">
+              <a:lnSpc>
+                <a:spcPct val="140000"/>
+              </a:lnSpc>
+              <a:buNone/>
+            </a:pPr>
+            <a:r>
+              <a:rPr lang="en-US" sz="1400" dirty="0">
+                <a:solidFill>
+                  <a:srgbClr val="334155"/>
+                </a:solidFill>
+                <a:latin typeface="Aptos" pitchFamily="34" charset="0"/>
+                <a:ea typeface="Aptos" pitchFamily="34" charset="-122"/>
+                <a:cs typeface="Aptos" pitchFamily="34" charset="-120"/>
+              </a:rPr>
+              <a:t>Finally, the content has been kept concise, visually consistent, and easy to navigate so that the key message is never lost.</a:t>
+            </a:r>
+            <a:endParaRPr lang="en-US" sz="1400" dirty="0"/>
+          </a:p>
+          <a:p>
+            <a:pPr algn="l" indent="0" marL="0">
+              <a:lnSpc>
+                <a:spcPct val="140000"/>
+              </a:lnSpc>
+              <a:buNone/>
+            </a:pPr>
+            <a:endParaRPr lang="en-US" sz="1400" dirty="0"/>
+          </a:p>
+          <a:p>
+            <a:pPr algn="l" indent="0" marL="0">
+              <a:lnSpc>
+                <a:spcPct val="140000"/>
+              </a:lnSpc>
+              <a:buNone/>
+            </a:pPr>
+            <a:r>
+              <a:rPr lang="en-US" sz="1400" dirty="0">
+                <a:solidFill>
+                  <a:srgbClr val="334155"/>
+                </a:solidFill>
+                <a:latin typeface="Aptos" pitchFamily="34" charset="0"/>
+                <a:ea typeface="Aptos" pitchFamily="34" charset="-122"/>
+                <a:cs typeface="Aptos" pitchFamily="34" charset="-120"/>
+              </a:rPr>
+              <a:t>We hope this presentation provides a strong starting point for deeper discussion and meaningful real-world application.</a:t>
+            </a:r>
+            <a:endParaRPr lang="en-US" sz="1400" dirty="0"/>
+          </a:p>
+        </p:txBody>
+      </p:sp>
+      <p:sp>
+        <p:nvSpPr>
+          <p:cNvPr id="6" name="Shape 4"/>
+          <p:cNvSpPr/>
+          <p:nvPr/>
+        </p:nvSpPr>
+        <p:spPr>
+          <a:xfrm>
+            <a:off x="7315200" y="1005840"/>
+            <a:ext cx="4389120" cy="4846320"/>
+          </a:xfrm>
+          <a:prstGeom prst="roundRect">
+            <a:avLst>
+              <a:gd name="adj" fmla="val 1667"/>
+            </a:avLst>
+          </a:prstGeom>
+          <a:solidFill>
+            <a:srgbClr val="FFFFFF"/>
+          </a:solidFill>
+          <a:ln w="6350">
+            <a:solidFill>
+              <a:srgbClr val="E2E8F0"/>
+            </a:solidFill>
+            <a:prstDash val="solid"/>
+          </a:ln>
+        </p:spPr>
+      </p:sp>
+      <p:sp>
+        <p:nvSpPr>
+          <p:cNvPr id="7" name="Text 5"/>
+          <p:cNvSpPr/>
+          <p:nvPr/>
+        </p:nvSpPr>
+        <p:spPr>
+          <a:xfrm>
+            <a:off x="7498080" y="1143000"/>
+            <a:ext cx="4023360" cy="365760"/>
+          </a:xfrm>
+          <a:prstGeom prst="rect">
+            <a:avLst/>
+          </a:prstGeom>
+          <a:noFill/>
+          <a:ln/>
+        </p:spPr>
+        <p:txBody>
+          <a:bodyPr wrap="square" lIns="0" tIns="0" rIns="0" bIns="0" rtlCol="0" anchor="ctr"/>
+          <a:lstStyle/>
+          <a:p>
+            <a:pPr algn="l" indent="0" marL="0">
+              <a:buNone/>
+            </a:pPr>
+            <a:r>
+              <a:rPr lang="en-US" sz="1400" b="1" dirty="0">
+                <a:solidFill>
+                  <a:srgbClr val="2563EB"/>
+                </a:solidFill>
+                <a:latin typeface="Aptos" pitchFamily="34" charset="0"/>
+                <a:ea typeface="Aptos" pitchFamily="34" charset="-122"/>
+                <a:cs typeface="Aptos" pitchFamily="34" charset="-120"/>
+              </a:rPr>
+              <a:t>Final Takeaways</a:t>
+            </a:r>
+            <a:endParaRPr lang="en-US" sz="1400" dirty="0"/>
+          </a:p>
+        </p:txBody>
+      </p:sp>
+      <p:graphicFrame>
+        <p:nvGraphicFramePr>
+          <p:cNvPr id="8" name="Chart 0" descr=""/>
+          <p:cNvGraphicFramePr/>
+          <p:nvPr/>
+        </p:nvGraphicFramePr>
+        <p:xfrm>
+          <a:off x="7498080" y="1600200"/>
+          <a:ext cx="4023360" cy="4114800"/>
+        </p:xfrm>
+        <a:graphic xmlns:a="http://schemas.openxmlformats.org/drawingml/2006/main">
+          <a:graphicData uri="http://schemas.openxmlformats.org/drawingml/2006/chart">
+            <c:chart xmlns:c="http://schemas.openxmlformats.org/drawingml/2006/chart" r:id="rId1"/>
+          </a:graphicData>
+        </a:graphic>
+      </p:graphicFrame>
+      <p:sp>
+        <p:nvSpPr>
+          <p:cNvPr id="9" name="Text 6"/>
+          <p:cNvSpPr/>
+          <p:nvPr/>
+        </p:nvSpPr>
+        <p:spPr>
+          <a:xfrm>
+            <a:off x="457200" y="6309360"/>
+            <a:ext cx="1828800" cy="182880"/>
+          </a:xfrm>
+          <a:prstGeom prst="rect">
+            <a:avLst/>
+          </a:prstGeom>
+          <a:noFill/>
+          <a:ln/>
+        </p:spPr>
+        <p:txBody>
+          <a:bodyPr wrap="square" lIns="0" tIns="0" rIns="0" bIns="0" rtlCol="0" anchor="ctr"/>
+          <a:lstStyle/>
+          <a:p>
+            <a:pPr algn="l" indent="0" marL="0">
+              <a:buNone/>
+            </a:pPr>
+            <a:r>
+              <a:rPr lang="en-US" sz="1000" b="1" dirty="0">
+                <a:solidFill>
+                  <a:srgbClr val="64748B"/>
+                </a:solidFill>
+                <a:latin typeface="Aptos" pitchFamily="34" charset="0"/>
+                <a:ea typeface="Aptos" pitchFamily="34" charset="-122"/>
+                <a:cs typeface="Aptos" pitchFamily="34" charset="-120"/>
+              </a:rPr>
+              <a:t>Solvix</a:t>
+            </a:r>
+            <a:endParaRPr lang="en-US" sz="1000" dirty="0"/>
+          </a:p>
+        </p:txBody>
+      </p:sp>
+      <p:sp>
+        <p:nvSpPr>
+          <p:cNvPr id="10" name="Text 7"/>
+          <p:cNvSpPr/>
+          <p:nvPr/>
+        </p:nvSpPr>
+        <p:spPr>
+          <a:xfrm>
+            <a:off x="10058400" y="6309360"/>
+            <a:ext cx="1645920" cy="182880"/>
+          </a:xfrm>
+          <a:prstGeom prst="rect">
+            <a:avLst/>
+          </a:prstGeom>
+          <a:noFill/>
+          <a:ln/>
+        </p:spPr>
+        <p:txBody>
+          <a:bodyPr wrap="square" lIns="0" tIns="0" rIns="0" bIns="0" rtlCol="0" anchor="ctr"/>
+          <a:lstStyle/>
+          <a:p>
+            <a:pPr algn="r" indent="0" marL="0">
+              <a:buNone/>
+            </a:pPr>
+            <a:r>
+              <a:rPr lang="en-US" sz="1000" b="1" dirty="0">
+                <a:solidFill>
+                  <a:srgbClr val="64748B"/>
+                </a:solidFill>
+                <a:latin typeface="Aptos" pitchFamily="34" charset="0"/>
+                <a:ea typeface="Aptos" pitchFamily="34" charset="-122"/>
+                <a:cs typeface="Aptos" pitchFamily="34" charset="-120"/>
+              </a:rPr>
+              <a:t>Summary 5/5</a:t>
+            </a:r>
+            <a:endParaRPr lang="en-US" sz="1000" dirty="0"/>
+          </a:p>
+        </p:txBody>
+      </p:sp>
+    </p:spTree>
+  </p:cSld>
+  <p:clrMapOvr>
+    <a:masterClrMapping/>
+  </p:clrMapOvr>
+</p:sld>
+</file>
+
+<file path=ppt/slides/slide13.xml><?xml version="1.0" encoding="utf-8"?>
+<p:sld xmlns:a="http://schemas.openxmlformats.org/drawingml/2006/main" xmlns:r="http://schemas.openxmlformats.org/officeDocument/2006/relationships" xmlns:p="http://schemas.openxmlformats.org/presentationml/2006/main">
+  <p:cSld name="Slide 13">
+    <p:bg>
+      <p:bgPr>
+        <a:solidFill>
+          <a:srgbClr val="0F172A"/>
+        </a:solidFill>
+      </p:bgPr>
+    </p:bg>
+    <p:spTree>
+      <p:nvGrpSpPr>
+        <p:cNvPr id="1" name=""/>
+        <p:cNvGrpSpPr/>
+        <p:nvPr/>
+      </p:nvGrpSpPr>
+      <p:grpSpPr>
+        <a:xfrm>
+          <a:off x="0" y="0"/>
+          <a:ext cx="0" cy="0"/>
+          <a:chOff x="0" y="0"/>
+          <a:chExt cx="0" cy="0"/>
+        </a:xfrm>
+      </p:grpSpPr>
+      <p:sp>
+        <p:nvSpPr>
+          <p:cNvPr id="2" name="Shape 0"/>
+          <p:cNvSpPr/>
+          <p:nvPr/>
+        </p:nvSpPr>
+        <p:spPr>
+          <a:xfrm>
+            <a:off x="0" y="0"/>
+            <a:ext cx="12188952" cy="164592"/>
+          </a:xfrm>
+          <a:prstGeom prst="rect">
+            <a:avLst/>
+          </a:prstGeom>
+          <a:solidFill>
+            <a:srgbClr val="60A5FA"/>
+          </a:solidFill>
+          <a:ln w="12700">
+            <a:solidFill>
+              <a:srgbClr val="60A5FA"/>
+            </a:solidFill>
+            <a:prstDash val="solid"/>
+          </a:ln>
+        </p:spPr>
+      </p:sp>
+      <p:sp>
+        <p:nvSpPr>
+          <p:cNvPr id="3" name="Text 1"/>
+          <p:cNvSpPr/>
+          <p:nvPr/>
+        </p:nvSpPr>
+        <p:spPr>
+          <a:xfrm>
+            <a:off x="914400" y="2194560"/>
+            <a:ext cx="10332720" cy="731520"/>
+          </a:xfrm>
+          <a:prstGeom prst="rect">
+            <a:avLst/>
+          </a:prstGeom>
+          <a:noFill/>
+          <a:ln/>
+        </p:spPr>
+        <p:txBody>
+          <a:bodyPr wrap="square" lIns="0" tIns="0" rIns="0" bIns="0" rtlCol="0" anchor="ctr"/>
+          <a:lstStyle/>
+          <a:p>
+            <a:pPr algn="ctr" indent="0" marL="0">
+              <a:buNone/>
+            </a:pPr>
+            <a:r>
+              <a:rPr lang="en-US" sz="3400" b="1" dirty="0">
+                <a:solidFill>
+                  <a:srgbClr val="FFFFFF"/>
+                </a:solidFill>
+                <a:latin typeface="Aptos Display" pitchFamily="34" charset="0"/>
+                <a:ea typeface="Aptos Display" pitchFamily="34" charset="-122"/>
+                <a:cs typeface="Aptos Display" pitchFamily="34" charset="-120"/>
+              </a:rPr>
+              <a:t>Thank You</a:t>
+            </a:r>
+            <a:endParaRPr lang="en-US" sz="3400" dirty="0"/>
+          </a:p>
+        </p:txBody>
+      </p:sp>
+      <p:sp>
+        <p:nvSpPr>
+          <p:cNvPr id="4" name="Text 2"/>
+          <p:cNvSpPr/>
+          <p:nvPr/>
+        </p:nvSpPr>
+        <p:spPr>
+          <a:xfrm>
+            <a:off x="914400" y="3154680"/>
+            <a:ext cx="10332720" cy="365760"/>
+          </a:xfrm>
+          <a:prstGeom prst="rect">
+            <a:avLst/>
+          </a:prstGeom>
+          <a:noFill/>
+          <a:ln/>
+        </p:spPr>
+        <p:txBody>
+          <a:bodyPr wrap="square" lIns="0" tIns="0" rIns="0" bIns="0" rtlCol="0" anchor="ctr"/>
+          <a:lstStyle/>
+          <a:p>
+            <a:pPr algn="ctr" indent="0" marL="0">
+              <a:buNone/>
+            </a:pPr>
+            <a:r>
+              <a:rPr lang="en-US" sz="1400" dirty="0">
+                <a:solidFill>
+                  <a:srgbClr val="DBEAFE"/>
+                </a:solidFill>
+                <a:latin typeface="Aptos" pitchFamily="34" charset="0"/>
+                <a:ea typeface="Aptos" pitchFamily="34" charset="-122"/>
+                <a:cs typeface="Aptos" pitchFamily="34" charset="-120"/>
+              </a:rPr>
+              <a:t>Generated by SolvixAI</a:t>
+            </a:r>
+            <a:endParaRPr lang="en-US" sz="1400" dirty="0"/>
+          </a:p>
+        </p:txBody>
+      </p:sp>
+      <p:sp>
+        <p:nvSpPr>
+          <p:cNvPr id="5" name="Text 3"/>
+          <p:cNvSpPr/>
+          <p:nvPr/>
+        </p:nvSpPr>
+        <p:spPr>
+          <a:xfrm>
+            <a:off x="0" y="6309360"/>
+            <a:ext cx="12188952" cy="182880"/>
+          </a:xfrm>
+          <a:prstGeom prst="rect">
+            <a:avLst/>
+          </a:prstGeom>
+          <a:noFill/>
+          <a:ln/>
+        </p:spPr>
+        <p:txBody>
+          <a:bodyPr wrap="square" lIns="0" tIns="0" rIns="0" bIns="0" rtlCol="0" anchor="ctr"/>
+          <a:lstStyle/>
+          <a:p>
+            <a:pPr algn="ctr" indent="0" marL="0">
+              <a:buNone/>
+            </a:pPr>
+            <a:r>
+              <a:rPr lang="en-US" sz="1000" b="1" dirty="0">
+                <a:solidFill>
+                  <a:srgbClr val="64748B"/>
+                </a:solidFill>
+                <a:latin typeface="Aptos" pitchFamily="34" charset="0"/>
+                <a:ea typeface="Aptos" pitchFamily="34" charset="-122"/>
+                <a:cs typeface="Aptos" pitchFamily="34" charset="-120"/>
+              </a:rPr>
+              <a:t>SOLVIX_AI</a:t>
             </a:r>
             <a:endParaRPr lang="en-US" sz="1000" dirty="0"/>
           </a:p>
@@ -1734,7 +5306,7 @@
                 <a:ea typeface="Aptos Display" pitchFamily="34" charset="-122"/>
                 <a:cs typeface="Aptos Display" pitchFamily="34" charset="-120"/>
               </a:rPr>
-              <a:t>What is a Notes App?</a:t>
+              <a:t>Early Life and Family</a:t>
             </a:r>
             <a:endParaRPr lang="en-US" sz="2400" dirty="0"/>
           </a:p>
@@ -1850,7 +5422,7 @@
                 <a:ea typeface="Aptos" pitchFamily="34" charset="-122"/>
                 <a:cs typeface="Aptos" pitchFamily="34" charset="-120"/>
               </a:rPr>
-              <a:t>Tool for capturing quick thoughts</a:t>
+              <a:t>Born 25 December 1876 in Karachi</a:t>
             </a:r>
             <a:endParaRPr lang="en-US" sz="1400" dirty="0"/>
           </a:p>
@@ -1943,7 +5515,7 @@
                 <a:ea typeface="Aptos" pitchFamily="34" charset="-122"/>
                 <a:cs typeface="Aptos" pitchFamily="34" charset="-120"/>
               </a:rPr>
-              <a:t>Common user tasks: add, edit, delete</a:t>
+              <a:t>Born into a prosperous Parsi family</a:t>
             </a:r>
             <a:endParaRPr lang="en-US" sz="1400" dirty="0"/>
           </a:p>
@@ -2036,7 +5608,7 @@
                 <a:ea typeface="Aptos" pitchFamily="34" charset="-122"/>
                 <a:cs typeface="Aptos" pitchFamily="34" charset="-120"/>
               </a:rPr>
-              <a:t>Core features: list, search, organize</a:t>
+              <a:t>Early schooling in local schools</a:t>
             </a:r>
             <a:endParaRPr lang="en-US" sz="1400" dirty="0"/>
           </a:p>
@@ -2129,7 +5701,7 @@
                 <a:ea typeface="Aptos" pitchFamily="34" charset="-122"/>
                 <a:cs typeface="Aptos" pitchFamily="34" charset="-120"/>
               </a:rPr>
-              <a:t>JavaScript enables dynamic interaction</a:t>
+              <a:t>Family influence on his values</a:t>
             </a:r>
             <a:endParaRPr lang="en-US" sz="1400" dirty="0"/>
           </a:p>
@@ -2280,7 +5852,7 @@
                 <a:ea typeface="Aptos Display" pitchFamily="34" charset="-122"/>
                 <a:cs typeface="Aptos Display" pitchFamily="34" charset="-120"/>
               </a:rPr>
-              <a:t>Environment Setup</a:t>
+              <a:t>Academic Excellence</a:t>
             </a:r>
             <a:endParaRPr lang="en-US" sz="2400" dirty="0"/>
           </a:p>
@@ -2396,7 +5968,7 @@
                 <a:ea typeface="Aptos" pitchFamily="34" charset="-122"/>
                 <a:cs typeface="Aptos" pitchFamily="34" charset="-120"/>
               </a:rPr>
-              <a:t>Install Node.js and npm</a:t>
+              <a:t>Studied at St. Patrick's High School</a:t>
             </a:r>
             <a:endParaRPr lang="en-US" sz="1400" dirty="0"/>
           </a:p>
@@ -2489,7 +6061,7 @@
                 <a:ea typeface="Aptos" pitchFamily="34" charset="-122"/>
                 <a:cs typeface="Aptos" pitchFamily="34" charset="-120"/>
               </a:rPr>
-              <a:t>Create project folder and init npm</a:t>
+              <a:t>Graduated from the University of Cambridge</a:t>
             </a:r>
             <a:endParaRPr lang="en-US" sz="1400" dirty="0"/>
           </a:p>
@@ -2582,7 +6154,7 @@
                 <a:ea typeface="Aptos" pitchFamily="34" charset="-122"/>
                 <a:cs typeface="Aptos" pitchFamily="34" charset="-120"/>
               </a:rPr>
-              <a:t>Choose a code editor (VS Code, Sublime)</a:t>
+              <a:t>Earned LLB from Lincoln's Inn</a:t>
             </a:r>
             <a:endParaRPr lang="en-US" sz="1400" dirty="0"/>
           </a:p>
@@ -2675,7 +6247,7 @@
                 <a:ea typeface="Aptos" pitchFamily="34" charset="-122"/>
                 <a:cs typeface="Aptos" pitchFamily="34" charset="-120"/>
               </a:rPr>
-              <a:t>Set up a local server (Live Server extension)</a:t>
+              <a:t>Returned to practice law in Bombay</a:t>
             </a:r>
             <a:endParaRPr lang="en-US" sz="1400" dirty="0"/>
           </a:p>
@@ -2826,7 +6398,7 @@
                 <a:ea typeface="Aptos Display" pitchFamily="34" charset="-122"/>
                 <a:cs typeface="Aptos Display" pitchFamily="34" charset="-120"/>
               </a:rPr>
-              <a:t>Data Model</a:t>
+              <a:t>Political Awakening</a:t>
             </a:r>
             <a:endParaRPr lang="en-US" sz="2400" dirty="0"/>
           </a:p>
@@ -2942,7 +6514,7 @@
                 <a:ea typeface="Aptos" pitchFamily="34" charset="-122"/>
                 <a:cs typeface="Aptos" pitchFamily="34" charset="-120"/>
               </a:rPr>
-              <a:t>Note object: { id, title, content, timestamp }</a:t>
+              <a:t>Joined Indian National Congress in 1906</a:t>
             </a:r>
             <a:endParaRPr lang="en-US" sz="1400" dirty="0"/>
           </a:p>
@@ -3035,7 +6607,7 @@
                 <a:ea typeface="Aptos" pitchFamily="34" charset="-122"/>
                 <a:cs typeface="Aptos" pitchFamily="34" charset="-120"/>
               </a:rPr>
-              <a:t>Store notes in an array</a:t>
+              <a:t>Shifted to Muslim League in 1930</a:t>
             </a:r>
             <a:endParaRPr lang="en-US" sz="1400" dirty="0"/>
           </a:p>
@@ -3128,7 +6700,7 @@
                 <a:ea typeface="Aptos" pitchFamily="34" charset="-122"/>
                 <a:cs typeface="Aptos" pitchFamily="34" charset="-120"/>
               </a:rPr>
-              <a:t>Generate unique id with Date.now() or UUID</a:t>
+              <a:t>Advocated for Muslim rights</a:t>
             </a:r>
             <a:endParaRPr lang="en-US" sz="1400" dirty="0"/>
           </a:p>
@@ -3221,7 +6793,7 @@
                 <a:ea typeface="Aptos" pitchFamily="34" charset="-122"/>
                 <a:cs typeface="Aptos" pitchFamily="34" charset="-120"/>
               </a:rPr>
-              <a:t>Use timestamps for sorting</a:t>
+              <a:t>Delivered key speeches in Bombay</a:t>
             </a:r>
             <a:endParaRPr lang="en-US" sz="1400" dirty="0"/>
           </a:p>
@@ -3372,7 +6944,7 @@
                 <a:ea typeface="Aptos Display" pitchFamily="34" charset="-122"/>
                 <a:cs typeface="Aptos Display" pitchFamily="34" charset="-120"/>
               </a:rPr>
-              <a:t>Building the UI</a:t>
+              <a:t>Leadership of the Muslim League</a:t>
             </a:r>
             <a:endParaRPr lang="en-US" sz="2400" dirty="0"/>
           </a:p>
@@ -3488,7 +7060,7 @@
                 <a:ea typeface="Aptos" pitchFamily="34" charset="-122"/>
                 <a:cs typeface="Aptos" pitchFamily="34" charset="-120"/>
               </a:rPr>
-              <a:t>Create basic HTML skeleton with form and list</a:t>
+              <a:t>Consolidated party structure nationwide</a:t>
             </a:r>
             <a:endParaRPr lang="en-US" sz="1400" dirty="0"/>
           </a:p>
@@ -3581,7 +7153,7 @@
                 <a:ea typeface="Aptos" pitchFamily="34" charset="-122"/>
                 <a:cs typeface="Aptos" pitchFamily="34" charset="-120"/>
               </a:rPr>
-              <a:t>Style with CSS for readability</a:t>
+              <a:t>Introduced Lahore Resolution 1940</a:t>
             </a:r>
             <a:endParaRPr lang="en-US" sz="1400" dirty="0"/>
           </a:p>
@@ -3674,7 +7246,7 @@
                 <a:ea typeface="Aptos" pitchFamily="34" charset="-122"/>
                 <a:cs typeface="Aptos" pitchFamily="34" charset="-120"/>
               </a:rPr>
-              <a:t>Add event listeners for form submit and delete buttons</a:t>
+              <a:t>Led 1946 elections with massive support</a:t>
             </a:r>
             <a:endParaRPr lang="en-US" sz="1400" dirty="0"/>
           </a:p>
@@ -3767,7 +7339,7 @@
                 <a:ea typeface="Aptos" pitchFamily="34" charset="-122"/>
                 <a:cs typeface="Aptos" pitchFamily="34" charset="-120"/>
               </a:rPr>
-              <a:t>Render notes dynamically with JavaScript</a:t>
+              <a:t>Negotiated with British authorities</a:t>
             </a:r>
             <a:endParaRPr lang="en-US" sz="1400" dirty="0"/>
           </a:p>
@@ -3918,7 +7490,7 @@
                 <a:ea typeface="Aptos Display" pitchFamily="34" charset="-122"/>
                 <a:cs typeface="Aptos Display" pitchFamily="34" charset="-120"/>
               </a:rPr>
-              <a:t>CRUD Operations</a:t>
+              <a:t>Role in Partition</a:t>
             </a:r>
             <a:endParaRPr lang="en-US" sz="2400" dirty="0"/>
           </a:p>
@@ -4034,7 +7606,7 @@
                 <a:ea typeface="Aptos" pitchFamily="34" charset="-122"/>
                 <a:cs typeface="Aptos" pitchFamily="34" charset="-120"/>
               </a:rPr>
-              <a:t>Create: push new note to array and re-render</a:t>
+              <a:t>Facilitated 1947 Independence Plan</a:t>
             </a:r>
             <a:endParaRPr lang="en-US" sz="1400" dirty="0"/>
           </a:p>
@@ -4127,7 +7699,7 @@
                 <a:ea typeface="Aptos" pitchFamily="34" charset="-122"/>
                 <a:cs typeface="Aptos" pitchFamily="34" charset="-120"/>
               </a:rPr>
-              <a:t>Read: display all notes from array</a:t>
+              <a:t>Negotiated with Viceroy Mountbatten</a:t>
             </a:r>
             <a:endParaRPr lang="en-US" sz="1400" dirty="0"/>
           </a:p>
@@ -4220,7 +7792,7 @@
                 <a:ea typeface="Aptos" pitchFamily="34" charset="-122"/>
                 <a:cs typeface="Aptos" pitchFamily="34" charset="-120"/>
               </a:rPr>
-              <a:t>Update: edit note fields and update array</a:t>
+              <a:t>Delivered farewell address to Muslims</a:t>
             </a:r>
             <a:endParaRPr lang="en-US" sz="1400" dirty="0"/>
           </a:p>
@@ -4313,7 +7885,7 @@
                 <a:ea typeface="Aptos" pitchFamily="34" charset="-122"/>
                 <a:cs typeface="Aptos" pitchFamily="34" charset="-120"/>
               </a:rPr>
-              <a:t>Delete: remove note by id and re-render</a:t>
+              <a:t>Established Pakistan’s foundational principles</a:t>
             </a:r>
             <a:endParaRPr lang="en-US" sz="1400" dirty="0"/>
           </a:p>
@@ -4464,7 +8036,7 @@
                 <a:ea typeface="Aptos Display" pitchFamily="34" charset="-122"/>
                 <a:cs typeface="Aptos Display" pitchFamily="34" charset="-120"/>
               </a:rPr>
-              <a:t>Persisting Data &amp; Wrap-up</a:t>
+              <a:t>Legacy and Impact</a:t>
             </a:r>
             <a:endParaRPr lang="en-US" sz="2400" dirty="0"/>
           </a:p>
@@ -4580,7 +8152,7 @@
                 <a:ea typeface="Aptos" pitchFamily="34" charset="-122"/>
                 <a:cs typeface="Aptos" pitchFamily="34" charset="-120"/>
               </a:rPr>
-              <a:t>Store notes in localStorage as JSON string</a:t>
+              <a:t>Founding Father of Pakistan</a:t>
             </a:r>
             <a:endParaRPr lang="en-US" sz="1400" dirty="0"/>
           </a:p>
@@ -4673,7 +8245,7 @@
                 <a:ea typeface="Aptos" pitchFamily="34" charset="-122"/>
                 <a:cs typeface="Aptos" pitchFamily="34" charset="-120"/>
               </a:rPr>
-              <a:t>Load notes on page load with JSON.parse</a:t>
+              <a:t>Legal reforms and constitutional framework</a:t>
             </a:r>
             <a:endParaRPr lang="en-US" sz="1400" dirty="0"/>
           </a:p>
@@ -4766,7 +8338,7 @@
                 <a:ea typeface="Aptos" pitchFamily="34" charset="-122"/>
                 <a:cs typeface="Aptos" pitchFamily="34" charset="-120"/>
               </a:rPr>
-              <a:t>Sync changes to localStorage after each CRUD</a:t>
+              <a:t>National symbols: Quaid-e-Azam Day, Jinnah's portrait</a:t>
             </a:r>
             <a:endParaRPr lang="en-US" sz="1400" dirty="0"/>
           </a:p>
@@ -4859,7 +8431,7 @@
                 <a:ea typeface="Aptos" pitchFamily="34" charset="-122"/>
                 <a:cs typeface="Aptos" pitchFamily="34" charset="-120"/>
               </a:rPr>
-              <a:t>Next steps: add tags, search, cloud sync</a:t>
+              <a:t>Enduring influence on Pakistani politics</a:t>
             </a:r>
             <a:endParaRPr lang="en-US" sz="1400" dirty="0"/>
           </a:p>
@@ -4957,7 +8529,7 @@
     <p:bg>
       <p:bgPr>
         <a:solidFill>
-          <a:srgbClr val="0F172A"/>
+          <a:srgbClr val="FFFFFF"/>
         </a:solidFill>
       </p:bgPr>
     </p:bg>
@@ -4977,39 +8549,14 @@
       </p:grpSpPr>
       <p:sp>
         <p:nvSpPr>
-          <p:cNvPr id="2" name="Shape 0"/>
-          <p:cNvSpPr/>
-          <p:nvPr/>
-        </p:nvSpPr>
-        <p:spPr>
-          <a:xfrm>
-            <a:off x="0" y="0"/>
-            <a:ext cx="12188952" cy="164592"/>
-          </a:xfrm>
-          <a:prstGeom prst="rect">
-            <a:avLst/>
-          </a:prstGeom>
-          <a:solidFill>
-            <a:srgbClr val="60A5FA"/>
-          </a:solidFill>
-          <a:ln w="12700">
-            <a:solidFill>
-              <a:srgbClr val="60A5FA"/>
-            </a:solidFill>
-            <a:prstDash val="solid"/>
-          </a:ln>
-        </p:spPr>
-      </p:sp>
-      <p:sp>
-        <p:nvSpPr>
-          <p:cNvPr id="3" name="Text 1"/>
-          <p:cNvSpPr/>
-          <p:nvPr/>
-        </p:nvSpPr>
-        <p:spPr>
-          <a:xfrm>
-            <a:off x="914400" y="2194560"/>
-            <a:ext cx="10332720" cy="731520"/>
+          <p:cNvPr id="2" name="Text 0"/>
+          <p:cNvSpPr/>
+          <p:nvPr/>
+        </p:nvSpPr>
+        <p:spPr>
+          <a:xfrm>
+            <a:off x="457200" y="228600"/>
+            <a:ext cx="9144000" cy="411480"/>
           </a:xfrm>
           <a:prstGeom prst="rect">
             <a:avLst/>
@@ -5021,34 +8568,84 @@
           <a:bodyPr wrap="square" lIns="0" tIns="0" rIns="0" bIns="0" rtlCol="0" anchor="ctr"/>
           <a:lstStyle/>
           <a:p>
-            <a:pPr algn="ctr" indent="0" marL="0">
-              <a:buNone/>
-            </a:pPr>
-            <a:r>
-              <a:rPr lang="en-US" sz="3400" b="1" dirty="0">
-                <a:solidFill>
-                  <a:srgbClr val="FFFFFF"/>
+            <a:pPr algn="l" indent="0" marL="0">
+              <a:buNone/>
+            </a:pPr>
+            <a:r>
+              <a:rPr lang="en-US" sz="2000" b="1" dirty="0">
+                <a:solidFill>
+                  <a:srgbClr val="2563EB"/>
                 </a:solidFill>
                 <a:latin typeface="Aptos Display" pitchFamily="34" charset="0"/>
                 <a:ea typeface="Aptos Display" pitchFamily="34" charset="-122"/>
                 <a:cs typeface="Aptos Display" pitchFamily="34" charset="-120"/>
               </a:rPr>
-              <a:t>Thank You</a:t>
-            </a:r>
-            <a:endParaRPr lang="en-US" sz="3400" dirty="0"/>
-          </a:p>
-        </p:txBody>
-      </p:sp>
-      <p:sp>
-        <p:nvSpPr>
-          <p:cNvPr id="4" name="Text 2"/>
-          <p:cNvSpPr/>
-          <p:nvPr/>
-        </p:nvSpPr>
-        <p:spPr>
-          <a:xfrm>
-            <a:off x="914400" y="3154680"/>
-            <a:ext cx="10332720" cy="365760"/>
+              <a:t>Detailed Summary — Part 1</a:t>
+            </a:r>
+            <a:endParaRPr lang="en-US" sz="2000" dirty="0"/>
+          </a:p>
+        </p:txBody>
+      </p:sp>
+      <p:sp>
+        <p:nvSpPr>
+          <p:cNvPr id="3" name="Shape 1"/>
+          <p:cNvSpPr/>
+          <p:nvPr/>
+        </p:nvSpPr>
+        <p:spPr>
+          <a:xfrm>
+            <a:off x="457200" y="713232"/>
+            <a:ext cx="11247120" cy="0"/>
+          </a:xfrm>
+          <a:prstGeom prst="line">
+            <a:avLst/>
+          </a:prstGeom>
+          <a:noFill/>
+          <a:ln w="12700">
+            <a:solidFill>
+              <a:srgbClr val="E2E8F0"/>
+            </a:solidFill>
+            <a:prstDash val="solid"/>
+          </a:ln>
+        </p:spPr>
+      </p:sp>
+      <p:sp>
+        <p:nvSpPr>
+          <p:cNvPr id="4" name="Shape 2"/>
+          <p:cNvSpPr/>
+          <p:nvPr/>
+        </p:nvSpPr>
+        <p:spPr>
+          <a:xfrm>
+            <a:off x="457200" y="1005840"/>
+            <a:ext cx="6675120" cy="4846320"/>
+          </a:xfrm>
+          <a:prstGeom prst="roundRect">
+            <a:avLst>
+              <a:gd name="adj" fmla="val 1509"/>
+            </a:avLst>
+          </a:prstGeom>
+          <a:solidFill>
+            <a:srgbClr val="EFF6FF"/>
+          </a:solidFill>
+          <a:ln w="6350">
+            <a:solidFill>
+              <a:srgbClr val="E2E8F0"/>
+            </a:solidFill>
+            <a:prstDash val="solid"/>
+          </a:ln>
+        </p:spPr>
+      </p:sp>
+      <p:sp>
+        <p:nvSpPr>
+          <p:cNvPr id="5" name="Text 3"/>
+          <p:cNvSpPr/>
+          <p:nvPr/>
+        </p:nvSpPr>
+        <p:spPr>
+          <a:xfrm>
+            <a:off x="685800" y="1188720"/>
+            <a:ext cx="6263640" cy="4526280"/>
           </a:xfrm>
           <a:prstGeom prst="rect">
             <a:avLst/>
@@ -5057,61 +8654,744 @@
           <a:ln/>
         </p:spPr>
         <p:txBody>
-          <a:bodyPr wrap="square" lIns="0" tIns="0" rIns="0" bIns="0" rtlCol="0" anchor="ctr"/>
-          <a:lstStyle/>
-          <a:p>
-            <a:pPr algn="ctr" indent="0" marL="0">
+          <a:bodyPr wrap="square" lIns="0" tIns="0" rIns="0" bIns="0" rtlCol="0" anchor="t">
+            <a:normAutofit/>
+          </a:bodyPr>
+          <a:lstStyle/>
+          <a:p>
+            <a:pPr algn="l" indent="0" marL="0">
+              <a:lnSpc>
+                <a:spcPct val="140000"/>
+              </a:lnSpc>
               <a:buNone/>
             </a:pPr>
             <a:r>
               <a:rPr lang="en-US" sz="1400" dirty="0">
                 <a:solidFill>
-                  <a:srgbClr val="DBEAFE"/>
+                  <a:srgbClr val="334155"/>
                 </a:solidFill>
                 <a:latin typeface="Aptos" pitchFamily="34" charset="0"/>
                 <a:ea typeface="Aptos" pitchFamily="34" charset="-122"/>
                 <a:cs typeface="Aptos" pitchFamily="34" charset="-120"/>
               </a:rPr>
-              <a:t>Generated by SolvixAI</a:t>
+              <a:t>Quaid-e-Azam: The Architect of Pakistan is a comprehensive, multi-dimensional subject carefully structured across 6 thematic sections in this presentation.</a:t>
             </a:r>
             <a:endParaRPr lang="en-US" sz="1400" dirty="0"/>
           </a:p>
-        </p:txBody>
-      </p:sp>
-      <p:sp>
-        <p:nvSpPr>
-          <p:cNvPr id="5" name="Text 3"/>
-          <p:cNvSpPr/>
-          <p:nvPr/>
-        </p:nvSpPr>
-        <p:spPr>
-          <a:xfrm>
-            <a:off x="0" y="6309360"/>
-            <a:ext cx="12188952" cy="182880"/>
-          </a:xfrm>
-          <a:prstGeom prst="rect">
-            <a:avLst/>
-          </a:prstGeom>
-          <a:noFill/>
-          <a:ln/>
-        </p:spPr>
-        <p:txBody>
-          <a:bodyPr wrap="square" lIns="0" tIns="0" rIns="0" bIns="0" rtlCol="0" anchor="ctr"/>
-          <a:lstStyle/>
-          <a:p>
-            <a:pPr algn="ctr" indent="0" marL="0">
-              <a:buNone/>
-            </a:pPr>
-            <a:r>
-              <a:rPr lang="en-US" sz="1000" b="1" dirty="0">
-                <a:solidFill>
-                  <a:srgbClr val="64748B"/>
+          <a:p>
+            <a:pPr algn="l" indent="0" marL="0">
+              <a:lnSpc>
+                <a:spcPct val="140000"/>
+              </a:lnSpc>
+              <a:buNone/>
+            </a:pPr>
+            <a:endParaRPr lang="en-US" sz="1400" dirty="0"/>
+          </a:p>
+          <a:p>
+            <a:pPr algn="l" indent="0" marL="0">
+              <a:lnSpc>
+                <a:spcPct val="140000"/>
+              </a:lnSpc>
+              <a:buNone/>
+            </a:pPr>
+            <a:r>
+              <a:rPr lang="en-US" sz="1400" dirty="0">
+                <a:solidFill>
+                  <a:srgbClr val="334155"/>
                 </a:solidFill>
                 <a:latin typeface="Aptos" pitchFamily="34" charset="0"/>
                 <a:ea typeface="Aptos" pitchFamily="34" charset="-122"/>
                 <a:cs typeface="Aptos" pitchFamily="34" charset="-120"/>
               </a:rPr>
-              <a:t>SOLVIX_AI</a:t>
+              <a:t>The presentation establishes a strong foundation, introducing the core concepts, background, and essential context needed for deep understanding.</a:t>
+            </a:r>
+            <a:endParaRPr lang="en-US" sz="1400" dirty="0"/>
+          </a:p>
+          <a:p>
+            <a:pPr algn="l" indent="0" marL="0">
+              <a:lnSpc>
+                <a:spcPct val="140000"/>
+              </a:lnSpc>
+              <a:buNone/>
+            </a:pPr>
+            <a:endParaRPr lang="en-US" sz="1400" dirty="0"/>
+          </a:p>
+          <a:p>
+            <a:pPr algn="l" indent="0" marL="0">
+              <a:lnSpc>
+                <a:spcPct val="140000"/>
+              </a:lnSpc>
+              <a:buNone/>
+            </a:pPr>
+            <a:r>
+              <a:rPr lang="en-US" sz="1400" dirty="0">
+                <a:solidFill>
+                  <a:srgbClr val="334155"/>
+                </a:solidFill>
+                <a:latin typeface="Aptos" pitchFamily="34" charset="0"/>
+                <a:ea typeface="Aptos" pitchFamily="34" charset="-122"/>
+                <a:cs typeface="Aptos" pitchFamily="34" charset="-120"/>
+              </a:rPr>
+              <a:t>The central theme "A Comprehensive Overview of His Life and Legacy" anchors the entire discussion and provides the reader with a clear and focused direction throughout.</a:t>
+            </a:r>
+            <a:endParaRPr lang="en-US" sz="1400" dirty="0"/>
+          </a:p>
+          <a:p>
+            <a:pPr algn="l" indent="0" marL="0">
+              <a:lnSpc>
+                <a:spcPct val="140000"/>
+              </a:lnSpc>
+              <a:buNone/>
+            </a:pPr>
+            <a:endParaRPr lang="en-US" sz="1400" dirty="0"/>
+          </a:p>
+          <a:p>
+            <a:pPr algn="l" indent="0" marL="0">
+              <a:lnSpc>
+                <a:spcPct val="140000"/>
+              </a:lnSpc>
+              <a:buNone/>
+            </a:pPr>
+            <a:r>
+              <a:rPr lang="en-US" sz="1400" dirty="0">
+                <a:solidFill>
+                  <a:srgbClr val="334155"/>
+                </a:solidFill>
+                <a:latin typeface="Aptos" pitchFamily="34" charset="0"/>
+                <a:ea typeface="Aptos" pitchFamily="34" charset="-122"/>
+                <a:cs typeface="Aptos" pitchFamily="34" charset="-120"/>
+              </a:rPr>
+              <a:t>Each section has been thoughtfully designed to build upon the previous one, ensuring a smooth, logical, and easy-to-follow flow of ideas.</a:t>
+            </a:r>
+            <a:endParaRPr lang="en-US" sz="1400" dirty="0"/>
+          </a:p>
+          <a:p>
+            <a:pPr algn="l" indent="0" marL="0">
+              <a:lnSpc>
+                <a:spcPct val="140000"/>
+              </a:lnSpc>
+              <a:buNone/>
+            </a:pPr>
+            <a:endParaRPr lang="en-US" sz="1400" dirty="0"/>
+          </a:p>
+          <a:p>
+            <a:pPr algn="l" indent="0" marL="0">
+              <a:lnSpc>
+                <a:spcPct val="140000"/>
+              </a:lnSpc>
+              <a:buNone/>
+            </a:pPr>
+            <a:r>
+              <a:rPr lang="en-US" sz="1400" dirty="0">
+                <a:solidFill>
+                  <a:srgbClr val="334155"/>
+                </a:solidFill>
+                <a:latin typeface="Aptos" pitchFamily="34" charset="0"/>
+                <a:ea typeface="Aptos" pitchFamily="34" charset="-122"/>
+                <a:cs typeface="Aptos" pitchFamily="34" charset="-120"/>
+              </a:rPr>
+              <a:t>The structure is intentionally modular so that every key area receives adequate attention while still contributing to a unified narrative.</a:t>
+            </a:r>
+            <a:endParaRPr lang="en-US" sz="1400" dirty="0"/>
+          </a:p>
+        </p:txBody>
+      </p:sp>
+      <p:sp>
+        <p:nvSpPr>
+          <p:cNvPr id="6" name="Shape 4"/>
+          <p:cNvSpPr/>
+          <p:nvPr/>
+        </p:nvSpPr>
+        <p:spPr>
+          <a:xfrm>
+            <a:off x="7315200" y="1005840"/>
+            <a:ext cx="4389120" cy="4846320"/>
+          </a:xfrm>
+          <a:prstGeom prst="roundRect">
+            <a:avLst>
+              <a:gd name="adj" fmla="val 1667"/>
+            </a:avLst>
+          </a:prstGeom>
+          <a:solidFill>
+            <a:srgbClr val="FFFFFF"/>
+          </a:solidFill>
+          <a:ln w="6350">
+            <a:solidFill>
+              <a:srgbClr val="E2E8F0"/>
+            </a:solidFill>
+            <a:prstDash val="solid"/>
+          </a:ln>
+        </p:spPr>
+      </p:sp>
+      <p:sp>
+        <p:nvSpPr>
+          <p:cNvPr id="7" name="Text 5"/>
+          <p:cNvSpPr/>
+          <p:nvPr/>
+        </p:nvSpPr>
+        <p:spPr>
+          <a:xfrm>
+            <a:off x="7498080" y="1143000"/>
+            <a:ext cx="4023360" cy="365760"/>
+          </a:xfrm>
+          <a:prstGeom prst="rect">
+            <a:avLst/>
+          </a:prstGeom>
+          <a:noFill/>
+          <a:ln/>
+        </p:spPr>
+        <p:txBody>
+          <a:bodyPr wrap="square" lIns="0" tIns="0" rIns="0" bIns="0" rtlCol="0" anchor="ctr"/>
+          <a:lstStyle/>
+          <a:p>
+            <a:pPr algn="l" indent="0" marL="0">
+              <a:buNone/>
+            </a:pPr>
+            <a:r>
+              <a:rPr lang="en-US" sz="1400" b="1" dirty="0">
+                <a:solidFill>
+                  <a:srgbClr val="2563EB"/>
+                </a:solidFill>
+                <a:latin typeface="Aptos" pitchFamily="34" charset="0"/>
+                <a:ea typeface="Aptos" pitchFamily="34" charset="-122"/>
+                <a:cs typeface="Aptos" pitchFamily="34" charset="-120"/>
+              </a:rPr>
+              <a:t>Section Emphasis</a:t>
+            </a:r>
+            <a:endParaRPr lang="en-US" sz="1400" dirty="0"/>
+          </a:p>
+        </p:txBody>
+      </p:sp>
+      <p:graphicFrame>
+        <p:nvGraphicFramePr>
+          <p:cNvPr id="8" name="Chart 0" descr=""/>
+          <p:cNvGraphicFramePr/>
+          <p:nvPr/>
+        </p:nvGraphicFramePr>
+        <p:xfrm>
+          <a:off x="7498080" y="1600200"/>
+          <a:ext cx="4023360" cy="4114800"/>
+        </p:xfrm>
+        <a:graphic xmlns:a="http://schemas.openxmlformats.org/drawingml/2006/main">
+          <a:graphicData uri="http://schemas.openxmlformats.org/drawingml/2006/chart">
+            <c:chart xmlns:c="http://schemas.openxmlformats.org/drawingml/2006/chart" r:id="rId1"/>
+          </a:graphicData>
+        </a:graphic>
+      </p:graphicFrame>
+      <p:sp>
+        <p:nvSpPr>
+          <p:cNvPr id="9" name="Text 6"/>
+          <p:cNvSpPr/>
+          <p:nvPr/>
+        </p:nvSpPr>
+        <p:spPr>
+          <a:xfrm>
+            <a:off x="457200" y="6309360"/>
+            <a:ext cx="1828800" cy="182880"/>
+          </a:xfrm>
+          <a:prstGeom prst="rect">
+            <a:avLst/>
+          </a:prstGeom>
+          <a:noFill/>
+          <a:ln/>
+        </p:spPr>
+        <p:txBody>
+          <a:bodyPr wrap="square" lIns="0" tIns="0" rIns="0" bIns="0" rtlCol="0" anchor="ctr"/>
+          <a:lstStyle/>
+          <a:p>
+            <a:pPr algn="l" indent="0" marL="0">
+              <a:buNone/>
+            </a:pPr>
+            <a:r>
+              <a:rPr lang="en-US" sz="1000" b="1" dirty="0">
+                <a:solidFill>
+                  <a:srgbClr val="64748B"/>
+                </a:solidFill>
+                <a:latin typeface="Aptos" pitchFamily="34" charset="0"/>
+                <a:ea typeface="Aptos" pitchFamily="34" charset="-122"/>
+                <a:cs typeface="Aptos" pitchFamily="34" charset="-120"/>
+              </a:rPr>
+              <a:t>Solvix</a:t>
+            </a:r>
+            <a:endParaRPr lang="en-US" sz="1000" dirty="0"/>
+          </a:p>
+        </p:txBody>
+      </p:sp>
+      <p:sp>
+        <p:nvSpPr>
+          <p:cNvPr id="10" name="Text 7"/>
+          <p:cNvSpPr/>
+          <p:nvPr/>
+        </p:nvSpPr>
+        <p:spPr>
+          <a:xfrm>
+            <a:off x="10058400" y="6309360"/>
+            <a:ext cx="1645920" cy="182880"/>
+          </a:xfrm>
+          <a:prstGeom prst="rect">
+            <a:avLst/>
+          </a:prstGeom>
+          <a:noFill/>
+          <a:ln/>
+        </p:spPr>
+        <p:txBody>
+          <a:bodyPr wrap="square" lIns="0" tIns="0" rIns="0" bIns="0" rtlCol="0" anchor="ctr"/>
+          <a:lstStyle/>
+          <a:p>
+            <a:pPr algn="r" indent="0" marL="0">
+              <a:buNone/>
+            </a:pPr>
+            <a:r>
+              <a:rPr lang="en-US" sz="1000" b="1" dirty="0">
+                <a:solidFill>
+                  <a:srgbClr val="64748B"/>
+                </a:solidFill>
+                <a:latin typeface="Aptos" pitchFamily="34" charset="0"/>
+                <a:ea typeface="Aptos" pitchFamily="34" charset="-122"/>
+                <a:cs typeface="Aptos" pitchFamily="34" charset="-120"/>
+              </a:rPr>
+              <a:t>Summary 1/5</a:t>
+            </a:r>
+            <a:endParaRPr lang="en-US" sz="1000" dirty="0"/>
+          </a:p>
+        </p:txBody>
+      </p:sp>
+    </p:spTree>
+  </p:cSld>
+  <p:clrMapOvr>
+    <a:masterClrMapping/>
+  </p:clrMapOvr>
+</p:sld>
+</file>
+
+<file path=ppt/slides/slide9.xml><?xml version="1.0" encoding="utf-8"?>
+<p:sld xmlns:a="http://schemas.openxmlformats.org/drawingml/2006/main" xmlns:r="http://schemas.openxmlformats.org/officeDocument/2006/relationships" xmlns:p="http://schemas.openxmlformats.org/presentationml/2006/main">
+  <p:cSld name="Slide 9">
+    <p:bg>
+      <p:bgPr>
+        <a:solidFill>
+          <a:srgbClr val="FFFFFF"/>
+        </a:solidFill>
+      </p:bgPr>
+    </p:bg>
+    <p:spTree>
+      <p:nvGrpSpPr>
+        <p:cNvPr id="1" name=""/>
+        <p:cNvGrpSpPr/>
+        <p:nvPr/>
+      </p:nvGrpSpPr>
+      <p:grpSpPr>
+        <a:xfrm>
+          <a:off x="0" y="0"/>
+          <a:ext cx="0" cy="0"/>
+          <a:chOff x="0" y="0"/>
+          <a:chExt cx="0" cy="0"/>
+        </a:xfrm>
+      </p:grpSpPr>
+      <p:sp>
+        <p:nvSpPr>
+          <p:cNvPr id="2" name="Text 0"/>
+          <p:cNvSpPr/>
+          <p:nvPr/>
+        </p:nvSpPr>
+        <p:spPr>
+          <a:xfrm>
+            <a:off x="457200" y="228600"/>
+            <a:ext cx="9144000" cy="411480"/>
+          </a:xfrm>
+          <a:prstGeom prst="rect">
+            <a:avLst/>
+          </a:prstGeom>
+          <a:noFill/>
+          <a:ln/>
+        </p:spPr>
+        <p:txBody>
+          <a:bodyPr wrap="square" lIns="0" tIns="0" rIns="0" bIns="0" rtlCol="0" anchor="ctr"/>
+          <a:lstStyle/>
+          <a:p>
+            <a:pPr algn="l" indent="0" marL="0">
+              <a:buNone/>
+            </a:pPr>
+            <a:r>
+              <a:rPr lang="en-US" sz="2000" b="1" dirty="0">
+                <a:solidFill>
+                  <a:srgbClr val="2563EB"/>
+                </a:solidFill>
+                <a:latin typeface="Aptos Display" pitchFamily="34" charset="0"/>
+                <a:ea typeface="Aptos Display" pitchFamily="34" charset="-122"/>
+                <a:cs typeface="Aptos Display" pitchFamily="34" charset="-120"/>
+              </a:rPr>
+              <a:t>Detailed Summary — Part 2</a:t>
+            </a:r>
+            <a:endParaRPr lang="en-US" sz="2000" dirty="0"/>
+          </a:p>
+        </p:txBody>
+      </p:sp>
+      <p:sp>
+        <p:nvSpPr>
+          <p:cNvPr id="3" name="Shape 1"/>
+          <p:cNvSpPr/>
+          <p:nvPr/>
+        </p:nvSpPr>
+        <p:spPr>
+          <a:xfrm>
+            <a:off x="457200" y="713232"/>
+            <a:ext cx="11247120" cy="0"/>
+          </a:xfrm>
+          <a:prstGeom prst="line">
+            <a:avLst/>
+          </a:prstGeom>
+          <a:noFill/>
+          <a:ln w="12700">
+            <a:solidFill>
+              <a:srgbClr val="E2E8F0"/>
+            </a:solidFill>
+            <a:prstDash val="solid"/>
+          </a:ln>
+        </p:spPr>
+      </p:sp>
+      <p:sp>
+        <p:nvSpPr>
+          <p:cNvPr id="4" name="Shape 2"/>
+          <p:cNvSpPr/>
+          <p:nvPr/>
+        </p:nvSpPr>
+        <p:spPr>
+          <a:xfrm>
+            <a:off x="457200" y="1005840"/>
+            <a:ext cx="6675120" cy="4846320"/>
+          </a:xfrm>
+          <a:prstGeom prst="roundRect">
+            <a:avLst>
+              <a:gd name="adj" fmla="val 1509"/>
+            </a:avLst>
+          </a:prstGeom>
+          <a:solidFill>
+            <a:srgbClr val="EFF6FF"/>
+          </a:solidFill>
+          <a:ln w="6350">
+            <a:solidFill>
+              <a:srgbClr val="E2E8F0"/>
+            </a:solidFill>
+            <a:prstDash val="solid"/>
+          </a:ln>
+        </p:spPr>
+      </p:sp>
+      <p:sp>
+        <p:nvSpPr>
+          <p:cNvPr id="5" name="Text 3"/>
+          <p:cNvSpPr/>
+          <p:nvPr/>
+        </p:nvSpPr>
+        <p:spPr>
+          <a:xfrm>
+            <a:off x="685800" y="1188720"/>
+            <a:ext cx="6263640" cy="4526280"/>
+          </a:xfrm>
+          <a:prstGeom prst="rect">
+            <a:avLst/>
+          </a:prstGeom>
+          <a:noFill/>
+          <a:ln/>
+        </p:spPr>
+        <p:txBody>
+          <a:bodyPr wrap="square" lIns="0" tIns="0" rIns="0" bIns="0" rtlCol="0" anchor="t">
+            <a:normAutofit/>
+          </a:bodyPr>
+          <a:lstStyle/>
+          <a:p>
+            <a:pPr algn="l" indent="0" marL="0">
+              <a:lnSpc>
+                <a:spcPct val="140000"/>
+              </a:lnSpc>
+              <a:buNone/>
+            </a:pPr>
+            <a:r>
+              <a:rPr lang="en-US" sz="1400" dirty="0">
+                <a:solidFill>
+                  <a:srgbClr val="334155"/>
+                </a:solidFill>
+                <a:latin typeface="Aptos" pitchFamily="34" charset="0"/>
+                <a:ea typeface="Aptos" pitchFamily="34" charset="-122"/>
+                <a:cs typeface="Aptos" pitchFamily="34" charset="-120"/>
+              </a:rPr>
+              <a:t>Together, these sections cover approximately 24 key bullet points highlighting the most important insights and takeaways.</a:t>
+            </a:r>
+            <a:endParaRPr lang="en-US" sz="1400" dirty="0"/>
+          </a:p>
+          <a:p>
+            <a:pPr algn="l" indent="0" marL="0">
+              <a:lnSpc>
+                <a:spcPct val="140000"/>
+              </a:lnSpc>
+              <a:buNone/>
+            </a:pPr>
+            <a:endParaRPr lang="en-US" sz="1400" dirty="0"/>
+          </a:p>
+          <a:p>
+            <a:pPr algn="l" indent="0" marL="0">
+              <a:lnSpc>
+                <a:spcPct val="140000"/>
+              </a:lnSpc>
+              <a:buNone/>
+            </a:pPr>
+            <a:r>
+              <a:rPr lang="en-US" sz="1400" dirty="0">
+                <a:solidFill>
+                  <a:srgbClr val="334155"/>
+                </a:solidFill>
+                <a:latin typeface="Aptos" pitchFamily="34" charset="0"/>
+                <a:ea typeface="Aptos" pitchFamily="34" charset="-122"/>
+                <a:cs typeface="Aptos" pitchFamily="34" charset="-120"/>
+              </a:rPr>
+              <a:t>From a strategic perspective, Quaid-e-Azam: The Architect of Pakistan plays a significant role in shaping outcomes, influencing decisions, and driving measurable value.</a:t>
+            </a:r>
+            <a:endParaRPr lang="en-US" sz="1400" dirty="0"/>
+          </a:p>
+          <a:p>
+            <a:pPr algn="l" indent="0" marL="0">
+              <a:lnSpc>
+                <a:spcPct val="140000"/>
+              </a:lnSpc>
+              <a:buNone/>
+            </a:pPr>
+            <a:endParaRPr lang="en-US" sz="1400" dirty="0"/>
+          </a:p>
+          <a:p>
+            <a:pPr algn="l" indent="0" marL="0">
+              <a:lnSpc>
+                <a:spcPct val="140000"/>
+              </a:lnSpc>
+              <a:buNone/>
+            </a:pPr>
+            <a:r>
+              <a:rPr lang="en-US" sz="1400" dirty="0">
+                <a:solidFill>
+                  <a:srgbClr val="334155"/>
+                </a:solidFill>
+                <a:latin typeface="Aptos" pitchFamily="34" charset="0"/>
+                <a:ea typeface="Aptos" pitchFamily="34" charset="-122"/>
+                <a:cs typeface="Aptos" pitchFamily="34" charset="-120"/>
+              </a:rPr>
+              <a:t>It combines theoretical understanding with practical application, making it relevant both for new learners and experienced professionals.</a:t>
+            </a:r>
+            <a:endParaRPr lang="en-US" sz="1400" dirty="0"/>
+          </a:p>
+          <a:p>
+            <a:pPr algn="l" indent="0" marL="0">
+              <a:lnSpc>
+                <a:spcPct val="140000"/>
+              </a:lnSpc>
+              <a:buNone/>
+            </a:pPr>
+            <a:endParaRPr lang="en-US" sz="1400" dirty="0"/>
+          </a:p>
+          <a:p>
+            <a:pPr algn="l" indent="0" marL="0">
+              <a:lnSpc>
+                <a:spcPct val="140000"/>
+              </a:lnSpc>
+              <a:buNone/>
+            </a:pPr>
+            <a:r>
+              <a:rPr lang="en-US" sz="1400" dirty="0">
+                <a:solidFill>
+                  <a:srgbClr val="334155"/>
+                </a:solidFill>
+                <a:latin typeface="Aptos" pitchFamily="34" charset="0"/>
+                <a:ea typeface="Aptos" pitchFamily="34" charset="-122"/>
+                <a:cs typeface="Aptos" pitchFamily="34" charset="-120"/>
+              </a:rPr>
+              <a:t>One of the most important observations is that Quaid-e-Azam: The Architect of Pakistan cannot be viewed in isolation from other internal or external factors.</a:t>
+            </a:r>
+            <a:endParaRPr lang="en-US" sz="1400" dirty="0"/>
+          </a:p>
+          <a:p>
+            <a:pPr algn="l" indent="0" marL="0">
+              <a:lnSpc>
+                <a:spcPct val="140000"/>
+              </a:lnSpc>
+              <a:buNone/>
+            </a:pPr>
+            <a:endParaRPr lang="en-US" sz="1400" dirty="0"/>
+          </a:p>
+          <a:p>
+            <a:pPr algn="l" indent="0" marL="0">
+              <a:lnSpc>
+                <a:spcPct val="140000"/>
+              </a:lnSpc>
+              <a:buNone/>
+            </a:pPr>
+            <a:r>
+              <a:rPr lang="en-US" sz="1400" dirty="0">
+                <a:solidFill>
+                  <a:srgbClr val="334155"/>
+                </a:solidFill>
+                <a:latin typeface="Aptos" pitchFamily="34" charset="0"/>
+                <a:ea typeface="Aptos" pitchFamily="34" charset="-122"/>
+                <a:cs typeface="Aptos" pitchFamily="34" charset="-120"/>
+              </a:rPr>
+              <a:t>It interacts with technology, human behavior, market dynamics, and organizational priorities in complex and often unpredictable ways.</a:t>
+            </a:r>
+            <a:endParaRPr lang="en-US" sz="1400" dirty="0"/>
+          </a:p>
+        </p:txBody>
+      </p:sp>
+      <p:sp>
+        <p:nvSpPr>
+          <p:cNvPr id="6" name="Shape 4"/>
+          <p:cNvSpPr/>
+          <p:nvPr/>
+        </p:nvSpPr>
+        <p:spPr>
+          <a:xfrm>
+            <a:off x="7315200" y="1005840"/>
+            <a:ext cx="4389120" cy="4846320"/>
+          </a:xfrm>
+          <a:prstGeom prst="roundRect">
+            <a:avLst>
+              <a:gd name="adj" fmla="val 1667"/>
+            </a:avLst>
+          </a:prstGeom>
+          <a:solidFill>
+            <a:srgbClr val="FFFFFF"/>
+          </a:solidFill>
+          <a:ln w="6350">
+            <a:solidFill>
+              <a:srgbClr val="E2E8F0"/>
+            </a:solidFill>
+            <a:prstDash val="solid"/>
+          </a:ln>
+        </p:spPr>
+      </p:sp>
+      <p:sp>
+        <p:nvSpPr>
+          <p:cNvPr id="7" name="Text 5"/>
+          <p:cNvSpPr/>
+          <p:nvPr/>
+        </p:nvSpPr>
+        <p:spPr>
+          <a:xfrm>
+            <a:off x="7498080" y="1143000"/>
+            <a:ext cx="4023360" cy="365760"/>
+          </a:xfrm>
+          <a:prstGeom prst="rect">
+            <a:avLst/>
+          </a:prstGeom>
+          <a:noFill/>
+          <a:ln/>
+        </p:spPr>
+        <p:txBody>
+          <a:bodyPr wrap="square" lIns="0" tIns="0" rIns="0" bIns="0" rtlCol="0" anchor="ctr"/>
+          <a:lstStyle/>
+          <a:p>
+            <a:pPr algn="l" indent="0" marL="0">
+              <a:buNone/>
+            </a:pPr>
+            <a:r>
+              <a:rPr lang="en-US" sz="1400" b="1" dirty="0">
+                <a:solidFill>
+                  <a:srgbClr val="2563EB"/>
+                </a:solidFill>
+                <a:latin typeface="Aptos" pitchFamily="34" charset="0"/>
+                <a:ea typeface="Aptos" pitchFamily="34" charset="-122"/>
+                <a:cs typeface="Aptos" pitchFamily="34" charset="-120"/>
+              </a:rPr>
+              <a:t>Key Insights</a:t>
+            </a:r>
+            <a:endParaRPr lang="en-US" sz="1400" dirty="0"/>
+          </a:p>
+        </p:txBody>
+      </p:sp>
+      <p:graphicFrame>
+        <p:nvGraphicFramePr>
+          <p:cNvPr id="8" name="Chart 0" descr=""/>
+          <p:cNvGraphicFramePr/>
+          <p:nvPr/>
+        </p:nvGraphicFramePr>
+        <p:xfrm>
+          <a:off x="7498080" y="1600200"/>
+          <a:ext cx="4023360" cy="4114800"/>
+        </p:xfrm>
+        <a:graphic xmlns:a="http://schemas.openxmlformats.org/drawingml/2006/main">
+          <a:graphicData uri="http://schemas.openxmlformats.org/drawingml/2006/chart">
+            <c:chart xmlns:c="http://schemas.openxmlformats.org/drawingml/2006/chart" r:id="rId1"/>
+          </a:graphicData>
+        </a:graphic>
+      </p:graphicFrame>
+      <p:sp>
+        <p:nvSpPr>
+          <p:cNvPr id="9" name="Text 6"/>
+          <p:cNvSpPr/>
+          <p:nvPr/>
+        </p:nvSpPr>
+        <p:spPr>
+          <a:xfrm>
+            <a:off x="457200" y="6309360"/>
+            <a:ext cx="1828800" cy="182880"/>
+          </a:xfrm>
+          <a:prstGeom prst="rect">
+            <a:avLst/>
+          </a:prstGeom>
+          <a:noFill/>
+          <a:ln/>
+        </p:spPr>
+        <p:txBody>
+          <a:bodyPr wrap="square" lIns="0" tIns="0" rIns="0" bIns="0" rtlCol="0" anchor="ctr"/>
+          <a:lstStyle/>
+          <a:p>
+            <a:pPr algn="l" indent="0" marL="0">
+              <a:buNone/>
+            </a:pPr>
+            <a:r>
+              <a:rPr lang="en-US" sz="1000" b="1" dirty="0">
+                <a:solidFill>
+                  <a:srgbClr val="64748B"/>
+                </a:solidFill>
+                <a:latin typeface="Aptos" pitchFamily="34" charset="0"/>
+                <a:ea typeface="Aptos" pitchFamily="34" charset="-122"/>
+                <a:cs typeface="Aptos" pitchFamily="34" charset="-120"/>
+              </a:rPr>
+              <a:t>Solvix</a:t>
+            </a:r>
+            <a:endParaRPr lang="en-US" sz="1000" dirty="0"/>
+          </a:p>
+        </p:txBody>
+      </p:sp>
+      <p:sp>
+        <p:nvSpPr>
+          <p:cNvPr id="10" name="Text 7"/>
+          <p:cNvSpPr/>
+          <p:nvPr/>
+        </p:nvSpPr>
+        <p:spPr>
+          <a:xfrm>
+            <a:off x="10058400" y="6309360"/>
+            <a:ext cx="1645920" cy="182880"/>
+          </a:xfrm>
+          <a:prstGeom prst="rect">
+            <a:avLst/>
+          </a:prstGeom>
+          <a:noFill/>
+          <a:ln/>
+        </p:spPr>
+        <p:txBody>
+          <a:bodyPr wrap="square" lIns="0" tIns="0" rIns="0" bIns="0" rtlCol="0" anchor="ctr"/>
+          <a:lstStyle/>
+          <a:p>
+            <a:pPr algn="r" indent="0" marL="0">
+              <a:buNone/>
+            </a:pPr>
+            <a:r>
+              <a:rPr lang="en-US" sz="1000" b="1" dirty="0">
+                <a:solidFill>
+                  <a:srgbClr val="64748B"/>
+                </a:solidFill>
+                <a:latin typeface="Aptos" pitchFamily="34" charset="0"/>
+                <a:ea typeface="Aptos" pitchFamily="34" charset="-122"/>
+                <a:cs typeface="Aptos" pitchFamily="34" charset="-120"/>
+              </a:rPr>
+              <a:t>Summary 2/5</a:t>
             </a:r>
             <a:endParaRPr lang="en-US" sz="1000" dirty="0"/>
           </a:p>

</xml_diff>

<commit_message>
some updates all files
</commit_message>
<xml_diff>
--- a/backend/services/agent/presentation.pptx
+++ b/backend/services/agent/presentation.pptx
@@ -119,7 +119,7 @@
 </p:presentation>
 </file>
 
-<file path=ppt/charts/chart1.xml><?xml version="1.0" encoding="utf-8"?>
+<file path=ppt/charts/chart16.xml><?xml version="1.0" encoding="utf-8"?>
 <c:chartSpace xmlns:c="http://schemas.openxmlformats.org/drawingml/2006/chart" xmlns:a="http://schemas.openxmlformats.org/drawingml/2006/main" xmlns:r="http://schemas.openxmlformats.org/officeDocument/2006/relationships">
   <c:date1904 val="0"/>
   <c:roundedCorners val="1"/>
@@ -252,19 +252,19 @@
                     <c:v>Early Life…</c:v>
                   </c:pt>
                   <c:pt idx="1">
-                    <c:v>Academic E…</c:v>
+                    <c:v>The 1992 W…</c:v>
                   </c:pt>
                   <c:pt idx="2">
-                    <c:v>Political …</c:v>
+                    <c:v>Philanthro…</c:v>
                   </c:pt>
                   <c:pt idx="3">
-                    <c:v>Leadership…</c:v>
+                    <c:v>Entry into…</c:v>
                   </c:pt>
                   <c:pt idx="4">
-                    <c:v>Role in Pa…</c:v>
+                    <c:v>Tenure as …</c:v>
                   </c:pt>
                   <c:pt idx="5">
-                    <c:v>Legacy and…</c:v>
+                    <c:v>Post-Premi…</c:v>
                   </c:pt>
                 </c:lvl>
               </c:multiLvlStrCache>
@@ -277,22 +277,22 @@
                 <c:formatCode>General</c:formatCode>
                 <c:ptCount val="6"/>
                 <c:pt idx="0">
-                  <c:v>4</c:v>
+                  <c:v>5</c:v>
                 </c:pt>
                 <c:pt idx="1">
-                  <c:v>4</c:v>
+                  <c:v>5</c:v>
                 </c:pt>
                 <c:pt idx="2">
-                  <c:v>4</c:v>
+                  <c:v>5</c:v>
                 </c:pt>
                 <c:pt idx="3">
-                  <c:v>4</c:v>
+                  <c:v>5</c:v>
                 </c:pt>
                 <c:pt idx="4">
-                  <c:v>4</c:v>
+                  <c:v>5</c:v>
                 </c:pt>
                 <c:pt idx="5">
-                  <c:v>4</c:v>
+                  <c:v>5</c:v>
                 </c:pt>
               </c:numCache>
             </c:numRef>
@@ -445,7 +445,7 @@
 </c:chartSpace>
 </file>
 
-<file path=ppt/charts/chart2.xml><?xml version="1.0" encoding="utf-8"?>
+<file path=ppt/charts/chart17.xml><?xml version="1.0" encoding="utf-8"?>
 <c:chartSpace xmlns:c="http://schemas.openxmlformats.org/drawingml/2006/chart" xmlns:a="http://schemas.openxmlformats.org/drawingml/2006/main" xmlns:r="http://schemas.openxmlformats.org/officeDocument/2006/relationships">
   <c:date1904 val="0"/>
   <c:roundedCorners val="1"/>
@@ -578,19 +578,19 @@
                     <c:v>Early Life…</c:v>
                   </c:pt>
                   <c:pt idx="1">
-                    <c:v>Academic E…</c:v>
+                    <c:v>The 1992 W…</c:v>
                   </c:pt>
                   <c:pt idx="2">
-                    <c:v>Political …</c:v>
+                    <c:v>Philanthro…</c:v>
                   </c:pt>
                   <c:pt idx="3">
-                    <c:v>Leadership…</c:v>
+                    <c:v>Entry into…</c:v>
                   </c:pt>
                   <c:pt idx="4">
-                    <c:v>Role in Pa…</c:v>
+                    <c:v>Tenure as …</c:v>
                   </c:pt>
                   <c:pt idx="5">
-                    <c:v>Legacy and…</c:v>
+                    <c:v>Post-Premi…</c:v>
                   </c:pt>
                 </c:lvl>
               </c:multiLvlStrCache>
@@ -603,22 +603,22 @@
                 <c:formatCode>General</c:formatCode>
                 <c:ptCount val="6"/>
                 <c:pt idx="0">
-                  <c:v>4</c:v>
+                  <c:v>5</c:v>
                 </c:pt>
                 <c:pt idx="1">
-                  <c:v>4</c:v>
+                  <c:v>5</c:v>
                 </c:pt>
                 <c:pt idx="2">
-                  <c:v>4</c:v>
+                  <c:v>5</c:v>
                 </c:pt>
                 <c:pt idx="3">
-                  <c:v>4</c:v>
+                  <c:v>5</c:v>
                 </c:pt>
                 <c:pt idx="4">
-                  <c:v>4</c:v>
+                  <c:v>5</c:v>
                 </c:pt>
                 <c:pt idx="5">
-                  <c:v>4</c:v>
+                  <c:v>5</c:v>
                 </c:pt>
               </c:numCache>
             </c:numRef>
@@ -771,7 +771,7 @@
 </c:chartSpace>
 </file>
 
-<file path=ppt/charts/chart3.xml><?xml version="1.0" encoding="utf-8"?>
+<file path=ppt/charts/chart18.xml><?xml version="1.0" encoding="utf-8"?>
 <c:chartSpace xmlns:c="http://schemas.openxmlformats.org/drawingml/2006/chart" xmlns:a="http://schemas.openxmlformats.org/drawingml/2006/main" xmlns:r="http://schemas.openxmlformats.org/officeDocument/2006/relationships">
   <c:date1904 val="0"/>
   <c:roundedCorners val="1"/>
@@ -904,19 +904,19 @@
                     <c:v>Early Life…</c:v>
                   </c:pt>
                   <c:pt idx="1">
-                    <c:v>Academic E…</c:v>
+                    <c:v>The 1992 W…</c:v>
                   </c:pt>
                   <c:pt idx="2">
-                    <c:v>Political …</c:v>
+                    <c:v>Philanthro…</c:v>
                   </c:pt>
                   <c:pt idx="3">
-                    <c:v>Leadership…</c:v>
+                    <c:v>Entry into…</c:v>
                   </c:pt>
                   <c:pt idx="4">
-                    <c:v>Role in Pa…</c:v>
+                    <c:v>Tenure as …</c:v>
                   </c:pt>
                   <c:pt idx="5">
-                    <c:v>Legacy and…</c:v>
+                    <c:v>Post-Premi…</c:v>
                   </c:pt>
                 </c:lvl>
               </c:multiLvlStrCache>
@@ -929,22 +929,22 @@
                 <c:formatCode>General</c:formatCode>
                 <c:ptCount val="6"/>
                 <c:pt idx="0">
-                  <c:v>4</c:v>
+                  <c:v>5</c:v>
                 </c:pt>
                 <c:pt idx="1">
-                  <c:v>4</c:v>
+                  <c:v>5</c:v>
                 </c:pt>
                 <c:pt idx="2">
-                  <c:v>4</c:v>
+                  <c:v>5</c:v>
                 </c:pt>
                 <c:pt idx="3">
-                  <c:v>4</c:v>
+                  <c:v>5</c:v>
                 </c:pt>
                 <c:pt idx="4">
-                  <c:v>4</c:v>
+                  <c:v>5</c:v>
                 </c:pt>
                 <c:pt idx="5">
-                  <c:v>4</c:v>
+                  <c:v>5</c:v>
                 </c:pt>
               </c:numCache>
             </c:numRef>
@@ -1097,7 +1097,7 @@
 </c:chartSpace>
 </file>
 
-<file path=ppt/charts/chart4.xml><?xml version="1.0" encoding="utf-8"?>
+<file path=ppt/charts/chart19.xml><?xml version="1.0" encoding="utf-8"?>
 <c:chartSpace xmlns:c="http://schemas.openxmlformats.org/drawingml/2006/chart" xmlns:a="http://schemas.openxmlformats.org/drawingml/2006/main" xmlns:r="http://schemas.openxmlformats.org/officeDocument/2006/relationships">
   <c:date1904 val="0"/>
   <c:roundedCorners val="1"/>
@@ -1230,19 +1230,19 @@
                     <c:v>Early Life…</c:v>
                   </c:pt>
                   <c:pt idx="1">
-                    <c:v>Academic E…</c:v>
+                    <c:v>The 1992 W…</c:v>
                   </c:pt>
                   <c:pt idx="2">
-                    <c:v>Political …</c:v>
+                    <c:v>Philanthro…</c:v>
                   </c:pt>
                   <c:pt idx="3">
-                    <c:v>Leadership…</c:v>
+                    <c:v>Entry into…</c:v>
                   </c:pt>
                   <c:pt idx="4">
-                    <c:v>Role in Pa…</c:v>
+                    <c:v>Tenure as …</c:v>
                   </c:pt>
                   <c:pt idx="5">
-                    <c:v>Legacy and…</c:v>
+                    <c:v>Post-Premi…</c:v>
                   </c:pt>
                 </c:lvl>
               </c:multiLvlStrCache>
@@ -1255,22 +1255,22 @@
                 <c:formatCode>General</c:formatCode>
                 <c:ptCount val="6"/>
                 <c:pt idx="0">
-                  <c:v>4</c:v>
+                  <c:v>5</c:v>
                 </c:pt>
                 <c:pt idx="1">
-                  <c:v>4</c:v>
+                  <c:v>5</c:v>
                 </c:pt>
                 <c:pt idx="2">
-                  <c:v>4</c:v>
+                  <c:v>5</c:v>
                 </c:pt>
                 <c:pt idx="3">
-                  <c:v>4</c:v>
+                  <c:v>5</c:v>
                 </c:pt>
                 <c:pt idx="4">
-                  <c:v>4</c:v>
+                  <c:v>5</c:v>
                 </c:pt>
                 <c:pt idx="5">
-                  <c:v>4</c:v>
+                  <c:v>5</c:v>
                 </c:pt>
               </c:numCache>
             </c:numRef>
@@ -1423,7 +1423,7 @@
 </c:chartSpace>
 </file>
 
-<file path=ppt/charts/chart5.xml><?xml version="1.0" encoding="utf-8"?>
+<file path=ppt/charts/chart20.xml><?xml version="1.0" encoding="utf-8"?>
 <c:chartSpace xmlns:c="http://schemas.openxmlformats.org/drawingml/2006/chart" xmlns:a="http://schemas.openxmlformats.org/drawingml/2006/main" xmlns:r="http://schemas.openxmlformats.org/officeDocument/2006/relationships">
   <c:date1904 val="0"/>
   <c:roundedCorners val="1"/>
@@ -1556,19 +1556,19 @@
                     <c:v>Early Life…</c:v>
                   </c:pt>
                   <c:pt idx="1">
-                    <c:v>Academic E…</c:v>
+                    <c:v>The 1992 W…</c:v>
                   </c:pt>
                   <c:pt idx="2">
-                    <c:v>Political …</c:v>
+                    <c:v>Philanthro…</c:v>
                   </c:pt>
                   <c:pt idx="3">
-                    <c:v>Leadership…</c:v>
+                    <c:v>Entry into…</c:v>
                   </c:pt>
                   <c:pt idx="4">
-                    <c:v>Role in Pa…</c:v>
+                    <c:v>Tenure as …</c:v>
                   </c:pt>
                   <c:pt idx="5">
-                    <c:v>Legacy and…</c:v>
+                    <c:v>Post-Premi…</c:v>
                   </c:pt>
                 </c:lvl>
               </c:multiLvlStrCache>
@@ -1581,22 +1581,22 @@
                 <c:formatCode>General</c:formatCode>
                 <c:ptCount val="6"/>
                 <c:pt idx="0">
-                  <c:v>4</c:v>
+                  <c:v>5</c:v>
                 </c:pt>
                 <c:pt idx="1">
-                  <c:v>4</c:v>
+                  <c:v>5</c:v>
                 </c:pt>
                 <c:pt idx="2">
-                  <c:v>4</c:v>
+                  <c:v>5</c:v>
                 </c:pt>
                 <c:pt idx="3">
-                  <c:v>4</c:v>
+                  <c:v>5</c:v>
                 </c:pt>
                 <c:pt idx="4">
-                  <c:v>4</c:v>
+                  <c:v>5</c:v>
                 </c:pt>
                 <c:pt idx="5">
-                  <c:v>4</c:v>
+                  <c:v>5</c:v>
                 </c:pt>
               </c:numCache>
             </c:numRef>
@@ -3633,7 +3633,7 @@
                 <a:ea typeface="Aptos Display" pitchFamily="34" charset="-122"/>
                 <a:cs typeface="Aptos Display" pitchFamily="34" charset="-120"/>
               </a:rPr>
-              <a:t>Quaid-e-Azam: The Architect of Pakistan</a:t>
+              <a:t>Imran Khan: Cricket Icon to Political Leader</a:t>
             </a:r>
             <a:endParaRPr lang="en-US" sz="2800" dirty="0"/>
           </a:p>
@@ -3674,7 +3674,7 @@
                 <a:ea typeface="Aptos" pitchFamily="34" charset="-122"/>
                 <a:cs typeface="Aptos" pitchFamily="34" charset="-120"/>
               </a:rPr>
-              <a:t>A Comprehensive Overview of His Life and Legacy</a:t>
+              <a:t>The Life, Legacy, and Political Journey of Pakistan's 22nd Prime Minister</a:t>
             </a:r>
             <a:endParaRPr lang="en-US" sz="1500" dirty="0"/>
           </a:p>
@@ -3930,7 +3930,7 @@
                 <a:ea typeface="Aptos" pitchFamily="34" charset="-122"/>
                 <a:cs typeface="Aptos" pitchFamily="34" charset="-120"/>
               </a:rPr>
-              <a:t>The presentation also highlights several emerging developments and opportunities that are likely to shape the future of Quaid-e-Azam: The Architect of Pakistan.</a:t>
+              <a:t>The presentation also highlights several emerging developments and opportunities that are likely to shape the future of Imran Khan: Cricket Icon to Political Leader.</a:t>
             </a:r>
             <a:endParaRPr lang="en-US" sz="1400" dirty="0"/>
           </a:p>
@@ -3988,7 +3988,7 @@
                 <a:ea typeface="Aptos" pitchFamily="34" charset="-122"/>
                 <a:cs typeface="Aptos" pitchFamily="34" charset="-120"/>
               </a:rPr>
-              <a:t>In terms of benefits, Quaid-e-Azam: The Architect of Pakistan offers improved efficiency, better decision-making, enhanced clarity, and stronger strategic alignment.</a:t>
+              <a:t>In terms of benefits, Imran Khan: Cricket Icon to Political Leader offers improved efficiency, better decision-making, enhanced clarity, and stronger strategic alignment.</a:t>
             </a:r>
             <a:endParaRPr lang="en-US" sz="1400" dirty="0"/>
           </a:p>
@@ -4429,7 +4429,7 @@
                 <a:ea typeface="Aptos" pitchFamily="34" charset="-122"/>
                 <a:cs typeface="Aptos" pitchFamily="34" charset="-120"/>
               </a:rPr>
-              <a:t>Overall, Quaid-e-Azam: The Architect of Pakistan is a topic of lasting importance, and the insights presented here serve as a practical reference for further exploration.</a:t>
+              <a:t>Overall, Imran Khan: Cricket Icon to Political Leader is a topic of lasting importance, and the insights presented here serve as a practical reference for further exploration.</a:t>
             </a:r>
             <a:endParaRPr lang="en-US" sz="1400" dirty="0"/>
           </a:p>
@@ -4783,7 +4783,7 @@
                 <a:ea typeface="Aptos" pitchFamily="34" charset="-122"/>
                 <a:cs typeface="Aptos" pitchFamily="34" charset="-120"/>
               </a:rPr>
-              <a:t>In summary, this presentation delivers a complete, structured, and insightful overview of Quaid-e-Azam: The Architect of Pakistan with clarity, depth, and relevance.</a:t>
+              <a:t>In summary, this presentation delivers a complete, structured, and insightful overview of Imran Khan: Cricket Icon to Political Leader with clarity, depth, and relevance.</a:t>
             </a:r>
             <a:endParaRPr lang="en-US" sz="1400" dirty="0"/>
           </a:p>
@@ -5306,7 +5306,7 @@
                 <a:ea typeface="Aptos Display" pitchFamily="34" charset="-122"/>
                 <a:cs typeface="Aptos Display" pitchFamily="34" charset="-120"/>
               </a:rPr>
-              <a:t>Early Life and Family</a:t>
+              <a:t>Early Life and Cricket Career</a:t>
             </a:r>
             <a:endParaRPr lang="en-US" sz="2400" dirty="0"/>
           </a:p>
@@ -5422,7 +5422,7 @@
                 <a:ea typeface="Aptos" pitchFamily="34" charset="-122"/>
                 <a:cs typeface="Aptos" pitchFamily="34" charset="-120"/>
               </a:rPr>
-              <a:t>Born 25 December 1876 in Karachi</a:t>
+              <a:t>Born in Lahore, Pakistan, in 1952 to an affluent Pashtun family</a:t>
             </a:r>
             <a:endParaRPr lang="en-US" sz="1400" dirty="0"/>
           </a:p>
@@ -5515,7 +5515,7 @@
                 <a:ea typeface="Aptos" pitchFamily="34" charset="-122"/>
                 <a:cs typeface="Aptos" pitchFamily="34" charset="-120"/>
               </a:rPr>
-              <a:t>Born into a prosperous Parsi family</a:t>
+              <a:t>Educated at Aitchison College Lahore and Keble College, Oxford</a:t>
             </a:r>
             <a:endParaRPr lang="en-US" sz="1400" dirty="0"/>
           </a:p>
@@ -5608,7 +5608,7 @@
                 <a:ea typeface="Aptos" pitchFamily="34" charset="-122"/>
                 <a:cs typeface="Aptos" pitchFamily="34" charset="-120"/>
               </a:rPr>
-              <a:t>Early schooling in local schools</a:t>
+              <a:t>Made international debut for the Pakistan national cricket team in 1971</a:t>
             </a:r>
             <a:endParaRPr lang="en-US" sz="1400" dirty="0"/>
           </a:p>
@@ -5701,7 +5701,7 @@
                 <a:ea typeface="Aptos" pitchFamily="34" charset="-122"/>
                 <a:cs typeface="Aptos" pitchFamily="34" charset="-120"/>
               </a:rPr>
-              <a:t>Family influence on his values</a:t>
+              <a:t>Emerged as one of the world's premier fast bowlers and all-rounders</a:t>
             </a:r>
             <a:endParaRPr lang="en-US" sz="1400" dirty="0"/>
           </a:p>
@@ -5709,7 +5709,100 @@
       </p:sp>
       <p:sp>
         <p:nvSpPr>
-          <p:cNvPr id="16" name="Text 14"/>
+          <p:cNvPr id="16" name="Shape 14"/>
+          <p:cNvSpPr/>
+          <p:nvPr/>
+        </p:nvSpPr>
+        <p:spPr>
+          <a:xfrm>
+            <a:off x="640080" y="3840480"/>
+            <a:ext cx="10927080" cy="548640"/>
+          </a:xfrm>
+          <a:prstGeom prst="roundRect">
+            <a:avLst>
+              <a:gd name="adj" fmla="val 13333"/>
+            </a:avLst>
+          </a:prstGeom>
+          <a:solidFill>
+            <a:srgbClr val="EFF6FF"/>
+          </a:solidFill>
+          <a:ln w="6350">
+            <a:solidFill>
+              <a:srgbClr val="E2E8F0"/>
+            </a:solidFill>
+            <a:prstDash val="solid"/>
+          </a:ln>
+        </p:spPr>
+      </p:sp>
+      <p:sp>
+        <p:nvSpPr>
+          <p:cNvPr id="17" name="Shape 15"/>
+          <p:cNvSpPr/>
+          <p:nvPr/>
+        </p:nvSpPr>
+        <p:spPr>
+          <a:xfrm>
+            <a:off x="841248" y="4023360"/>
+            <a:ext cx="109728" cy="109728"/>
+          </a:xfrm>
+          <a:prstGeom prst="ellipse">
+            <a:avLst/>
+          </a:prstGeom>
+          <a:solidFill>
+            <a:srgbClr val="2563EB"/>
+          </a:solidFill>
+          <a:ln w="6350">
+            <a:solidFill>
+              <a:srgbClr val="2563EB"/>
+            </a:solidFill>
+            <a:prstDash val="solid"/>
+          </a:ln>
+        </p:spPr>
+      </p:sp>
+      <p:sp>
+        <p:nvSpPr>
+          <p:cNvPr id="18" name="Text 16"/>
+          <p:cNvSpPr/>
+          <p:nvPr/>
+        </p:nvSpPr>
+        <p:spPr>
+          <a:xfrm>
+            <a:off x="1097280" y="3886200"/>
+            <a:ext cx="10058400" cy="457200"/>
+          </a:xfrm>
+          <a:prstGeom prst="rect">
+            <a:avLst/>
+          </a:prstGeom>
+          <a:noFill/>
+          <a:ln/>
+        </p:spPr>
+        <p:txBody>
+          <a:bodyPr wrap="square" lIns="0" tIns="0" rIns="0" bIns="0" rtlCol="0" anchor="ctr">
+            <a:normAutofit/>
+          </a:bodyPr>
+          <a:lstStyle/>
+          <a:p>
+            <a:pPr algn="l" indent="0" marL="0">
+              <a:buNone/>
+            </a:pPr>
+            <a:r>
+              <a:rPr lang="en-US" sz="1400" dirty="0">
+                <a:solidFill>
+                  <a:srgbClr val="334155"/>
+                </a:solidFill>
+                <a:latin typeface="Aptos" pitchFamily="34" charset="0"/>
+                <a:ea typeface="Aptos" pitchFamily="34" charset="-122"/>
+                <a:cs typeface="Aptos" pitchFamily="34" charset="-120"/>
+              </a:rPr>
+              <a:t>Served as team captain during Pakistan cricket's golden era</a:t>
+            </a:r>
+            <a:endParaRPr lang="en-US" sz="1400" dirty="0"/>
+          </a:p>
+        </p:txBody>
+      </p:sp>
+      <p:sp>
+        <p:nvSpPr>
+          <p:cNvPr id="19" name="Text 17"/>
           <p:cNvSpPr/>
           <p:nvPr/>
         </p:nvSpPr>
@@ -5748,7 +5841,7 @@
       </p:sp>
       <p:sp>
         <p:nvSpPr>
-          <p:cNvPr id="17" name="Text 15"/>
+          <p:cNvPr id="20" name="Text 18"/>
           <p:cNvSpPr/>
           <p:nvPr/>
         </p:nvSpPr>
@@ -5852,7 +5945,7 @@
                 <a:ea typeface="Aptos Display" pitchFamily="34" charset="-122"/>
                 <a:cs typeface="Aptos Display" pitchFamily="34" charset="-120"/>
               </a:rPr>
-              <a:t>Academic Excellence</a:t>
+              <a:t>The 1992 World Cup Triumph</a:t>
             </a:r>
             <a:endParaRPr lang="en-US" sz="2400" dirty="0"/>
           </a:p>
@@ -5968,7 +6061,7 @@
                 <a:ea typeface="Aptos" pitchFamily="34" charset="-122"/>
                 <a:cs typeface="Aptos" pitchFamily="34" charset="-120"/>
               </a:rPr>
-              <a:t>Studied at St. Patrick's High School</a:t>
+              <a:t>Led Pakistan to its first and only ICC Cricket World Cup victory in 1992</a:t>
             </a:r>
             <a:endParaRPr lang="en-US" sz="1400" dirty="0"/>
           </a:p>
@@ -6061,7 +6154,7 @@
                 <a:ea typeface="Aptos" pitchFamily="34" charset="-122"/>
                 <a:cs typeface="Aptos" pitchFamily="34" charset="-120"/>
               </a:rPr>
-              <a:t>Graduated from the University of Cambridge</a:t>
+              <a:t>Rallied the team with his famous 'cornered tigers' speech</a:t>
             </a:r>
             <a:endParaRPr lang="en-US" sz="1400" dirty="0"/>
           </a:p>
@@ -6154,7 +6247,7 @@
                 <a:ea typeface="Aptos" pitchFamily="34" charset="-122"/>
                 <a:cs typeface="Aptos" pitchFamily="34" charset="-120"/>
               </a:rPr>
-              <a:t>Earned LLB from Lincoln's Inn</a:t>
+              <a:t>Scored a crucial 72 runs in the final against England</a:t>
             </a:r>
             <a:endParaRPr lang="en-US" sz="1400" dirty="0"/>
           </a:p>
@@ -6247,7 +6340,7 @@
                 <a:ea typeface="Aptos" pitchFamily="34" charset="-122"/>
                 <a:cs typeface="Aptos" pitchFamily="34" charset="-120"/>
               </a:rPr>
-              <a:t>Returned to practice law in Bombay</a:t>
+              <a:t>Retired from international cricket immediately following the victory</a:t>
             </a:r>
             <a:endParaRPr lang="en-US" sz="1400" dirty="0"/>
           </a:p>
@@ -6255,7 +6348,100 @@
       </p:sp>
       <p:sp>
         <p:nvSpPr>
-          <p:cNvPr id="16" name="Text 14"/>
+          <p:cNvPr id="16" name="Shape 14"/>
+          <p:cNvSpPr/>
+          <p:nvPr/>
+        </p:nvSpPr>
+        <p:spPr>
+          <a:xfrm>
+            <a:off x="640080" y="3840480"/>
+            <a:ext cx="10927080" cy="548640"/>
+          </a:xfrm>
+          <a:prstGeom prst="roundRect">
+            <a:avLst>
+              <a:gd name="adj" fmla="val 13333"/>
+            </a:avLst>
+          </a:prstGeom>
+          <a:solidFill>
+            <a:srgbClr val="EFF6FF"/>
+          </a:solidFill>
+          <a:ln w="6350">
+            <a:solidFill>
+              <a:srgbClr val="E2E8F0"/>
+            </a:solidFill>
+            <a:prstDash val="solid"/>
+          </a:ln>
+        </p:spPr>
+      </p:sp>
+      <p:sp>
+        <p:nvSpPr>
+          <p:cNvPr id="17" name="Shape 15"/>
+          <p:cNvSpPr/>
+          <p:nvPr/>
+        </p:nvSpPr>
+        <p:spPr>
+          <a:xfrm>
+            <a:off x="841248" y="4023360"/>
+            <a:ext cx="109728" cy="109728"/>
+          </a:xfrm>
+          <a:prstGeom prst="ellipse">
+            <a:avLst/>
+          </a:prstGeom>
+          <a:solidFill>
+            <a:srgbClr val="2563EB"/>
+          </a:solidFill>
+          <a:ln w="6350">
+            <a:solidFill>
+              <a:srgbClr val="2563EB"/>
+            </a:solidFill>
+            <a:prstDash val="solid"/>
+          </a:ln>
+        </p:spPr>
+      </p:sp>
+      <p:sp>
+        <p:nvSpPr>
+          <p:cNvPr id="18" name="Text 16"/>
+          <p:cNvSpPr/>
+          <p:nvPr/>
+        </p:nvSpPr>
+        <p:spPr>
+          <a:xfrm>
+            <a:off x="1097280" y="3886200"/>
+            <a:ext cx="10058400" cy="457200"/>
+          </a:xfrm>
+          <a:prstGeom prst="rect">
+            <a:avLst/>
+          </a:prstGeom>
+          <a:noFill/>
+          <a:ln/>
+        </p:spPr>
+        <p:txBody>
+          <a:bodyPr wrap="square" lIns="0" tIns="0" rIns="0" bIns="0" rtlCol="0" anchor="ctr">
+            <a:normAutofit/>
+          </a:bodyPr>
+          <a:lstStyle/>
+          <a:p>
+            <a:pPr algn="l" indent="0" marL="0">
+              <a:buNone/>
+            </a:pPr>
+            <a:r>
+              <a:rPr lang="en-US" sz="1400" dirty="0">
+                <a:solidFill>
+                  <a:srgbClr val="334155"/>
+                </a:solidFill>
+                <a:latin typeface="Aptos" pitchFamily="34" charset="0"/>
+                <a:ea typeface="Aptos" pitchFamily="34" charset="-122"/>
+                <a:cs typeface="Aptos" pitchFamily="34" charset="-120"/>
+              </a:rPr>
+              <a:t>Cemented his status as an enduring national hero</a:t>
+            </a:r>
+            <a:endParaRPr lang="en-US" sz="1400" dirty="0"/>
+          </a:p>
+        </p:txBody>
+      </p:sp>
+      <p:sp>
+        <p:nvSpPr>
+          <p:cNvPr id="19" name="Text 17"/>
           <p:cNvSpPr/>
           <p:nvPr/>
         </p:nvSpPr>
@@ -6294,7 +6480,7 @@
       </p:sp>
       <p:sp>
         <p:nvSpPr>
-          <p:cNvPr id="17" name="Text 15"/>
+          <p:cNvPr id="20" name="Text 18"/>
           <p:cNvSpPr/>
           <p:nvPr/>
         </p:nvSpPr>
@@ -6398,7 +6584,7 @@
                 <a:ea typeface="Aptos Display" pitchFamily="34" charset="-122"/>
                 <a:cs typeface="Aptos Display" pitchFamily="34" charset="-120"/>
               </a:rPr>
-              <a:t>Political Awakening</a:t>
+              <a:t>Philanthropy and Social Impact</a:t>
             </a:r>
             <a:endParaRPr lang="en-US" sz="2400" dirty="0"/>
           </a:p>
@@ -6514,7 +6700,7 @@
                 <a:ea typeface="Aptos" pitchFamily="34" charset="-122"/>
                 <a:cs typeface="Aptos" pitchFamily="34" charset="-120"/>
               </a:rPr>
-              <a:t>Joined Indian National Congress in 1906</a:t>
+              <a:t>Founded Shaukat Khanum Memorial Cancer Hospital in 1994</a:t>
             </a:r>
             <a:endParaRPr lang="en-US" sz="1400" dirty="0"/>
           </a:p>
@@ -6607,7 +6793,7 @@
                 <a:ea typeface="Aptos" pitchFamily="34" charset="-122"/>
                 <a:cs typeface="Aptos" pitchFamily="34" charset="-120"/>
               </a:rPr>
-              <a:t>Shifted to Muslim League in 1930</a:t>
+              <a:t>Provided free, high-quality cancer care to underprivileged patients</a:t>
             </a:r>
             <a:endParaRPr lang="en-US" sz="1400" dirty="0"/>
           </a:p>
@@ -6700,7 +6886,7 @@
                 <a:ea typeface="Aptos" pitchFamily="34" charset="-122"/>
                 <a:cs typeface="Aptos" pitchFamily="34" charset="-120"/>
               </a:rPr>
-              <a:t>Advocated for Muslim rights</a:t>
+              <a:t>Established Namal University in Mianwali in 2008</a:t>
             </a:r>
             <a:endParaRPr lang="en-US" sz="1400" dirty="0"/>
           </a:p>
@@ -6793,7 +6979,7 @@
                 <a:ea typeface="Aptos" pitchFamily="34" charset="-122"/>
                 <a:cs typeface="Aptos" pitchFamily="34" charset="-120"/>
               </a:rPr>
-              <a:t>Delivered key speeches in Bombay</a:t>
+              <a:t>Focused on providing affordable higher education to rural youth</a:t>
             </a:r>
             <a:endParaRPr lang="en-US" sz="1400" dirty="0"/>
           </a:p>
@@ -6801,7 +6987,100 @@
       </p:sp>
       <p:sp>
         <p:nvSpPr>
-          <p:cNvPr id="16" name="Text 14"/>
+          <p:cNvPr id="16" name="Shape 14"/>
+          <p:cNvSpPr/>
+          <p:nvPr/>
+        </p:nvSpPr>
+        <p:spPr>
+          <a:xfrm>
+            <a:off x="640080" y="3840480"/>
+            <a:ext cx="10927080" cy="548640"/>
+          </a:xfrm>
+          <a:prstGeom prst="roundRect">
+            <a:avLst>
+              <a:gd name="adj" fmla="val 13333"/>
+            </a:avLst>
+          </a:prstGeom>
+          <a:solidFill>
+            <a:srgbClr val="EFF6FF"/>
+          </a:solidFill>
+          <a:ln w="6350">
+            <a:solidFill>
+              <a:srgbClr val="E2E8F0"/>
+            </a:solidFill>
+            <a:prstDash val="solid"/>
+          </a:ln>
+        </p:spPr>
+      </p:sp>
+      <p:sp>
+        <p:nvSpPr>
+          <p:cNvPr id="17" name="Shape 15"/>
+          <p:cNvSpPr/>
+          <p:nvPr/>
+        </p:nvSpPr>
+        <p:spPr>
+          <a:xfrm>
+            <a:off x="841248" y="4023360"/>
+            <a:ext cx="109728" cy="109728"/>
+          </a:xfrm>
+          <a:prstGeom prst="ellipse">
+            <a:avLst/>
+          </a:prstGeom>
+          <a:solidFill>
+            <a:srgbClr val="2563EB"/>
+          </a:solidFill>
+          <a:ln w="6350">
+            <a:solidFill>
+              <a:srgbClr val="2563EB"/>
+            </a:solidFill>
+            <a:prstDash val="solid"/>
+          </a:ln>
+        </p:spPr>
+      </p:sp>
+      <p:sp>
+        <p:nvSpPr>
+          <p:cNvPr id="18" name="Text 16"/>
+          <p:cNvSpPr/>
+          <p:nvPr/>
+        </p:nvSpPr>
+        <p:spPr>
+          <a:xfrm>
+            <a:off x="1097280" y="3886200"/>
+            <a:ext cx="10058400" cy="457200"/>
+          </a:xfrm>
+          <a:prstGeom prst="rect">
+            <a:avLst/>
+          </a:prstGeom>
+          <a:noFill/>
+          <a:ln/>
+        </p:spPr>
+        <p:txBody>
+          <a:bodyPr wrap="square" lIns="0" tIns="0" rIns="0" bIns="0" rtlCol="0" anchor="ctr">
+            <a:normAutofit/>
+          </a:bodyPr>
+          <a:lstStyle/>
+          <a:p>
+            <a:pPr algn="l" indent="0" marL="0">
+              <a:buNone/>
+            </a:pPr>
+            <a:r>
+              <a:rPr lang="en-US" sz="1400" dirty="0">
+                <a:solidFill>
+                  <a:srgbClr val="334155"/>
+                </a:solidFill>
+                <a:latin typeface="Aptos" pitchFamily="34" charset="0"/>
+                <a:ea typeface="Aptos" pitchFamily="34" charset="-122"/>
+                <a:cs typeface="Aptos" pitchFamily="34" charset="-120"/>
+              </a:rPr>
+              <a:t>Built widespread trust through transparent charitable endeavors</a:t>
+            </a:r>
+            <a:endParaRPr lang="en-US" sz="1400" dirty="0"/>
+          </a:p>
+        </p:txBody>
+      </p:sp>
+      <p:sp>
+        <p:nvSpPr>
+          <p:cNvPr id="19" name="Text 17"/>
           <p:cNvSpPr/>
           <p:nvPr/>
         </p:nvSpPr>
@@ -6840,7 +7119,7 @@
       </p:sp>
       <p:sp>
         <p:nvSpPr>
-          <p:cNvPr id="17" name="Text 15"/>
+          <p:cNvPr id="20" name="Text 18"/>
           <p:cNvSpPr/>
           <p:nvPr/>
         </p:nvSpPr>
@@ -6944,7 +7223,7 @@
                 <a:ea typeface="Aptos Display" pitchFamily="34" charset="-122"/>
                 <a:cs typeface="Aptos Display" pitchFamily="34" charset="-120"/>
               </a:rPr>
-              <a:t>Leadership of the Muslim League</a:t>
+              <a:t>Entry into Politics and Rise of PTI</a:t>
             </a:r>
             <a:endParaRPr lang="en-US" sz="2400" dirty="0"/>
           </a:p>
@@ -7060,7 +7339,7 @@
                 <a:ea typeface="Aptos" pitchFamily="34" charset="-122"/>
                 <a:cs typeface="Aptos" pitchFamily="34" charset="-120"/>
               </a:rPr>
-              <a:t>Consolidated party structure nationwide</a:t>
+              <a:t>Founded the political party Pakistan Tehreek-e-Insaf (PTI) in 1996</a:t>
             </a:r>
             <a:endParaRPr lang="en-US" sz="1400" dirty="0"/>
           </a:p>
@@ -7153,7 +7432,7 @@
                 <a:ea typeface="Aptos" pitchFamily="34" charset="-122"/>
                 <a:cs typeface="Aptos" pitchFamily="34" charset="-120"/>
               </a:rPr>
-              <a:t>Introduced Lahore Resolution 1940</a:t>
+              <a:t>Campaigned on anti-corruption, rule of law, and social justice</a:t>
             </a:r>
             <a:endParaRPr lang="en-US" sz="1400" dirty="0"/>
           </a:p>
@@ -7246,7 +7525,7 @@
                 <a:ea typeface="Aptos" pitchFamily="34" charset="-122"/>
                 <a:cs typeface="Aptos" pitchFamily="34" charset="-120"/>
               </a:rPr>
-              <a:t>Led 1946 elections with massive support</a:t>
+              <a:t>Spent over a decade as a minor political player in parliament</a:t>
             </a:r>
             <a:endParaRPr lang="en-US" sz="1400" dirty="0"/>
           </a:p>
@@ -7339,7 +7618,7 @@
                 <a:ea typeface="Aptos" pitchFamily="34" charset="-122"/>
                 <a:cs typeface="Aptos" pitchFamily="34" charset="-120"/>
               </a:rPr>
-              <a:t>Negotiated with British authorities</a:t>
+              <a:t>Achieved a major political breakthrough with mass rallies in 2011</a:t>
             </a:r>
             <a:endParaRPr lang="en-US" sz="1400" dirty="0"/>
           </a:p>
@@ -7347,7 +7626,100 @@
       </p:sp>
       <p:sp>
         <p:nvSpPr>
-          <p:cNvPr id="16" name="Text 14"/>
+          <p:cNvPr id="16" name="Shape 14"/>
+          <p:cNvSpPr/>
+          <p:nvPr/>
+        </p:nvSpPr>
+        <p:spPr>
+          <a:xfrm>
+            <a:off x="640080" y="3840480"/>
+            <a:ext cx="10927080" cy="548640"/>
+          </a:xfrm>
+          <a:prstGeom prst="roundRect">
+            <a:avLst>
+              <a:gd name="adj" fmla="val 13333"/>
+            </a:avLst>
+          </a:prstGeom>
+          <a:solidFill>
+            <a:srgbClr val="EFF6FF"/>
+          </a:solidFill>
+          <a:ln w="6350">
+            <a:solidFill>
+              <a:srgbClr val="E2E8F0"/>
+            </a:solidFill>
+            <a:prstDash val="solid"/>
+          </a:ln>
+        </p:spPr>
+      </p:sp>
+      <p:sp>
+        <p:nvSpPr>
+          <p:cNvPr id="17" name="Shape 15"/>
+          <p:cNvSpPr/>
+          <p:nvPr/>
+        </p:nvSpPr>
+        <p:spPr>
+          <a:xfrm>
+            <a:off x="841248" y="4023360"/>
+            <a:ext cx="109728" cy="109728"/>
+          </a:xfrm>
+          <a:prstGeom prst="ellipse">
+            <a:avLst/>
+          </a:prstGeom>
+          <a:solidFill>
+            <a:srgbClr val="2563EB"/>
+          </a:solidFill>
+          <a:ln w="6350">
+            <a:solidFill>
+              <a:srgbClr val="2563EB"/>
+            </a:solidFill>
+            <a:prstDash val="solid"/>
+          </a:ln>
+        </p:spPr>
+      </p:sp>
+      <p:sp>
+        <p:nvSpPr>
+          <p:cNvPr id="18" name="Text 16"/>
+          <p:cNvSpPr/>
+          <p:nvPr/>
+        </p:nvSpPr>
+        <p:spPr>
+          <a:xfrm>
+            <a:off x="1097280" y="3886200"/>
+            <a:ext cx="10058400" cy="457200"/>
+          </a:xfrm>
+          <a:prstGeom prst="rect">
+            <a:avLst/>
+          </a:prstGeom>
+          <a:noFill/>
+          <a:ln/>
+        </p:spPr>
+        <p:txBody>
+          <a:bodyPr wrap="square" lIns="0" tIns="0" rIns="0" bIns="0" rtlCol="0" anchor="ctr">
+            <a:normAutofit/>
+          </a:bodyPr>
+          <a:lstStyle/>
+          <a:p>
+            <a:pPr algn="l" indent="0" marL="0">
+              <a:buNone/>
+            </a:pPr>
+            <a:r>
+              <a:rPr lang="en-US" sz="1400" dirty="0">
+                <a:solidFill>
+                  <a:srgbClr val="334155"/>
+                </a:solidFill>
+                <a:latin typeface="Aptos" pitchFamily="34" charset="0"/>
+                <a:ea typeface="Aptos" pitchFamily="34" charset="-122"/>
+                <a:cs typeface="Aptos" pitchFamily="34" charset="-120"/>
+              </a:rPr>
+              <a:t>Mobilized youth and urban middle-class voters across the country</a:t>
+            </a:r>
+            <a:endParaRPr lang="en-US" sz="1400" dirty="0"/>
+          </a:p>
+        </p:txBody>
+      </p:sp>
+      <p:sp>
+        <p:nvSpPr>
+          <p:cNvPr id="19" name="Text 17"/>
           <p:cNvSpPr/>
           <p:nvPr/>
         </p:nvSpPr>
@@ -7386,7 +7758,7 @@
       </p:sp>
       <p:sp>
         <p:nvSpPr>
-          <p:cNvPr id="17" name="Text 15"/>
+          <p:cNvPr id="20" name="Text 18"/>
           <p:cNvSpPr/>
           <p:nvPr/>
         </p:nvSpPr>
@@ -7490,7 +7862,7 @@
                 <a:ea typeface="Aptos Display" pitchFamily="34" charset="-122"/>
                 <a:cs typeface="Aptos Display" pitchFamily="34" charset="-120"/>
               </a:rPr>
-              <a:t>Role in Partition</a:t>
+              <a:t>Tenure as Prime Minister (2018–2022)</a:t>
             </a:r>
             <a:endParaRPr lang="en-US" sz="2400" dirty="0"/>
           </a:p>
@@ -7606,7 +7978,7 @@
                 <a:ea typeface="Aptos" pitchFamily="34" charset="-122"/>
                 <a:cs typeface="Aptos" pitchFamily="34" charset="-120"/>
               </a:rPr>
-              <a:t>Facilitated 1947 Independence Plan</a:t>
+              <a:t>Elected as the 22nd Prime Minister of Pakistan in August 2018</a:t>
             </a:r>
             <a:endParaRPr lang="en-US" sz="1400" dirty="0"/>
           </a:p>
@@ -7699,7 +8071,7 @@
                 <a:ea typeface="Aptos" pitchFamily="34" charset="-122"/>
                 <a:cs typeface="Aptos" pitchFamily="34" charset="-120"/>
               </a:rPr>
-              <a:t>Negotiated with Viceroy Mountbatten</a:t>
+              <a:t>Launched the 'Ehsaas' social safety and poverty alleviation program</a:t>
             </a:r>
             <a:endParaRPr lang="en-US" sz="1400" dirty="0"/>
           </a:p>
@@ -7792,7 +8164,7 @@
                 <a:ea typeface="Aptos" pitchFamily="34" charset="-122"/>
                 <a:cs typeface="Aptos" pitchFamily="34" charset="-120"/>
               </a:rPr>
-              <a:t>Delivered farewell address to Muslims</a:t>
+              <a:t>Initiated the 10 Billion Tree Tsunami environmental initiative</a:t>
             </a:r>
             <a:endParaRPr lang="en-US" sz="1400" dirty="0"/>
           </a:p>
@@ -7885,7 +8257,7 @@
                 <a:ea typeface="Aptos" pitchFamily="34" charset="-122"/>
                 <a:cs typeface="Aptos" pitchFamily="34" charset="-120"/>
               </a:rPr>
-              <a:t>Established Pakistan’s foundational principles</a:t>
+              <a:t>Managed the national response to the COVID-19 pandemic</a:t>
             </a:r>
             <a:endParaRPr lang="en-US" sz="1400" dirty="0"/>
           </a:p>
@@ -7893,7 +8265,100 @@
       </p:sp>
       <p:sp>
         <p:nvSpPr>
-          <p:cNvPr id="16" name="Text 14"/>
+          <p:cNvPr id="16" name="Shape 14"/>
+          <p:cNvSpPr/>
+          <p:nvPr/>
+        </p:nvSpPr>
+        <p:spPr>
+          <a:xfrm>
+            <a:off x="640080" y="3840480"/>
+            <a:ext cx="10927080" cy="548640"/>
+          </a:xfrm>
+          <a:prstGeom prst="roundRect">
+            <a:avLst>
+              <a:gd name="adj" fmla="val 13333"/>
+            </a:avLst>
+          </a:prstGeom>
+          <a:solidFill>
+            <a:srgbClr val="EFF6FF"/>
+          </a:solidFill>
+          <a:ln w="6350">
+            <a:solidFill>
+              <a:srgbClr val="E2E8F0"/>
+            </a:solidFill>
+            <a:prstDash val="solid"/>
+          </a:ln>
+        </p:spPr>
+      </p:sp>
+      <p:sp>
+        <p:nvSpPr>
+          <p:cNvPr id="17" name="Shape 15"/>
+          <p:cNvSpPr/>
+          <p:nvPr/>
+        </p:nvSpPr>
+        <p:spPr>
+          <a:xfrm>
+            <a:off x="841248" y="4023360"/>
+            <a:ext cx="109728" cy="109728"/>
+          </a:xfrm>
+          <a:prstGeom prst="ellipse">
+            <a:avLst/>
+          </a:prstGeom>
+          <a:solidFill>
+            <a:srgbClr val="2563EB"/>
+          </a:solidFill>
+          <a:ln w="6350">
+            <a:solidFill>
+              <a:srgbClr val="2563EB"/>
+            </a:solidFill>
+            <a:prstDash val="solid"/>
+          </a:ln>
+        </p:spPr>
+      </p:sp>
+      <p:sp>
+        <p:nvSpPr>
+          <p:cNvPr id="18" name="Text 16"/>
+          <p:cNvSpPr/>
+          <p:nvPr/>
+        </p:nvSpPr>
+        <p:spPr>
+          <a:xfrm>
+            <a:off x="1097280" y="3886200"/>
+            <a:ext cx="10058400" cy="457200"/>
+          </a:xfrm>
+          <a:prstGeom prst="rect">
+            <a:avLst/>
+          </a:prstGeom>
+          <a:noFill/>
+          <a:ln/>
+        </p:spPr>
+        <p:txBody>
+          <a:bodyPr wrap="square" lIns="0" tIns="0" rIns="0" bIns="0" rtlCol="0" anchor="ctr">
+            <a:normAutofit/>
+          </a:bodyPr>
+          <a:lstStyle/>
+          <a:p>
+            <a:pPr algn="l" indent="0" marL="0">
+              <a:buNone/>
+            </a:pPr>
+            <a:r>
+              <a:rPr lang="en-US" sz="1400" dirty="0">
+                <a:solidFill>
+                  <a:srgbClr val="334155"/>
+                </a:solidFill>
+                <a:latin typeface="Aptos" pitchFamily="34" charset="0"/>
+                <a:ea typeface="Aptos" pitchFamily="34" charset="-122"/>
+                <a:cs typeface="Aptos" pitchFamily="34" charset="-120"/>
+              </a:rPr>
+              <a:t>Removed from office via a parliamentary no-confidence vote in April 2022</a:t>
+            </a:r>
+            <a:endParaRPr lang="en-US" sz="1400" dirty="0"/>
+          </a:p>
+        </p:txBody>
+      </p:sp>
+      <p:sp>
+        <p:nvSpPr>
+          <p:cNvPr id="19" name="Text 17"/>
           <p:cNvSpPr/>
           <p:nvPr/>
         </p:nvSpPr>
@@ -7932,7 +8397,7 @@
       </p:sp>
       <p:sp>
         <p:nvSpPr>
-          <p:cNvPr id="17" name="Text 15"/>
+          <p:cNvPr id="20" name="Text 18"/>
           <p:cNvSpPr/>
           <p:nvPr/>
         </p:nvSpPr>
@@ -8036,7 +8501,7 @@
                 <a:ea typeface="Aptos Display" pitchFamily="34" charset="-122"/>
                 <a:cs typeface="Aptos Display" pitchFamily="34" charset="-120"/>
               </a:rPr>
-              <a:t>Legacy and Impact</a:t>
+              <a:t>Post-Premiership and Current Landscape</a:t>
             </a:r>
             <a:endParaRPr lang="en-US" sz="2400" dirty="0"/>
           </a:p>
@@ -8152,7 +8617,7 @@
                 <a:ea typeface="Aptos" pitchFamily="34" charset="-122"/>
                 <a:cs typeface="Aptos" pitchFamily="34" charset="-120"/>
               </a:rPr>
-              <a:t>Founding Father of Pakistan</a:t>
+              <a:t>Led massive public protest rallies demanding early general elections</a:t>
             </a:r>
             <a:endParaRPr lang="en-US" sz="1400" dirty="0"/>
           </a:p>
@@ -8245,7 +8710,7 @@
                 <a:ea typeface="Aptos" pitchFamily="34" charset="-122"/>
                 <a:cs typeface="Aptos" pitchFamily="34" charset="-120"/>
               </a:rPr>
-              <a:t>Legal reforms and constitutional framework</a:t>
+              <a:t>Survived an assassination attempt during a political march in November 2022</a:t>
             </a:r>
             <a:endParaRPr lang="en-US" sz="1400" dirty="0"/>
           </a:p>
@@ -8338,7 +8803,7 @@
                 <a:ea typeface="Aptos" pitchFamily="34" charset="-122"/>
                 <a:cs typeface="Aptos" pitchFamily="34" charset="-120"/>
               </a:rPr>
-              <a:t>National symbols: Quaid-e-Azam Day, Jinnah's portrait</a:t>
+              <a:t>Faced dozens of legal charges and subsequent imprisonment in 2023</a:t>
             </a:r>
             <a:endParaRPr lang="en-US" sz="1400" dirty="0"/>
           </a:p>
@@ -8431,7 +8896,7 @@
                 <a:ea typeface="Aptos" pitchFamily="34" charset="-122"/>
                 <a:cs typeface="Aptos" pitchFamily="34" charset="-120"/>
               </a:rPr>
-              <a:t>Enduring influence on Pakistani politics</a:t>
+              <a:t>Demonstrated continued popular support through independent election candidates</a:t>
             </a:r>
             <a:endParaRPr lang="en-US" sz="1400" dirty="0"/>
           </a:p>
@@ -8439,7 +8904,100 @@
       </p:sp>
       <p:sp>
         <p:nvSpPr>
-          <p:cNvPr id="16" name="Text 14"/>
+          <p:cNvPr id="16" name="Shape 14"/>
+          <p:cNvSpPr/>
+          <p:nvPr/>
+        </p:nvSpPr>
+        <p:spPr>
+          <a:xfrm>
+            <a:off x="640080" y="3840480"/>
+            <a:ext cx="10927080" cy="548640"/>
+          </a:xfrm>
+          <a:prstGeom prst="roundRect">
+            <a:avLst>
+              <a:gd name="adj" fmla="val 13333"/>
+            </a:avLst>
+          </a:prstGeom>
+          <a:solidFill>
+            <a:srgbClr val="EFF6FF"/>
+          </a:solidFill>
+          <a:ln w="6350">
+            <a:solidFill>
+              <a:srgbClr val="E2E8F0"/>
+            </a:solidFill>
+            <a:prstDash val="solid"/>
+          </a:ln>
+        </p:spPr>
+      </p:sp>
+      <p:sp>
+        <p:nvSpPr>
+          <p:cNvPr id="17" name="Shape 15"/>
+          <p:cNvSpPr/>
+          <p:nvPr/>
+        </p:nvSpPr>
+        <p:spPr>
+          <a:xfrm>
+            <a:off x="841248" y="4023360"/>
+            <a:ext cx="109728" cy="109728"/>
+          </a:xfrm>
+          <a:prstGeom prst="ellipse">
+            <a:avLst/>
+          </a:prstGeom>
+          <a:solidFill>
+            <a:srgbClr val="2563EB"/>
+          </a:solidFill>
+          <a:ln w="6350">
+            <a:solidFill>
+              <a:srgbClr val="2563EB"/>
+            </a:solidFill>
+            <a:prstDash val="solid"/>
+          </a:ln>
+        </p:spPr>
+      </p:sp>
+      <p:sp>
+        <p:nvSpPr>
+          <p:cNvPr id="18" name="Text 16"/>
+          <p:cNvSpPr/>
+          <p:nvPr/>
+        </p:nvSpPr>
+        <p:spPr>
+          <a:xfrm>
+            <a:off x="1097280" y="3886200"/>
+            <a:ext cx="10058400" cy="457200"/>
+          </a:xfrm>
+          <a:prstGeom prst="rect">
+            <a:avLst/>
+          </a:prstGeom>
+          <a:noFill/>
+          <a:ln/>
+        </p:spPr>
+        <p:txBody>
+          <a:bodyPr wrap="square" lIns="0" tIns="0" rIns="0" bIns="0" rtlCol="0" anchor="ctr">
+            <a:normAutofit/>
+          </a:bodyPr>
+          <a:lstStyle/>
+          <a:p>
+            <a:pPr algn="l" indent="0" marL="0">
+              <a:buNone/>
+            </a:pPr>
+            <a:r>
+              <a:rPr lang="en-US" sz="1400" dirty="0">
+                <a:solidFill>
+                  <a:srgbClr val="334155"/>
+                </a:solidFill>
+                <a:latin typeface="Aptos" pitchFamily="34" charset="0"/>
+                <a:ea typeface="Aptos" pitchFamily="34" charset="-122"/>
+                <a:cs typeface="Aptos" pitchFamily="34" charset="-120"/>
+              </a:rPr>
+              <a:t>Remains one of the most polarizing and influential figures in modern Pakistan</a:t>
+            </a:r>
+            <a:endParaRPr lang="en-US" sz="1400" dirty="0"/>
+          </a:p>
+        </p:txBody>
+      </p:sp>
+      <p:sp>
+        <p:nvSpPr>
+          <p:cNvPr id="19" name="Text 17"/>
           <p:cNvSpPr/>
           <p:nvPr/>
         </p:nvSpPr>
@@ -8478,7 +9036,7 @@
       </p:sp>
       <p:sp>
         <p:nvSpPr>
-          <p:cNvPr id="17" name="Text 15"/>
+          <p:cNvPr id="20" name="Text 18"/>
           <p:cNvSpPr/>
           <p:nvPr/>
         </p:nvSpPr>
@@ -8674,7 +9232,7 @@
                 <a:ea typeface="Aptos" pitchFamily="34" charset="-122"/>
                 <a:cs typeface="Aptos" pitchFamily="34" charset="-120"/>
               </a:rPr>
-              <a:t>Quaid-e-Azam: The Architect of Pakistan is a comprehensive, multi-dimensional subject carefully structured across 6 thematic sections in this presentation.</a:t>
+              <a:t>Imran Khan: Cricket Icon to Political Leader is a comprehensive, multi-dimensional subject carefully structured across 6 thematic sections in this presentation.</a:t>
             </a:r>
             <a:endParaRPr lang="en-US" sz="1400" dirty="0"/>
           </a:p>
@@ -8732,7 +9290,7 @@
                 <a:ea typeface="Aptos" pitchFamily="34" charset="-122"/>
                 <a:cs typeface="Aptos" pitchFamily="34" charset="-120"/>
               </a:rPr>
-              <a:t>The central theme "A Comprehensive Overview of His Life and Legacy" anchors the entire discussion and provides the reader with a clear and focused direction throughout.</a:t>
+              <a:t>The central theme "The Life, Legacy, and Political Journey of Pakistan's 22nd Prime Minister" anchors the entire discussion and provides the reader with a clear and focused direction throughout.</a:t>
             </a:r>
             <a:endParaRPr lang="en-US" sz="1400" dirty="0"/>
           </a:p>
@@ -9115,7 +9673,7 @@
                 <a:ea typeface="Aptos" pitchFamily="34" charset="-122"/>
                 <a:cs typeface="Aptos" pitchFamily="34" charset="-120"/>
               </a:rPr>
-              <a:t>Together, these sections cover approximately 24 key bullet points highlighting the most important insights and takeaways.</a:t>
+              <a:t>Together, these sections cover approximately 30 key bullet points highlighting the most important insights and takeaways.</a:t>
             </a:r>
             <a:endParaRPr lang="en-US" sz="1400" dirty="0"/>
           </a:p>
@@ -9144,7 +9702,7 @@
                 <a:ea typeface="Aptos" pitchFamily="34" charset="-122"/>
                 <a:cs typeface="Aptos" pitchFamily="34" charset="-120"/>
               </a:rPr>
-              <a:t>From a strategic perspective, Quaid-e-Azam: The Architect of Pakistan plays a significant role in shaping outcomes, influencing decisions, and driving measurable value.</a:t>
+              <a:t>From a strategic perspective, Imran Khan: Cricket Icon to Political Leader plays a significant role in shaping outcomes, influencing decisions, and driving measurable value.</a:t>
             </a:r>
             <a:endParaRPr lang="en-US" sz="1400" dirty="0"/>
           </a:p>
@@ -9202,7 +9760,7 @@
                 <a:ea typeface="Aptos" pitchFamily="34" charset="-122"/>
                 <a:cs typeface="Aptos" pitchFamily="34" charset="-120"/>
               </a:rPr>
-              <a:t>One of the most important observations is that Quaid-e-Azam: The Architect of Pakistan cannot be viewed in isolation from other internal or external factors.</a:t>
+              <a:t>One of the most important observations is that Imran Khan: Cricket Icon to Political Leader cannot be viewed in isolation from other internal or external factors.</a:t>
             </a:r>
             <a:endParaRPr lang="en-US" sz="1400" dirty="0"/>
           </a:p>

</xml_diff>

<commit_message>
all data fully update and correct
</commit_message>
<xml_diff>
--- a/backend/services/agent/presentation.pptx
+++ b/backend/services/agent/presentation.pptx
@@ -119,7 +119,7 @@
 </p:presentation>
 </file>
 
-<file path=ppt/charts/chart16.xml><?xml version="1.0" encoding="utf-8"?>
+<file path=ppt/charts/chart1.xml><?xml version="1.0" encoding="utf-8"?>
 <c:chartSpace xmlns:c="http://schemas.openxmlformats.org/drawingml/2006/chart" xmlns:a="http://schemas.openxmlformats.org/drawingml/2006/main" xmlns:r="http://schemas.openxmlformats.org/officeDocument/2006/relationships">
   <c:date1904 val="0"/>
   <c:roundedCorners val="1"/>
@@ -249,22 +249,22 @@
                 <c:ptCount val="6"/>
                 <c:lvl>
                   <c:pt idx="0">
-                    <c:v>Early Life…</c:v>
+                    <c:v>Pre-Indepe…</c:v>
                   </c:pt>
                   <c:pt idx="1">
-                    <c:v>The 1992 W…</c:v>
+                    <c:v>Foundation…</c:v>
                   </c:pt>
                   <c:pt idx="2">
-                    <c:v>Philanthro…</c:v>
+                    <c:v>The Ayub E…</c:v>
                   </c:pt>
                   <c:pt idx="3">
-                    <c:v>Entry into…</c:v>
+                    <c:v>The 1971 C…</c:v>
                   </c:pt>
                   <c:pt idx="4">
-                    <c:v>Tenure as …</c:v>
+                    <c:v>Zia Era, G…</c:v>
                   </c:pt>
                   <c:pt idx="5">
-                    <c:v>Post-Premi…</c:v>
+                    <c:v>The 21st C…</c:v>
                   </c:pt>
                 </c:lvl>
               </c:multiLvlStrCache>
@@ -445,7 +445,7 @@
 </c:chartSpace>
 </file>
 
-<file path=ppt/charts/chart17.xml><?xml version="1.0" encoding="utf-8"?>
+<file path=ppt/charts/chart2.xml><?xml version="1.0" encoding="utf-8"?>
 <c:chartSpace xmlns:c="http://schemas.openxmlformats.org/drawingml/2006/chart" xmlns:a="http://schemas.openxmlformats.org/drawingml/2006/main" xmlns:r="http://schemas.openxmlformats.org/officeDocument/2006/relationships">
   <c:date1904 val="0"/>
   <c:roundedCorners val="1"/>
@@ -575,22 +575,22 @@
                 <c:ptCount val="6"/>
                 <c:lvl>
                   <c:pt idx="0">
-                    <c:v>Early Life…</c:v>
+                    <c:v>Pre-Indepe…</c:v>
                   </c:pt>
                   <c:pt idx="1">
-                    <c:v>The 1992 W…</c:v>
+                    <c:v>Foundation…</c:v>
                   </c:pt>
                   <c:pt idx="2">
-                    <c:v>Philanthro…</c:v>
+                    <c:v>The Ayub E…</c:v>
                   </c:pt>
                   <c:pt idx="3">
-                    <c:v>Entry into…</c:v>
+                    <c:v>The 1971 C…</c:v>
                   </c:pt>
                   <c:pt idx="4">
-                    <c:v>Tenure as …</c:v>
+                    <c:v>Zia Era, G…</c:v>
                   </c:pt>
                   <c:pt idx="5">
-                    <c:v>Post-Premi…</c:v>
+                    <c:v>The 21st C…</c:v>
                   </c:pt>
                 </c:lvl>
               </c:multiLvlStrCache>
@@ -771,7 +771,7 @@
 </c:chartSpace>
 </file>
 
-<file path=ppt/charts/chart18.xml><?xml version="1.0" encoding="utf-8"?>
+<file path=ppt/charts/chart3.xml><?xml version="1.0" encoding="utf-8"?>
 <c:chartSpace xmlns:c="http://schemas.openxmlformats.org/drawingml/2006/chart" xmlns:a="http://schemas.openxmlformats.org/drawingml/2006/main" xmlns:r="http://schemas.openxmlformats.org/officeDocument/2006/relationships">
   <c:date1904 val="0"/>
   <c:roundedCorners val="1"/>
@@ -901,22 +901,22 @@
                 <c:ptCount val="6"/>
                 <c:lvl>
                   <c:pt idx="0">
-                    <c:v>Early Life…</c:v>
+                    <c:v>Pre-Indepe…</c:v>
                   </c:pt>
                   <c:pt idx="1">
-                    <c:v>The 1992 W…</c:v>
+                    <c:v>Foundation…</c:v>
                   </c:pt>
                   <c:pt idx="2">
-                    <c:v>Philanthro…</c:v>
+                    <c:v>The Ayub E…</c:v>
                   </c:pt>
                   <c:pt idx="3">
-                    <c:v>Entry into…</c:v>
+                    <c:v>The 1971 C…</c:v>
                   </c:pt>
                   <c:pt idx="4">
-                    <c:v>Tenure as …</c:v>
+                    <c:v>Zia Era, G…</c:v>
                   </c:pt>
                   <c:pt idx="5">
-                    <c:v>Post-Premi…</c:v>
+                    <c:v>The 21st C…</c:v>
                   </c:pt>
                 </c:lvl>
               </c:multiLvlStrCache>
@@ -1097,7 +1097,7 @@
 </c:chartSpace>
 </file>
 
-<file path=ppt/charts/chart19.xml><?xml version="1.0" encoding="utf-8"?>
+<file path=ppt/charts/chart4.xml><?xml version="1.0" encoding="utf-8"?>
 <c:chartSpace xmlns:c="http://schemas.openxmlformats.org/drawingml/2006/chart" xmlns:a="http://schemas.openxmlformats.org/drawingml/2006/main" xmlns:r="http://schemas.openxmlformats.org/officeDocument/2006/relationships">
   <c:date1904 val="0"/>
   <c:roundedCorners val="1"/>
@@ -1227,22 +1227,22 @@
                 <c:ptCount val="6"/>
                 <c:lvl>
                   <c:pt idx="0">
-                    <c:v>Early Life…</c:v>
+                    <c:v>Pre-Indepe…</c:v>
                   </c:pt>
                   <c:pt idx="1">
-                    <c:v>The 1992 W…</c:v>
+                    <c:v>Foundation…</c:v>
                   </c:pt>
                   <c:pt idx="2">
-                    <c:v>Philanthro…</c:v>
+                    <c:v>The Ayub E…</c:v>
                   </c:pt>
                   <c:pt idx="3">
-                    <c:v>Entry into…</c:v>
+                    <c:v>The 1971 C…</c:v>
                   </c:pt>
                   <c:pt idx="4">
-                    <c:v>Tenure as …</c:v>
+                    <c:v>Zia Era, G…</c:v>
                   </c:pt>
                   <c:pt idx="5">
-                    <c:v>Post-Premi…</c:v>
+                    <c:v>The 21st C…</c:v>
                   </c:pt>
                 </c:lvl>
               </c:multiLvlStrCache>
@@ -1423,7 +1423,7 @@
 </c:chartSpace>
 </file>
 
-<file path=ppt/charts/chart20.xml><?xml version="1.0" encoding="utf-8"?>
+<file path=ppt/charts/chart5.xml><?xml version="1.0" encoding="utf-8"?>
 <c:chartSpace xmlns:c="http://schemas.openxmlformats.org/drawingml/2006/chart" xmlns:a="http://schemas.openxmlformats.org/drawingml/2006/main" xmlns:r="http://schemas.openxmlformats.org/officeDocument/2006/relationships">
   <c:date1904 val="0"/>
   <c:roundedCorners val="1"/>
@@ -1553,22 +1553,22 @@
                 <c:ptCount val="6"/>
                 <c:lvl>
                   <c:pt idx="0">
-                    <c:v>Early Life…</c:v>
+                    <c:v>Pre-Indepe…</c:v>
                   </c:pt>
                   <c:pt idx="1">
-                    <c:v>The 1992 W…</c:v>
+                    <c:v>Foundation…</c:v>
                   </c:pt>
                   <c:pt idx="2">
-                    <c:v>Philanthro…</c:v>
+                    <c:v>The Ayub E…</c:v>
                   </c:pt>
                   <c:pt idx="3">
-                    <c:v>Entry into…</c:v>
+                    <c:v>The 1971 C…</c:v>
                   </c:pt>
                   <c:pt idx="4">
-                    <c:v>Tenure as …</c:v>
+                    <c:v>Zia Era, G…</c:v>
                   </c:pt>
                   <c:pt idx="5">
-                    <c:v>Post-Premi…</c:v>
+                    <c:v>The 21st C…</c:v>
                   </c:pt>
                 </c:lvl>
               </c:multiLvlStrCache>
@@ -3633,7 +3633,7 @@
                 <a:ea typeface="Aptos Display" pitchFamily="34" charset="-122"/>
                 <a:cs typeface="Aptos Display" pitchFamily="34" charset="-120"/>
               </a:rPr>
-              <a:t>Imran Khan: Cricket Icon to Political Leader</a:t>
+              <a:t>A Journey Through Time</a:t>
             </a:r>
             <a:endParaRPr lang="en-US" sz="2800" dirty="0"/>
           </a:p>
@@ -3674,7 +3674,7 @@
                 <a:ea typeface="Aptos" pitchFamily="34" charset="-122"/>
                 <a:cs typeface="Aptos" pitchFamily="34" charset="-120"/>
               </a:rPr>
-              <a:t>The Life, Legacy, and Political Journey of Pakistan's 22nd Prime Minister</a:t>
+              <a:t>The Historical Evolution of Pakistan</a:t>
             </a:r>
             <a:endParaRPr lang="en-US" sz="1500" dirty="0"/>
           </a:p>
@@ -3930,7 +3930,7 @@
                 <a:ea typeface="Aptos" pitchFamily="34" charset="-122"/>
                 <a:cs typeface="Aptos" pitchFamily="34" charset="-120"/>
               </a:rPr>
-              <a:t>The presentation also highlights several emerging developments and opportunities that are likely to shape the future of Imran Khan: Cricket Icon to Political Leader.</a:t>
+              <a:t>The presentation also highlights several emerging developments and opportunities that are likely to shape the future of A Journey Through Time.</a:t>
             </a:r>
             <a:endParaRPr lang="en-US" sz="1400" dirty="0"/>
           </a:p>
@@ -3988,7 +3988,7 @@
                 <a:ea typeface="Aptos" pitchFamily="34" charset="-122"/>
                 <a:cs typeface="Aptos" pitchFamily="34" charset="-120"/>
               </a:rPr>
-              <a:t>In terms of benefits, Imran Khan: Cricket Icon to Political Leader offers improved efficiency, better decision-making, enhanced clarity, and stronger strategic alignment.</a:t>
+              <a:t>In terms of benefits, A Journey Through Time offers improved efficiency, better decision-making, enhanced clarity, and stronger strategic alignment.</a:t>
             </a:r>
             <a:endParaRPr lang="en-US" sz="1400" dirty="0"/>
           </a:p>
@@ -4429,7 +4429,7 @@
                 <a:ea typeface="Aptos" pitchFamily="34" charset="-122"/>
                 <a:cs typeface="Aptos" pitchFamily="34" charset="-120"/>
               </a:rPr>
-              <a:t>Overall, Imran Khan: Cricket Icon to Political Leader is a topic of lasting importance, and the insights presented here serve as a practical reference for further exploration.</a:t>
+              <a:t>Overall, A Journey Through Time is a topic of lasting importance, and the insights presented here serve as a practical reference for further exploration.</a:t>
             </a:r>
             <a:endParaRPr lang="en-US" sz="1400" dirty="0"/>
           </a:p>
@@ -4783,7 +4783,7 @@
                 <a:ea typeface="Aptos" pitchFamily="34" charset="-122"/>
                 <a:cs typeface="Aptos" pitchFamily="34" charset="-120"/>
               </a:rPr>
-              <a:t>In summary, this presentation delivers a complete, structured, and insightful overview of Imran Khan: Cricket Icon to Political Leader with clarity, depth, and relevance.</a:t>
+              <a:t>In summary, this presentation delivers a complete, structured, and insightful overview of A Journey Through Time with clarity, depth, and relevance.</a:t>
             </a:r>
             <a:endParaRPr lang="en-US" sz="1400" dirty="0"/>
           </a:p>
@@ -5306,7 +5306,7 @@
                 <a:ea typeface="Aptos Display" pitchFamily="34" charset="-122"/>
                 <a:cs typeface="Aptos Display" pitchFamily="34" charset="-120"/>
               </a:rPr>
-              <a:t>Early Life and Cricket Career</a:t>
+              <a:t>Pre-Independence &amp; The Freedom Struggle</a:t>
             </a:r>
             <a:endParaRPr lang="en-US" sz="2400" dirty="0"/>
           </a:p>
@@ -5422,7 +5422,7 @@
                 <a:ea typeface="Aptos" pitchFamily="34" charset="-122"/>
                 <a:cs typeface="Aptos" pitchFamily="34" charset="-120"/>
               </a:rPr>
-              <a:t>Born in Lahore, Pakistan, in 1952 to an affluent Pashtun family</a:t>
+              <a:t>Rich historical heritage rooted in the ancient Indus Valley Civilization</a:t>
             </a:r>
             <a:endParaRPr lang="en-US" sz="1400" dirty="0"/>
           </a:p>
@@ -5515,7 +5515,7 @@
                 <a:ea typeface="Aptos" pitchFamily="34" charset="-122"/>
                 <a:cs typeface="Aptos" pitchFamily="34" charset="-120"/>
               </a:rPr>
-              <a:t>Educated at Aitchison College Lahore and Keble College, Oxford</a:t>
+              <a:t>Emergence of Muslim nationalism led by reformists like Sir Syed Ahmad Khan</a:t>
             </a:r>
             <a:endParaRPr lang="en-US" sz="1400" dirty="0"/>
           </a:p>
@@ -5608,7 +5608,7 @@
                 <a:ea typeface="Aptos" pitchFamily="34" charset="-122"/>
                 <a:cs typeface="Aptos" pitchFamily="34" charset="-120"/>
               </a:rPr>
-              <a:t>Made international debut for the Pakistan national cricket team in 1971</a:t>
+              <a:t>Founding of the All-India Muslim League in 1906 for minority rights</a:t>
             </a:r>
             <a:endParaRPr lang="en-US" sz="1400" dirty="0"/>
           </a:p>
@@ -5701,7 +5701,7 @@
                 <a:ea typeface="Aptos" pitchFamily="34" charset="-122"/>
                 <a:cs typeface="Aptos" pitchFamily="34" charset="-120"/>
               </a:rPr>
-              <a:t>Emerged as one of the world's premier fast bowlers and all-rounders</a:t>
+              <a:t>Passage of the historic Lahore Resolution demanding autonomy in 1940</a:t>
             </a:r>
             <a:endParaRPr lang="en-US" sz="1400" dirty="0"/>
           </a:p>
@@ -5794,7 +5794,7 @@
                 <a:ea typeface="Aptos" pitchFamily="34" charset="-122"/>
                 <a:cs typeface="Aptos" pitchFamily="34" charset="-120"/>
               </a:rPr>
-              <a:t>Served as team captain during Pakistan cricket's golden era</a:t>
+              <a:t>Independence achieved on August 14, 1947, under Muhammad Ali Jinnah</a:t>
             </a:r>
             <a:endParaRPr lang="en-US" sz="1400" dirty="0"/>
           </a:p>
@@ -5945,7 +5945,7 @@
                 <a:ea typeface="Aptos Display" pitchFamily="34" charset="-122"/>
                 <a:cs typeface="Aptos Display" pitchFamily="34" charset="-120"/>
               </a:rPr>
-              <a:t>The 1992 World Cup Triumph</a:t>
+              <a:t>Foundational Challenges &amp; Early Governance (1947–1958)</a:t>
             </a:r>
             <a:endParaRPr lang="en-US" sz="2400" dirty="0"/>
           </a:p>
@@ -6061,7 +6061,7 @@
                 <a:ea typeface="Aptos" pitchFamily="34" charset="-122"/>
                 <a:cs typeface="Aptos" pitchFamily="34" charset="-120"/>
               </a:rPr>
-              <a:t>Led Pakistan to its first and only ICC Cricket World Cup victory in 1992</a:t>
+              <a:t>Muhammad Ali Jinnah guided the nation as the first Governor-General</a:t>
             </a:r>
             <a:endParaRPr lang="en-US" sz="1400" dirty="0"/>
           </a:p>
@@ -6154,7 +6154,7 @@
                 <a:ea typeface="Aptos" pitchFamily="34" charset="-122"/>
                 <a:cs typeface="Aptos" pitchFamily="34" charset="-120"/>
               </a:rPr>
-              <a:t>Rallied the team with his famous 'cornered tigers' speech</a:t>
+              <a:t>Massive logistical hurdles including severe refugee crises and asset division</a:t>
             </a:r>
             <a:endParaRPr lang="en-US" sz="1400" dirty="0"/>
           </a:p>
@@ -6247,7 +6247,7 @@
                 <a:ea typeface="Aptos" pitchFamily="34" charset="-122"/>
                 <a:cs typeface="Aptos" pitchFamily="34" charset="-120"/>
               </a:rPr>
-              <a:t>Scored a crucial 72 runs in the final against England</a:t>
+              <a:t>Adoption of the Objectives Resolution in 1949 laying ideological foundations</a:t>
             </a:r>
             <a:endParaRPr lang="en-US" sz="1400" dirty="0"/>
           </a:p>
@@ -6340,7 +6340,7 @@
                 <a:ea typeface="Aptos" pitchFamily="34" charset="-122"/>
                 <a:cs typeface="Aptos" pitchFamily="34" charset="-120"/>
               </a:rPr>
-              <a:t>Retired from international cricket immediately following the victory</a:t>
+              <a:t>Promulgation of the first official constitution in 1956</a:t>
             </a:r>
             <a:endParaRPr lang="en-US" sz="1400" dirty="0"/>
           </a:p>
@@ -6433,7 +6433,7 @@
                 <a:ea typeface="Aptos" pitchFamily="34" charset="-122"/>
                 <a:cs typeface="Aptos" pitchFamily="34" charset="-120"/>
               </a:rPr>
-              <a:t>Cemented his status as an enduring national hero</a:t>
+              <a:t>Frequent changes in prime ministers signaling early political instability</a:t>
             </a:r>
             <a:endParaRPr lang="en-US" sz="1400" dirty="0"/>
           </a:p>
@@ -6584,7 +6584,7 @@
                 <a:ea typeface="Aptos Display" pitchFamily="34" charset="-122"/>
                 <a:cs typeface="Aptos Display" pitchFamily="34" charset="-120"/>
               </a:rPr>
-              <a:t>Philanthropy and Social Impact</a:t>
+              <a:t>The Ayub Era &amp; Regional Conflicts (1958–1969)</a:t>
             </a:r>
             <a:endParaRPr lang="en-US" sz="2400" dirty="0"/>
           </a:p>
@@ -6700,7 +6700,7 @@
                 <a:ea typeface="Aptos" pitchFamily="34" charset="-122"/>
                 <a:cs typeface="Aptos" pitchFamily="34" charset="-120"/>
               </a:rPr>
-              <a:t>Founded Shaukat Khanum Memorial Cancer Hospital in 1994</a:t>
+              <a:t>General Ayub Khan enacted the country's first nationwide martial law</a:t>
             </a:r>
             <a:endParaRPr lang="en-US" sz="1400" dirty="0"/>
           </a:p>
@@ -6793,7 +6793,7 @@
                 <a:ea typeface="Aptos" pitchFamily="34" charset="-122"/>
                 <a:cs typeface="Aptos" pitchFamily="34" charset="-120"/>
               </a:rPr>
-              <a:t>Provided free, high-quality cancer care to underprivileged patients</a:t>
+              <a:t>Rapid industrialization and agricultural expansion during the Green Revolution</a:t>
             </a:r>
             <a:endParaRPr lang="en-US" sz="1400" dirty="0"/>
           </a:p>
@@ -6886,7 +6886,7 @@
                 <a:ea typeface="Aptos" pitchFamily="34" charset="-122"/>
                 <a:cs typeface="Aptos" pitchFamily="34" charset="-120"/>
               </a:rPr>
-              <a:t>Established Namal University in Mianwali in 2008</a:t>
+              <a:t>Construction of vital infrastructure including Mangla Dam and Tarbela Dam</a:t>
             </a:r>
             <a:endParaRPr lang="en-US" sz="1400" dirty="0"/>
           </a:p>
@@ -6979,7 +6979,7 @@
                 <a:ea typeface="Aptos" pitchFamily="34" charset="-122"/>
                 <a:cs typeface="Aptos" pitchFamily="34" charset="-120"/>
               </a:rPr>
-              <a:t>Focused on providing affordable higher education to rural youth</a:t>
+              <a:t>The 1965 Indo-Pakistani War over disputed territories</a:t>
             </a:r>
             <a:endParaRPr lang="en-US" sz="1400" dirty="0"/>
           </a:p>
@@ -7072,7 +7072,7 @@
                 <a:ea typeface="Aptos" pitchFamily="34" charset="-122"/>
                 <a:cs typeface="Aptos" pitchFamily="34" charset="-120"/>
               </a:rPr>
-              <a:t>Built widespread trust through transparent charitable endeavors</a:t>
+              <a:t>Official relocation of the federal capital from Karachi to Islamabad</a:t>
             </a:r>
             <a:endParaRPr lang="en-US" sz="1400" dirty="0"/>
           </a:p>
@@ -7223,7 +7223,7 @@
                 <a:ea typeface="Aptos Display" pitchFamily="34" charset="-122"/>
                 <a:cs typeface="Aptos Display" pitchFamily="34" charset="-120"/>
               </a:rPr>
-              <a:t>Entry into Politics and Rise of PTI</a:t>
+              <a:t>The 1971 Crisis &amp; Democratic Revival (1969–1977)</a:t>
             </a:r>
             <a:endParaRPr lang="en-US" sz="2400" dirty="0"/>
           </a:p>
@@ -7339,7 +7339,7 @@
                 <a:ea typeface="Aptos" pitchFamily="34" charset="-122"/>
                 <a:cs typeface="Aptos" pitchFamily="34" charset="-120"/>
               </a:rPr>
-              <a:t>Founded the political party Pakistan Tehreek-e-Insaf (PTI) in 1996</a:t>
+              <a:t>Rising regional tensions leading to the separation of East Pakistan as Bangladesh</a:t>
             </a:r>
             <a:endParaRPr lang="en-US" sz="1400" dirty="0"/>
           </a:p>
@@ -7432,7 +7432,7 @@
                 <a:ea typeface="Aptos" pitchFamily="34" charset="-122"/>
                 <a:cs typeface="Aptos" pitchFamily="34" charset="-120"/>
               </a:rPr>
-              <a:t>Campaigned on anti-corruption, rule of law, and social justice</a:t>
+              <a:t>Zulfikar Ali Bhutto assumed power to rebuild national institutions</a:t>
             </a:r>
             <a:endParaRPr lang="en-US" sz="1400" dirty="0"/>
           </a:p>
@@ -7525,7 +7525,7 @@
                 <a:ea typeface="Aptos" pitchFamily="34" charset="-122"/>
                 <a:cs typeface="Aptos" pitchFamily="34" charset="-120"/>
               </a:rPr>
-              <a:t>Spent over a decade as a minor political player in parliament</a:t>
+              <a:t>Unanimous passage of the landmark 1973 Constitution of Pakistan</a:t>
             </a:r>
             <a:endParaRPr lang="en-US" sz="1400" dirty="0"/>
           </a:p>
@@ -7618,7 +7618,7 @@
                 <a:ea typeface="Aptos" pitchFamily="34" charset="-122"/>
                 <a:cs typeface="Aptos" pitchFamily="34" charset="-120"/>
               </a:rPr>
-              <a:t>Achieved a major political breakthrough with mass rallies in 2011</a:t>
+              <a:t>Implementation of sweeping socialist economic and nationalization policies</a:t>
             </a:r>
             <a:endParaRPr lang="en-US" sz="1400" dirty="0"/>
           </a:p>
@@ -7711,7 +7711,7 @@
                 <a:ea typeface="Aptos" pitchFamily="34" charset="-122"/>
                 <a:cs typeface="Aptos" pitchFamily="34" charset="-120"/>
               </a:rPr>
-              <a:t>Mobilized youth and urban middle-class voters across the country</a:t>
+              <a:t>Initiation of the national nuclear energy and defense program</a:t>
             </a:r>
             <a:endParaRPr lang="en-US" sz="1400" dirty="0"/>
           </a:p>
@@ -7862,7 +7862,7 @@
                 <a:ea typeface="Aptos Display" pitchFamily="34" charset="-122"/>
                 <a:cs typeface="Aptos Display" pitchFamily="34" charset="-120"/>
               </a:rPr>
-              <a:t>Tenure as Prime Minister (2018–2022)</a:t>
+              <a:t>Zia Era, Geopolitics &amp; Nuclear Emergence (1977–1999)</a:t>
             </a:r>
             <a:endParaRPr lang="en-US" sz="2400" dirty="0"/>
           </a:p>
@@ -7978,7 +7978,7 @@
                 <a:ea typeface="Aptos" pitchFamily="34" charset="-122"/>
                 <a:cs typeface="Aptos" pitchFamily="34" charset="-120"/>
               </a:rPr>
-              <a:t>Elected as the 22nd Prime Minister of Pakistan in August 2018</a:t>
+              <a:t>General Zia-ul-Haq imposed martial law and initiated state Islamization</a:t>
             </a:r>
             <a:endParaRPr lang="en-US" sz="1400" dirty="0"/>
           </a:p>
@@ -8071,7 +8071,7 @@
                 <a:ea typeface="Aptos" pitchFamily="34" charset="-122"/>
                 <a:cs typeface="Aptos" pitchFamily="34" charset="-120"/>
               </a:rPr>
-              <a:t>Launched the 'Ehsaas' social safety and poverty alleviation program</a:t>
+              <a:t>Pakistan served as a frontline ally during the Soviet-Afghan War</a:t>
             </a:r>
             <a:endParaRPr lang="en-US" sz="1400" dirty="0"/>
           </a:p>
@@ -8164,7 +8164,7 @@
                 <a:ea typeface="Aptos" pitchFamily="34" charset="-122"/>
                 <a:cs typeface="Aptos" pitchFamily="34" charset="-120"/>
               </a:rPr>
-              <a:t>Initiated the 10 Billion Tree Tsunami environmental initiative</a:t>
+              <a:t>Democratic decade in the 1990s alternating between Benazir Bhutto and Nawaz Sharif</a:t>
             </a:r>
             <a:endParaRPr lang="en-US" sz="1400" dirty="0"/>
           </a:p>
@@ -8257,7 +8257,7 @@
                 <a:ea typeface="Aptos" pitchFamily="34" charset="-122"/>
                 <a:cs typeface="Aptos" pitchFamily="34" charset="-120"/>
               </a:rPr>
-              <a:t>Managed the national response to the COVID-19 pandemic</a:t>
+              <a:t>Successful underground nuclear tests conducted in May 1998</a:t>
             </a:r>
             <a:endParaRPr lang="en-US" sz="1400" dirty="0"/>
           </a:p>
@@ -8350,7 +8350,7 @@
                 <a:ea typeface="Aptos" pitchFamily="34" charset="-122"/>
                 <a:cs typeface="Aptos" pitchFamily="34" charset="-120"/>
               </a:rPr>
-              <a:t>Removed from office via a parliamentary no-confidence vote in April 2022</a:t>
+              <a:t>Heightened regional tensions culminating in the 1999 Kargil conflict</a:t>
             </a:r>
             <a:endParaRPr lang="en-US" sz="1400" dirty="0"/>
           </a:p>
@@ -8501,7 +8501,7 @@
                 <a:ea typeface="Aptos Display" pitchFamily="34" charset="-122"/>
                 <a:cs typeface="Aptos Display" pitchFamily="34" charset="-120"/>
               </a:rPr>
-              <a:t>Post-Premiership and Current Landscape</a:t>
+              <a:t>The 21st Century &amp; Modern Horizon (1999–Present)</a:t>
             </a:r>
             <a:endParaRPr lang="en-US" sz="2400" dirty="0"/>
           </a:p>
@@ -8617,7 +8617,7 @@
                 <a:ea typeface="Aptos" pitchFamily="34" charset="-122"/>
                 <a:cs typeface="Aptos" pitchFamily="34" charset="-120"/>
               </a:rPr>
-              <a:t>Led massive public protest rallies demanding early general elections</a:t>
+              <a:t>General Pervez Musharraf's administration and alliance in the War on Terror</a:t>
             </a:r>
             <a:endParaRPr lang="en-US" sz="1400" dirty="0"/>
           </a:p>
@@ -8710,7 +8710,7 @@
                 <a:ea typeface="Aptos" pitchFamily="34" charset="-122"/>
                 <a:cs typeface="Aptos" pitchFamily="34" charset="-120"/>
               </a:rPr>
-              <a:t>Survived an assassination attempt during a political march in November 2022</a:t>
+              <a:t>Restoration of civilian rule with consecutive peaceful transfers of power</a:t>
             </a:r>
             <a:endParaRPr lang="en-US" sz="1400" dirty="0"/>
           </a:p>
@@ -8803,7 +8803,7 @@
                 <a:ea typeface="Aptos" pitchFamily="34" charset="-122"/>
                 <a:cs typeface="Aptos" pitchFamily="34" charset="-120"/>
               </a:rPr>
-              <a:t>Faced dozens of legal charges and subsequent imprisonment in 2023</a:t>
+              <a:t>18th Constitutional Amendment enacted to grant greater provincial autonomy</a:t>
             </a:r>
             <a:endParaRPr lang="en-US" sz="1400" dirty="0"/>
           </a:p>
@@ -8896,7 +8896,7 @@
                 <a:ea typeface="Aptos" pitchFamily="34" charset="-122"/>
                 <a:cs typeface="Aptos" pitchFamily="34" charset="-120"/>
               </a:rPr>
-              <a:t>Demonstrated continued popular support through independent election candidates</a:t>
+              <a:t>Launch of strategic megaprojects under the China-Pakistan Economic Corridor</a:t>
             </a:r>
             <a:endParaRPr lang="en-US" sz="1400" dirty="0"/>
           </a:p>
@@ -8989,7 +8989,7 @@
                 <a:ea typeface="Aptos" pitchFamily="34" charset="-122"/>
                 <a:cs typeface="Aptos" pitchFamily="34" charset="-120"/>
               </a:rPr>
-              <a:t>Remains one of the most polarizing and influential figures in modern Pakistan</a:t>
+              <a:t>Continuous focus on digital innovation, economic reform, and regional stability</a:t>
             </a:r>
             <a:endParaRPr lang="en-US" sz="1400" dirty="0"/>
           </a:p>
@@ -9232,7 +9232,7 @@
                 <a:ea typeface="Aptos" pitchFamily="34" charset="-122"/>
                 <a:cs typeface="Aptos" pitchFamily="34" charset="-120"/>
               </a:rPr>
-              <a:t>Imran Khan: Cricket Icon to Political Leader is a comprehensive, multi-dimensional subject carefully structured across 6 thematic sections in this presentation.</a:t>
+              <a:t>A Journey Through Time is a comprehensive, multi-dimensional subject carefully structured across 6 thematic sections in this presentation.</a:t>
             </a:r>
             <a:endParaRPr lang="en-US" sz="1400" dirty="0"/>
           </a:p>
@@ -9290,7 +9290,7 @@
                 <a:ea typeface="Aptos" pitchFamily="34" charset="-122"/>
                 <a:cs typeface="Aptos" pitchFamily="34" charset="-120"/>
               </a:rPr>
-              <a:t>The central theme "The Life, Legacy, and Political Journey of Pakistan's 22nd Prime Minister" anchors the entire discussion and provides the reader with a clear and focused direction throughout.</a:t>
+              <a:t>The central theme "The Historical Evolution of Pakistan" anchors the entire discussion and provides the reader with a clear and focused direction throughout.</a:t>
             </a:r>
             <a:endParaRPr lang="en-US" sz="1400" dirty="0"/>
           </a:p>
@@ -9702,7 +9702,7 @@
                 <a:ea typeface="Aptos" pitchFamily="34" charset="-122"/>
                 <a:cs typeface="Aptos" pitchFamily="34" charset="-120"/>
               </a:rPr>
-              <a:t>From a strategic perspective, Imran Khan: Cricket Icon to Political Leader plays a significant role in shaping outcomes, influencing decisions, and driving measurable value.</a:t>
+              <a:t>From a strategic perspective, A Journey Through Time plays a significant role in shaping outcomes, influencing decisions, and driving measurable value.</a:t>
             </a:r>
             <a:endParaRPr lang="en-US" sz="1400" dirty="0"/>
           </a:p>
@@ -9760,7 +9760,7 @@
                 <a:ea typeface="Aptos" pitchFamily="34" charset="-122"/>
                 <a:cs typeface="Aptos" pitchFamily="34" charset="-120"/>
               </a:rPr>
-              <a:t>One of the most important observations is that Imran Khan: Cricket Icon to Political Leader cannot be viewed in isolation from other internal or external factors.</a:t>
+              <a:t>One of the most important observations is that A Journey Through Time cannot be viewed in isolation from other internal or external factors.</a:t>
             </a:r>
             <a:endParaRPr lang="en-US" sz="1400" dirty="0"/>
           </a:p>

</xml_diff>